<commit_message>
Add Semester 3 project folders and sql 1 deliverables
</commit_message>
<xml_diff>
--- a/Other/Lisa’s Status Updates.pptx
+++ b/Other/Lisa’s Status Updates.pptx
@@ -4,9 +4,16 @@
   <p:sldMasterIdLst>
     <p:sldMasterId id="2147483648" r:id="rId1"/>
   </p:sldMasterIdLst>
+  <p:notesMasterIdLst>
+    <p:notesMasterId r:id="rId8"/>
+  </p:notesMasterIdLst>
   <p:sldIdLst>
     <p:sldId id="256" r:id="rId2"/>
     <p:sldId id="257" r:id="rId3"/>
+    <p:sldId id="258" r:id="rId4"/>
+    <p:sldId id="259" r:id="rId5"/>
+    <p:sldId id="260" r:id="rId6"/>
+    <p:sldId id="261" r:id="rId7"/>
   </p:sldIdLst>
   <p:sldSz cx="12192000" cy="6858000"/>
   <p:notesSz cx="6858000" cy="9144000"/>
@@ -105,7 +112,615 @@
       </a:defRPr>
     </a:lvl9pPr>
   </p:defaultTextStyle>
+  <p:extLst>
+    <p:ext uri="{EFAFB233-063F-42B5-8137-9DF3F51BA10A}">
+      <p15:sldGuideLst xmlns:p15="http://schemas.microsoft.com/office/powerpoint/2012/main"/>
+    </p:ext>
+  </p:extLst>
 </p:presentation>
+</file>
+
+<file path=ppt/notesMasters/notesMaster1.xml><?xml version="1.0" encoding="utf-8"?>
+<p:notesMaster xmlns:a="http://schemas.openxmlformats.org/drawingml/2006/main" xmlns:r="http://schemas.openxmlformats.org/officeDocument/2006/relationships" xmlns:p="http://schemas.openxmlformats.org/presentationml/2006/main">
+  <p:cSld>
+    <p:bg>
+      <p:bgRef idx="1001">
+        <a:schemeClr val="bg1"/>
+      </p:bgRef>
+    </p:bg>
+    <p:spTree>
+      <p:nvGrpSpPr>
+        <p:cNvPr id="1" name=""/>
+        <p:cNvGrpSpPr/>
+        <p:nvPr/>
+      </p:nvGrpSpPr>
+      <p:grpSpPr>
+        <a:xfrm>
+          <a:off x="0" y="0"/>
+          <a:ext cx="0" cy="0"/>
+          <a:chOff x="0" y="0"/>
+          <a:chExt cx="0" cy="0"/>
+        </a:xfrm>
+      </p:grpSpPr>
+      <p:sp>
+        <p:nvSpPr>
+          <p:cNvPr id="2" name="Header Placeholder 1"/>
+          <p:cNvSpPr>
+            <a:spLocks noGrp="1"/>
+          </p:cNvSpPr>
+          <p:nvPr>
+            <p:ph type="hdr" sz="quarter"/>
+          </p:nvPr>
+        </p:nvSpPr>
+        <p:spPr>
+          <a:xfrm>
+            <a:off x="0" y="0"/>
+            <a:ext cx="2971800" cy="458788"/>
+          </a:xfrm>
+          <a:prstGeom prst="rect">
+            <a:avLst/>
+          </a:prstGeom>
+        </p:spPr>
+        <p:txBody>
+          <a:bodyPr vert="horz" lIns="91440" tIns="45720" rIns="91440" bIns="45720" rtlCol="0"/>
+          <a:lstStyle>
+            <a:lvl1pPr algn="l">
+              <a:defRPr sz="1200"/>
+            </a:lvl1pPr>
+          </a:lstStyle>
+          <a:p>
+            <a:endParaRPr lang="en-US"/>
+          </a:p>
+        </p:txBody>
+      </p:sp>
+      <p:sp>
+        <p:nvSpPr>
+          <p:cNvPr id="3" name="Date Placeholder 2"/>
+          <p:cNvSpPr>
+            <a:spLocks noGrp="1"/>
+          </p:cNvSpPr>
+          <p:nvPr>
+            <p:ph type="dt" idx="1"/>
+          </p:nvPr>
+        </p:nvSpPr>
+        <p:spPr>
+          <a:xfrm>
+            <a:off x="3884613" y="0"/>
+            <a:ext cx="2971800" cy="458788"/>
+          </a:xfrm>
+          <a:prstGeom prst="rect">
+            <a:avLst/>
+          </a:prstGeom>
+        </p:spPr>
+        <p:txBody>
+          <a:bodyPr vert="horz" lIns="91440" tIns="45720" rIns="91440" bIns="45720" rtlCol="0"/>
+          <a:lstStyle>
+            <a:lvl1pPr algn="r">
+              <a:defRPr sz="1200"/>
+            </a:lvl1pPr>
+          </a:lstStyle>
+          <a:p>
+            <a:fld id="{235E2641-94F1-4F41-BC64-DA1C34E512FB}" type="datetimeFigureOut">
+              <a:rPr lang="en-US" smtClean="0"/>
+              <a:t>9/4/2025</a:t>
+            </a:fld>
+            <a:endParaRPr lang="en-US"/>
+          </a:p>
+        </p:txBody>
+      </p:sp>
+      <p:sp>
+        <p:nvSpPr>
+          <p:cNvPr id="4" name="Slide Image Placeholder 3"/>
+          <p:cNvSpPr>
+            <a:spLocks noGrp="1" noRot="1" noChangeAspect="1"/>
+          </p:cNvSpPr>
+          <p:nvPr>
+            <p:ph type="sldImg" idx="2"/>
+          </p:nvPr>
+        </p:nvSpPr>
+        <p:spPr>
+          <a:xfrm>
+            <a:off x="685800" y="1143000"/>
+            <a:ext cx="5486400" cy="3086100"/>
+          </a:xfrm>
+          <a:prstGeom prst="rect">
+            <a:avLst/>
+          </a:prstGeom>
+          <a:noFill/>
+          <a:ln w="12700">
+            <a:solidFill>
+              <a:prstClr val="black"/>
+            </a:solidFill>
+          </a:ln>
+        </p:spPr>
+        <p:txBody>
+          <a:bodyPr vert="horz" lIns="91440" tIns="45720" rIns="91440" bIns="45720" rtlCol="0" anchor="ctr"/>
+          <a:lstStyle/>
+          <a:p>
+            <a:endParaRPr lang="en-US"/>
+          </a:p>
+        </p:txBody>
+      </p:sp>
+      <p:sp>
+        <p:nvSpPr>
+          <p:cNvPr id="5" name="Notes Placeholder 4"/>
+          <p:cNvSpPr>
+            <a:spLocks noGrp="1"/>
+          </p:cNvSpPr>
+          <p:nvPr>
+            <p:ph type="body" sz="quarter" idx="3"/>
+          </p:nvPr>
+        </p:nvSpPr>
+        <p:spPr>
+          <a:xfrm>
+            <a:off x="685800" y="4400550"/>
+            <a:ext cx="5486400" cy="3600450"/>
+          </a:xfrm>
+          <a:prstGeom prst="rect">
+            <a:avLst/>
+          </a:prstGeom>
+        </p:spPr>
+        <p:txBody>
+          <a:bodyPr vert="horz" lIns="91440" tIns="45720" rIns="91440" bIns="45720" rtlCol="0"/>
+          <a:lstStyle/>
+          <a:p>
+            <a:pPr lvl="0"/>
+            <a:r>
+              <a:rPr lang="en-US" smtClean="0"/>
+              <a:t>Edit Master text styles</a:t>
+            </a:r>
+          </a:p>
+          <a:p>
+            <a:pPr lvl="1"/>
+            <a:r>
+              <a:rPr lang="en-US" smtClean="0"/>
+              <a:t>Second level</a:t>
+            </a:r>
+          </a:p>
+          <a:p>
+            <a:pPr lvl="2"/>
+            <a:r>
+              <a:rPr lang="en-US" smtClean="0"/>
+              <a:t>Third level</a:t>
+            </a:r>
+          </a:p>
+          <a:p>
+            <a:pPr lvl="3"/>
+            <a:r>
+              <a:rPr lang="en-US" smtClean="0"/>
+              <a:t>Fourth level</a:t>
+            </a:r>
+          </a:p>
+          <a:p>
+            <a:pPr lvl="4"/>
+            <a:r>
+              <a:rPr lang="en-US" smtClean="0"/>
+              <a:t>Fifth level</a:t>
+            </a:r>
+            <a:endParaRPr lang="en-US"/>
+          </a:p>
+        </p:txBody>
+      </p:sp>
+      <p:sp>
+        <p:nvSpPr>
+          <p:cNvPr id="6" name="Footer Placeholder 5"/>
+          <p:cNvSpPr>
+            <a:spLocks noGrp="1"/>
+          </p:cNvSpPr>
+          <p:nvPr>
+            <p:ph type="ftr" sz="quarter" idx="4"/>
+          </p:nvPr>
+        </p:nvSpPr>
+        <p:spPr>
+          <a:xfrm>
+            <a:off x="0" y="8685213"/>
+            <a:ext cx="2971800" cy="458787"/>
+          </a:xfrm>
+          <a:prstGeom prst="rect">
+            <a:avLst/>
+          </a:prstGeom>
+        </p:spPr>
+        <p:txBody>
+          <a:bodyPr vert="horz" lIns="91440" tIns="45720" rIns="91440" bIns="45720" rtlCol="0" anchor="b"/>
+          <a:lstStyle>
+            <a:lvl1pPr algn="l">
+              <a:defRPr sz="1200"/>
+            </a:lvl1pPr>
+          </a:lstStyle>
+          <a:p>
+            <a:endParaRPr lang="en-US"/>
+          </a:p>
+        </p:txBody>
+      </p:sp>
+      <p:sp>
+        <p:nvSpPr>
+          <p:cNvPr id="7" name="Slide Number Placeholder 6"/>
+          <p:cNvSpPr>
+            <a:spLocks noGrp="1"/>
+          </p:cNvSpPr>
+          <p:nvPr>
+            <p:ph type="sldNum" sz="quarter" idx="5"/>
+          </p:nvPr>
+        </p:nvSpPr>
+        <p:spPr>
+          <a:xfrm>
+            <a:off x="3884613" y="8685213"/>
+            <a:ext cx="2971800" cy="458787"/>
+          </a:xfrm>
+          <a:prstGeom prst="rect">
+            <a:avLst/>
+          </a:prstGeom>
+        </p:spPr>
+        <p:txBody>
+          <a:bodyPr vert="horz" lIns="91440" tIns="45720" rIns="91440" bIns="45720" rtlCol="0" anchor="b"/>
+          <a:lstStyle>
+            <a:lvl1pPr algn="r">
+              <a:defRPr sz="1200"/>
+            </a:lvl1pPr>
+          </a:lstStyle>
+          <a:p>
+            <a:fld id="{D195DE54-355A-4569-8D12-E453AA6D2C38}" type="slidenum">
+              <a:rPr lang="en-US" smtClean="0"/>
+              <a:t>‹#›</a:t>
+            </a:fld>
+            <a:endParaRPr lang="en-US"/>
+          </a:p>
+        </p:txBody>
+      </p:sp>
+    </p:spTree>
+    <p:extLst>
+      <p:ext uri="{BB962C8B-B14F-4D97-AF65-F5344CB8AC3E}">
+        <p14:creationId xmlns:p14="http://schemas.microsoft.com/office/powerpoint/2010/main" val="3383688115"/>
+      </p:ext>
+    </p:extLst>
+  </p:cSld>
+  <p:clrMap bg1="lt1" tx1="dk1" bg2="lt2" tx2="dk2" accent1="accent1" accent2="accent2" accent3="accent3" accent4="accent4" accent5="accent5" accent6="accent6" hlink="hlink" folHlink="folHlink"/>
+  <p:notesStyle>
+    <a:lvl1pPr marL="0" algn="l" defTabSz="914400" rtl="0" eaLnBrk="1" latinLnBrk="0" hangingPunct="1">
+      <a:defRPr sz="1200" kern="1200">
+        <a:solidFill>
+          <a:schemeClr val="tx1"/>
+        </a:solidFill>
+        <a:latin typeface="+mn-lt"/>
+        <a:ea typeface="+mn-ea"/>
+        <a:cs typeface="+mn-cs"/>
+      </a:defRPr>
+    </a:lvl1pPr>
+    <a:lvl2pPr marL="457200" algn="l" defTabSz="914400" rtl="0" eaLnBrk="1" latinLnBrk="0" hangingPunct="1">
+      <a:defRPr sz="1200" kern="1200">
+        <a:solidFill>
+          <a:schemeClr val="tx1"/>
+        </a:solidFill>
+        <a:latin typeface="+mn-lt"/>
+        <a:ea typeface="+mn-ea"/>
+        <a:cs typeface="+mn-cs"/>
+      </a:defRPr>
+    </a:lvl2pPr>
+    <a:lvl3pPr marL="914400" algn="l" defTabSz="914400" rtl="0" eaLnBrk="1" latinLnBrk="0" hangingPunct="1">
+      <a:defRPr sz="1200" kern="1200">
+        <a:solidFill>
+          <a:schemeClr val="tx1"/>
+        </a:solidFill>
+        <a:latin typeface="+mn-lt"/>
+        <a:ea typeface="+mn-ea"/>
+        <a:cs typeface="+mn-cs"/>
+      </a:defRPr>
+    </a:lvl3pPr>
+    <a:lvl4pPr marL="1371600" algn="l" defTabSz="914400" rtl="0" eaLnBrk="1" latinLnBrk="0" hangingPunct="1">
+      <a:defRPr sz="1200" kern="1200">
+        <a:solidFill>
+          <a:schemeClr val="tx1"/>
+        </a:solidFill>
+        <a:latin typeface="+mn-lt"/>
+        <a:ea typeface="+mn-ea"/>
+        <a:cs typeface="+mn-cs"/>
+      </a:defRPr>
+    </a:lvl4pPr>
+    <a:lvl5pPr marL="1828800" algn="l" defTabSz="914400" rtl="0" eaLnBrk="1" latinLnBrk="0" hangingPunct="1">
+      <a:defRPr sz="1200" kern="1200">
+        <a:solidFill>
+          <a:schemeClr val="tx1"/>
+        </a:solidFill>
+        <a:latin typeface="+mn-lt"/>
+        <a:ea typeface="+mn-ea"/>
+        <a:cs typeface="+mn-cs"/>
+      </a:defRPr>
+    </a:lvl5pPr>
+    <a:lvl6pPr marL="2286000" algn="l" defTabSz="914400" rtl="0" eaLnBrk="1" latinLnBrk="0" hangingPunct="1">
+      <a:defRPr sz="1200" kern="1200">
+        <a:solidFill>
+          <a:schemeClr val="tx1"/>
+        </a:solidFill>
+        <a:latin typeface="+mn-lt"/>
+        <a:ea typeface="+mn-ea"/>
+        <a:cs typeface="+mn-cs"/>
+      </a:defRPr>
+    </a:lvl6pPr>
+    <a:lvl7pPr marL="2743200" algn="l" defTabSz="914400" rtl="0" eaLnBrk="1" latinLnBrk="0" hangingPunct="1">
+      <a:defRPr sz="1200" kern="1200">
+        <a:solidFill>
+          <a:schemeClr val="tx1"/>
+        </a:solidFill>
+        <a:latin typeface="+mn-lt"/>
+        <a:ea typeface="+mn-ea"/>
+        <a:cs typeface="+mn-cs"/>
+      </a:defRPr>
+    </a:lvl7pPr>
+    <a:lvl8pPr marL="3200400" algn="l" defTabSz="914400" rtl="0" eaLnBrk="1" latinLnBrk="0" hangingPunct="1">
+      <a:defRPr sz="1200" kern="1200">
+        <a:solidFill>
+          <a:schemeClr val="tx1"/>
+        </a:solidFill>
+        <a:latin typeface="+mn-lt"/>
+        <a:ea typeface="+mn-ea"/>
+        <a:cs typeface="+mn-cs"/>
+      </a:defRPr>
+    </a:lvl8pPr>
+    <a:lvl9pPr marL="3657600" algn="l" defTabSz="914400" rtl="0" eaLnBrk="1" latinLnBrk="0" hangingPunct="1">
+      <a:defRPr sz="1200" kern="1200">
+        <a:solidFill>
+          <a:schemeClr val="tx1"/>
+        </a:solidFill>
+        <a:latin typeface="+mn-lt"/>
+        <a:ea typeface="+mn-ea"/>
+        <a:cs typeface="+mn-cs"/>
+      </a:defRPr>
+    </a:lvl9pPr>
+  </p:notesStyle>
+</p:notesMaster>
+</file>
+
+<file path=ppt/notesSlides/notesSlide1.xml><?xml version="1.0" encoding="utf-8"?>
+<p:notes xmlns:a="http://schemas.openxmlformats.org/drawingml/2006/main" xmlns:r="http://schemas.openxmlformats.org/officeDocument/2006/relationships" xmlns:p="http://schemas.openxmlformats.org/presentationml/2006/main">
+  <p:cSld>
+    <p:spTree>
+      <p:nvGrpSpPr>
+        <p:cNvPr id="1" name=""/>
+        <p:cNvGrpSpPr/>
+        <p:nvPr/>
+      </p:nvGrpSpPr>
+      <p:grpSpPr>
+        <a:xfrm>
+          <a:off x="0" y="0"/>
+          <a:ext cx="0" cy="0"/>
+          <a:chOff x="0" y="0"/>
+          <a:chExt cx="0" cy="0"/>
+        </a:xfrm>
+      </p:grpSpPr>
+      <p:sp>
+        <p:nvSpPr>
+          <p:cNvPr id="2" name="Slide Image Placeholder 1"/>
+          <p:cNvSpPr>
+            <a:spLocks noGrp="1" noRot="1" noChangeAspect="1"/>
+          </p:cNvSpPr>
+          <p:nvPr>
+            <p:ph type="sldImg"/>
+          </p:nvPr>
+        </p:nvSpPr>
+        <p:spPr/>
+      </p:sp>
+      <p:sp>
+        <p:nvSpPr>
+          <p:cNvPr id="3" name="Notes Placeholder 2"/>
+          <p:cNvSpPr>
+            <a:spLocks noGrp="1"/>
+          </p:cNvSpPr>
+          <p:nvPr>
+            <p:ph type="body" idx="1"/>
+          </p:nvPr>
+        </p:nvSpPr>
+        <p:spPr/>
+        <p:txBody>
+          <a:bodyPr/>
+          <a:lstStyle/>
+          <a:p>
+            <a:pPr marL="0" marR="0" lvl="0" indent="0" algn="l" defTabSz="914400" rtl="0" eaLnBrk="1" fontAlgn="auto" latinLnBrk="0" hangingPunct="1">
+              <a:lnSpc>
+                <a:spcPct val="100000"/>
+              </a:lnSpc>
+              <a:spcBef>
+                <a:spcPts val="0"/>
+              </a:spcBef>
+              <a:spcAft>
+                <a:spcPts val="0"/>
+              </a:spcAft>
+              <a:buClrTx/>
+              <a:buSzTx/>
+              <a:buFontTx/>
+              <a:buNone/>
+              <a:tabLst/>
+              <a:defRPr/>
+            </a:pPr>
+            <a:r>
+              <a:rPr lang="en-US" sz="1200" b="0" kern="1200" dirty="0" smtClean="0">
+                <a:solidFill>
+                  <a:schemeClr val="tx1"/>
+                </a:solidFill>
+                <a:effectLst/>
+                <a:latin typeface="+mn-lt"/>
+                <a:ea typeface="+mn-ea"/>
+                <a:cs typeface="+mn-cs"/>
+              </a:rPr>
+              <a:t>To implement a stack is to create a working data structure that adheres to the Last-In, First-Out (LIFO) principle.</a:t>
+            </a:r>
+          </a:p>
+          <a:p>
+            <a:endParaRPr lang="en-US" dirty="0"/>
+          </a:p>
+        </p:txBody>
+      </p:sp>
+      <p:sp>
+        <p:nvSpPr>
+          <p:cNvPr id="4" name="Slide Number Placeholder 3"/>
+          <p:cNvSpPr>
+            <a:spLocks noGrp="1"/>
+          </p:cNvSpPr>
+          <p:nvPr>
+            <p:ph type="sldNum" sz="quarter" idx="10"/>
+          </p:nvPr>
+        </p:nvSpPr>
+        <p:spPr/>
+        <p:txBody>
+          <a:bodyPr/>
+          <a:lstStyle/>
+          <a:p>
+            <a:fld id="{D195DE54-355A-4569-8D12-E453AA6D2C38}" type="slidenum">
+              <a:rPr lang="en-US" smtClean="0"/>
+              <a:t>4</a:t>
+            </a:fld>
+            <a:endParaRPr lang="en-US"/>
+          </a:p>
+        </p:txBody>
+      </p:sp>
+    </p:spTree>
+    <p:extLst>
+      <p:ext uri="{BB962C8B-B14F-4D97-AF65-F5344CB8AC3E}">
+        <p14:creationId xmlns:p14="http://schemas.microsoft.com/office/powerpoint/2010/main" val="47894573"/>
+      </p:ext>
+    </p:extLst>
+  </p:cSld>
+  <p:clrMapOvr>
+    <a:masterClrMapping/>
+  </p:clrMapOvr>
+</p:notes>
+</file>
+
+<file path=ppt/notesSlides/notesSlide2.xml><?xml version="1.0" encoding="utf-8"?>
+<p:notes xmlns:a="http://schemas.openxmlformats.org/drawingml/2006/main" xmlns:r="http://schemas.openxmlformats.org/officeDocument/2006/relationships" xmlns:p="http://schemas.openxmlformats.org/presentationml/2006/main">
+  <p:cSld>
+    <p:spTree>
+      <p:nvGrpSpPr>
+        <p:cNvPr id="1" name=""/>
+        <p:cNvGrpSpPr/>
+        <p:nvPr/>
+      </p:nvGrpSpPr>
+      <p:grpSpPr>
+        <a:xfrm>
+          <a:off x="0" y="0"/>
+          <a:ext cx="0" cy="0"/>
+          <a:chOff x="0" y="0"/>
+          <a:chExt cx="0" cy="0"/>
+        </a:xfrm>
+      </p:grpSpPr>
+      <p:sp>
+        <p:nvSpPr>
+          <p:cNvPr id="2" name="Slide Image Placeholder 1"/>
+          <p:cNvSpPr>
+            <a:spLocks noGrp="1" noRot="1" noChangeAspect="1"/>
+          </p:cNvSpPr>
+          <p:nvPr>
+            <p:ph type="sldImg"/>
+          </p:nvPr>
+        </p:nvSpPr>
+        <p:spPr/>
+      </p:sp>
+      <p:sp>
+        <p:nvSpPr>
+          <p:cNvPr id="3" name="Notes Placeholder 2"/>
+          <p:cNvSpPr>
+            <a:spLocks noGrp="1"/>
+          </p:cNvSpPr>
+          <p:nvPr>
+            <p:ph type="body" idx="1"/>
+          </p:nvPr>
+        </p:nvSpPr>
+        <p:spPr/>
+        <p:txBody>
+          <a:bodyPr/>
+          <a:lstStyle/>
+          <a:p>
+            <a:r>
+              <a:rPr lang="en-US" sz="1200" b="0" i="0" kern="1200" dirty="0" smtClean="0">
+                <a:solidFill>
+                  <a:schemeClr val="tx1"/>
+                </a:solidFill>
+                <a:effectLst/>
+                <a:latin typeface="+mn-lt"/>
+                <a:ea typeface="+mn-ea"/>
+                <a:cs typeface="+mn-cs"/>
+              </a:rPr>
+              <a:t>Express: The main frame for your lemonade stand.</a:t>
+            </a:r>
+          </a:p>
+          <a:p>
+            <a:r>
+              <a:rPr lang="en-US" sz="1200" b="0" i="0" kern="1200" dirty="0" err="1" smtClean="0">
+                <a:solidFill>
+                  <a:schemeClr val="tx1"/>
+                </a:solidFill>
+                <a:effectLst/>
+                <a:latin typeface="+mn-lt"/>
+                <a:ea typeface="+mn-ea"/>
+                <a:cs typeface="+mn-cs"/>
+              </a:rPr>
+              <a:t>Sequelize</a:t>
+            </a:r>
+            <a:r>
+              <a:rPr lang="en-US" sz="1200" b="0" i="0" kern="1200" dirty="0" smtClean="0">
+                <a:solidFill>
+                  <a:schemeClr val="tx1"/>
+                </a:solidFill>
+                <a:effectLst/>
+                <a:latin typeface="+mn-lt"/>
+                <a:ea typeface="+mn-ea"/>
+                <a:cs typeface="+mn-cs"/>
+              </a:rPr>
+              <a:t>: The helpful translator who knows the language of the recipe box.</a:t>
+            </a:r>
+          </a:p>
+          <a:p>
+            <a:r>
+              <a:rPr lang="en-US" sz="1200" b="0" i="0" kern="1200" dirty="0" smtClean="0">
+                <a:solidFill>
+                  <a:schemeClr val="tx1"/>
+                </a:solidFill>
+                <a:effectLst/>
+                <a:latin typeface="+mn-lt"/>
+                <a:ea typeface="+mn-ea"/>
+                <a:cs typeface="+mn-cs"/>
+              </a:rPr>
+              <a:t>SQLite: The simple recipe box itself. </a:t>
+            </a:r>
+          </a:p>
+          <a:p>
+            <a:endParaRPr lang="en-US" dirty="0"/>
+          </a:p>
+        </p:txBody>
+      </p:sp>
+      <p:sp>
+        <p:nvSpPr>
+          <p:cNvPr id="4" name="Slide Number Placeholder 3"/>
+          <p:cNvSpPr>
+            <a:spLocks noGrp="1"/>
+          </p:cNvSpPr>
+          <p:nvPr>
+            <p:ph type="sldNum" sz="quarter" idx="10"/>
+          </p:nvPr>
+        </p:nvSpPr>
+        <p:spPr/>
+        <p:txBody>
+          <a:bodyPr/>
+          <a:lstStyle/>
+          <a:p>
+            <a:fld id="{D195DE54-355A-4569-8D12-E453AA6D2C38}" type="slidenum">
+              <a:rPr lang="en-US" smtClean="0"/>
+              <a:t>5</a:t>
+            </a:fld>
+            <a:endParaRPr lang="en-US"/>
+          </a:p>
+        </p:txBody>
+      </p:sp>
+    </p:spTree>
+    <p:extLst>
+      <p:ext uri="{BB962C8B-B14F-4D97-AF65-F5344CB8AC3E}">
+        <p14:creationId xmlns:p14="http://schemas.microsoft.com/office/powerpoint/2010/main" val="3062405853"/>
+      </p:ext>
+    </p:extLst>
+  </p:cSld>
+  <p:clrMapOvr>
+    <a:masterClrMapping/>
+  </p:clrMapOvr>
+</p:notes>
 </file>
 
 <file path=ppt/slideLayouts/slideLayout1.xml><?xml version="1.0" encoding="utf-8"?>
@@ -440,7 +1055,7 @@
             <a:fld id="{B61BEF0D-F0BB-DE4B-95CE-6DB70DBA9567}" type="datetimeFigureOut">
               <a:rPr lang="en-US" dirty="0"/>
               <a:pPr/>
-              <a:t>8/14/2025</a:t>
+              <a:t>9/4/2025</a:t>
             </a:fld>
             <a:endParaRPr lang="en-US" dirty="0"/>
           </a:p>
@@ -761,7 +1376,7 @@
             <a:fld id="{B61BEF0D-F0BB-DE4B-95CE-6DB70DBA9567}" type="datetimeFigureOut">
               <a:rPr lang="en-US" dirty="0"/>
               <a:pPr/>
-              <a:t>8/14/2025</a:t>
+              <a:t>9/4/2025</a:t>
             </a:fld>
             <a:endParaRPr lang="en-US" dirty="0"/>
           </a:p>
@@ -1006,7 +1621,7 @@
             <a:fld id="{B61BEF0D-F0BB-DE4B-95CE-6DB70DBA9567}" type="datetimeFigureOut">
               <a:rPr lang="en-US" dirty="0"/>
               <a:pPr/>
-              <a:t>8/14/2025</a:t>
+              <a:t>9/4/2025</a:t>
             </a:fld>
             <a:endParaRPr lang="en-US" dirty="0"/>
           </a:p>
@@ -1342,7 +1957,7 @@
             <a:fld id="{B61BEF0D-F0BB-DE4B-95CE-6DB70DBA9567}" type="datetimeFigureOut">
               <a:rPr lang="en-US" dirty="0"/>
               <a:pPr/>
-              <a:t>8/14/2025</a:t>
+              <a:t>9/4/2025</a:t>
             </a:fld>
             <a:endParaRPr lang="en-US" dirty="0"/>
           </a:p>
@@ -1686,7 +2301,7 @@
             <a:fld id="{B61BEF0D-F0BB-DE4B-95CE-6DB70DBA9567}" type="datetimeFigureOut">
               <a:rPr lang="en-US" dirty="0"/>
               <a:pPr/>
-              <a:t>8/14/2025</a:t>
+              <a:t>9/4/2025</a:t>
             </a:fld>
             <a:endParaRPr lang="en-US" dirty="0"/>
           </a:p>
@@ -2057,7 +2672,7 @@
             <a:fld id="{B61BEF0D-F0BB-DE4B-95CE-6DB70DBA9567}" type="datetimeFigureOut">
               <a:rPr lang="en-US" dirty="0"/>
               <a:pPr/>
-              <a:t>8/14/2025</a:t>
+              <a:t>9/4/2025</a:t>
             </a:fld>
             <a:endParaRPr lang="en-US" dirty="0"/>
           </a:p>
@@ -2524,7 +3139,7 @@
             <a:fld id="{B61BEF0D-F0BB-DE4B-95CE-6DB70DBA9567}" type="datetimeFigureOut">
               <a:rPr lang="en-US" dirty="0"/>
               <a:pPr/>
-              <a:t>8/14/2025</a:t>
+              <a:t>9/4/2025</a:t>
             </a:fld>
             <a:endParaRPr lang="en-US" dirty="0"/>
           </a:p>
@@ -2726,7 +3341,7 @@
             <a:fld id="{B61BEF0D-F0BB-DE4B-95CE-6DB70DBA9567}" type="datetimeFigureOut">
               <a:rPr lang="en-US" dirty="0"/>
               <a:pPr/>
-              <a:t>8/14/2025</a:t>
+              <a:t>9/4/2025</a:t>
             </a:fld>
             <a:endParaRPr lang="en-US" dirty="0"/>
           </a:p>
@@ -2934,7 +3549,7 @@
             <a:fld id="{B61BEF0D-F0BB-DE4B-95CE-6DB70DBA9567}" type="datetimeFigureOut">
               <a:rPr lang="en-US" dirty="0"/>
               <a:pPr/>
-              <a:t>8/14/2025</a:t>
+              <a:t>9/4/2025</a:t>
             </a:fld>
             <a:endParaRPr lang="en-US" dirty="0"/>
           </a:p>
@@ -3162,7 +3777,7 @@
           <a:p>
             <a:fld id="{05BFA754-D5C3-4E66-96A6-867B257F58DC}" type="datetimeFigureOut">
               <a:rPr lang="en-US" dirty="0"/>
-              <a:t>8/14/2025</a:t>
+              <a:t>9/4/2025</a:t>
             </a:fld>
             <a:endParaRPr lang="en-US" dirty="0"/>
           </a:p>
@@ -3406,7 +4021,7 @@
             <a:fld id="{B61BEF0D-F0BB-DE4B-95CE-6DB70DBA9567}" type="datetimeFigureOut">
               <a:rPr lang="en-US" dirty="0"/>
               <a:pPr/>
-              <a:t>8/14/2025</a:t>
+              <a:t>9/4/2025</a:t>
             </a:fld>
             <a:endParaRPr lang="en-US" dirty="0"/>
           </a:p>
@@ -3669,7 +4284,7 @@
           <a:p>
             <a:fld id="{05BFA754-D5C3-4E66-96A6-867B257F58DC}" type="datetimeFigureOut">
               <a:rPr lang="en-US" dirty="0"/>
-              <a:t>8/14/2025</a:t>
+              <a:t>9/4/2025</a:t>
             </a:fld>
             <a:endParaRPr lang="en-US" dirty="0"/>
           </a:p>
@@ -4078,7 +4693,7 @@
             <a:fld id="{B61BEF0D-F0BB-DE4B-95CE-6DB70DBA9567}" type="datetimeFigureOut">
               <a:rPr lang="en-US" dirty="0"/>
               <a:pPr/>
-              <a:t>8/14/2025</a:t>
+              <a:t>9/4/2025</a:t>
             </a:fld>
             <a:endParaRPr lang="en-US" dirty="0"/>
           </a:p>
@@ -4224,7 +4839,7 @@
             <a:fld id="{B61BEF0D-F0BB-DE4B-95CE-6DB70DBA9567}" type="datetimeFigureOut">
               <a:rPr lang="en-US" dirty="0"/>
               <a:pPr/>
-              <a:t>8/14/2025</a:t>
+              <a:t>9/4/2025</a:t>
             </a:fld>
             <a:endParaRPr lang="en-US" dirty="0"/>
           </a:p>
@@ -4347,7 +4962,7 @@
             <a:fld id="{B61BEF0D-F0BB-DE4B-95CE-6DB70DBA9567}" type="datetimeFigureOut">
               <a:rPr lang="en-US" dirty="0"/>
               <a:pPr/>
-              <a:t>8/14/2025</a:t>
+              <a:t>9/4/2025</a:t>
             </a:fld>
             <a:endParaRPr lang="en-US" dirty="0"/>
           </a:p>
@@ -4599,7 +5214,7 @@
             <a:fld id="{B61BEF0D-F0BB-DE4B-95CE-6DB70DBA9567}" type="datetimeFigureOut">
               <a:rPr lang="en-US" dirty="0"/>
               <a:pPr/>
-              <a:t>8/14/2025</a:t>
+              <a:t>9/4/2025</a:t>
             </a:fld>
             <a:endParaRPr lang="en-US" dirty="0"/>
           </a:p>
@@ -4911,7 +5526,7 @@
             <a:fld id="{B61BEF0D-F0BB-DE4B-95CE-6DB70DBA9567}" type="datetimeFigureOut">
               <a:rPr lang="en-US" dirty="0"/>
               <a:pPr/>
-              <a:t>8/14/2025</a:t>
+              <a:t>9/4/2025</a:t>
             </a:fld>
             <a:endParaRPr lang="en-US" dirty="0"/>
           </a:p>
@@ -5259,7 +5874,7 @@
             <a:fld id="{B61BEF0D-F0BB-DE4B-95CE-6DB70DBA9567}" type="datetimeFigureOut">
               <a:rPr lang="en-US" dirty="0"/>
               <a:pPr/>
-              <a:t>8/14/2025</a:t>
+              <a:t>9/4/2025</a:t>
             </a:fld>
             <a:endParaRPr lang="en-US" dirty="0"/>
           </a:p>
@@ -5782,6 +6397,209 @@
 </file>
 
 <file path=ppt/slides/slide1.xml><?xml version="1.0" encoding="utf-8"?>
+<p:sld xmlns:a="http://schemas.openxmlformats.org/drawingml/2006/main" xmlns:r="http://schemas.openxmlformats.org/officeDocument/2006/relationships" xmlns:p="http://schemas.openxmlformats.org/presentationml/2006/main" show="0">
+  <p:cSld>
+    <p:spTree>
+      <p:nvGrpSpPr>
+        <p:cNvPr id="1" name=""/>
+        <p:cNvGrpSpPr/>
+        <p:nvPr/>
+      </p:nvGrpSpPr>
+      <p:grpSpPr>
+        <a:xfrm>
+          <a:off x="0" y="0"/>
+          <a:ext cx="0" cy="0"/>
+          <a:chOff x="0" y="0"/>
+          <a:chExt cx="0" cy="0"/>
+        </a:xfrm>
+      </p:grpSpPr>
+      <p:sp>
+        <p:nvSpPr>
+          <p:cNvPr id="2" name="Title 1"/>
+          <p:cNvSpPr>
+            <a:spLocks noGrp="1"/>
+          </p:cNvSpPr>
+          <p:nvPr>
+            <p:ph type="ctrTitle"/>
+          </p:nvPr>
+        </p:nvSpPr>
+        <p:spPr/>
+        <p:txBody>
+          <a:bodyPr/>
+          <a:lstStyle/>
+          <a:p>
+            <a:r>
+              <a:rPr lang="en-US" dirty="0" smtClean="0"/>
+              <a:t>Lisa’s Status Updates</a:t>
+            </a:r>
+            <a:br>
+              <a:rPr lang="en-US" dirty="0" smtClean="0"/>
+            </a:br>
+            <a:r>
+              <a:rPr lang="en-US" dirty="0" smtClean="0"/>
+              <a:t>Semester 2</a:t>
+            </a:r>
+            <a:endParaRPr lang="en-US" dirty="0"/>
+          </a:p>
+        </p:txBody>
+      </p:sp>
+    </p:spTree>
+    <p:extLst>
+      <p:ext uri="{BB962C8B-B14F-4D97-AF65-F5344CB8AC3E}">
+        <p14:creationId xmlns:p14="http://schemas.microsoft.com/office/powerpoint/2010/main" val="2826115447"/>
+      </p:ext>
+    </p:extLst>
+  </p:cSld>
+  <p:clrMapOvr>
+    <a:masterClrMapping/>
+  </p:clrMapOvr>
+  <mc:AlternateContent xmlns:mc="http://schemas.openxmlformats.org/markup-compatibility/2006">
+    <mc:Choice xmlns:p14="http://schemas.microsoft.com/office/powerpoint/2010/main" Requires="p14">
+      <p:transition spd="slow" p14:dur="2000"/>
+    </mc:Choice>
+    <mc:Fallback>
+      <p:transition spd="slow"/>
+    </mc:Fallback>
+  </mc:AlternateContent>
+  <p:timing>
+    <p:tnLst>
+      <p:par>
+        <p:cTn id="1" dur="indefinite" restart="never" nodeType="tmRoot"/>
+      </p:par>
+    </p:tnLst>
+  </p:timing>
+</p:sld>
+</file>
+
+<file path=ppt/slides/slide2.xml><?xml version="1.0" encoding="utf-8"?>
+<p:sld xmlns:a="http://schemas.openxmlformats.org/drawingml/2006/main" xmlns:r="http://schemas.openxmlformats.org/officeDocument/2006/relationships" xmlns:p="http://schemas.openxmlformats.org/presentationml/2006/main" show="0">
+  <p:cSld>
+    <p:spTree>
+      <p:nvGrpSpPr>
+        <p:cNvPr id="1" name=""/>
+        <p:cNvGrpSpPr/>
+        <p:nvPr/>
+      </p:nvGrpSpPr>
+      <p:grpSpPr>
+        <a:xfrm>
+          <a:off x="0" y="0"/>
+          <a:ext cx="0" cy="0"/>
+          <a:chOff x="0" y="0"/>
+          <a:chExt cx="0" cy="0"/>
+        </a:xfrm>
+      </p:grpSpPr>
+      <p:sp>
+        <p:nvSpPr>
+          <p:cNvPr id="2" name="Title 1"/>
+          <p:cNvSpPr>
+            <a:spLocks noGrp="1"/>
+          </p:cNvSpPr>
+          <p:nvPr>
+            <p:ph type="title"/>
+          </p:nvPr>
+        </p:nvSpPr>
+        <p:spPr/>
+        <p:txBody>
+          <a:bodyPr/>
+          <a:lstStyle/>
+          <a:p>
+            <a:r>
+              <a:rPr lang="en-US" b="1" dirty="0" smtClean="0"/>
+              <a:t>Agenda</a:t>
+            </a:r>
+            <a:endParaRPr lang="en-US" b="1" dirty="0"/>
+          </a:p>
+        </p:txBody>
+      </p:sp>
+      <p:sp>
+        <p:nvSpPr>
+          <p:cNvPr id="3" name="Content Placeholder 2"/>
+          <p:cNvSpPr>
+            <a:spLocks noGrp="1"/>
+          </p:cNvSpPr>
+          <p:nvPr>
+            <p:ph idx="1"/>
+          </p:nvPr>
+        </p:nvSpPr>
+        <p:spPr/>
+        <p:txBody>
+          <a:bodyPr/>
+          <a:lstStyle/>
+          <a:p>
+            <a:r>
+              <a:rPr lang="en-US" dirty="0" smtClean="0"/>
+              <a:t>Weekly Goal?</a:t>
+            </a:r>
+          </a:p>
+          <a:p>
+            <a:r>
+              <a:rPr lang="en-US" dirty="0" smtClean="0"/>
+              <a:t>Status?</a:t>
+            </a:r>
+          </a:p>
+          <a:p>
+            <a:r>
+              <a:rPr lang="en-US" dirty="0" smtClean="0"/>
+              <a:t>Demo:</a:t>
+            </a:r>
+          </a:p>
+          <a:p>
+            <a:pPr lvl="1"/>
+            <a:r>
+              <a:rPr lang="en-US" dirty="0" err="1" smtClean="0"/>
+              <a:t>Github</a:t>
+            </a:r>
+            <a:r>
+              <a:rPr lang="en-US" dirty="0" smtClean="0"/>
+              <a:t> Page</a:t>
+            </a:r>
+          </a:p>
+          <a:p>
+            <a:pPr lvl="1"/>
+            <a:r>
+              <a:rPr lang="en-US" dirty="0" smtClean="0"/>
+              <a:t>Monday Project Board</a:t>
+            </a:r>
+          </a:p>
+          <a:p>
+            <a:pPr lvl="1"/>
+            <a:r>
+              <a:rPr lang="en-US" dirty="0" smtClean="0"/>
+              <a:t>Project Plan – Technical Document</a:t>
+            </a:r>
+            <a:endParaRPr lang="en-US" dirty="0"/>
+          </a:p>
+        </p:txBody>
+      </p:sp>
+    </p:spTree>
+    <p:extLst>
+      <p:ext uri="{BB962C8B-B14F-4D97-AF65-F5344CB8AC3E}">
+        <p14:creationId xmlns:p14="http://schemas.microsoft.com/office/powerpoint/2010/main" val="3593725805"/>
+      </p:ext>
+    </p:extLst>
+  </p:cSld>
+  <p:clrMapOvr>
+    <a:masterClrMapping/>
+  </p:clrMapOvr>
+  <mc:AlternateContent xmlns:mc="http://schemas.openxmlformats.org/markup-compatibility/2006">
+    <mc:Choice xmlns:p14="http://schemas.microsoft.com/office/powerpoint/2010/main" Requires="p14">
+      <p:transition spd="slow" p14:dur="2000"/>
+    </mc:Choice>
+    <mc:Fallback>
+      <p:transition spd="slow"/>
+    </mc:Fallback>
+  </mc:AlternateContent>
+  <p:timing>
+    <p:tnLst>
+      <p:par>
+        <p:cTn id="1" dur="indefinite" restart="never" nodeType="tmRoot"/>
+      </p:par>
+    </p:tnLst>
+  </p:timing>
+</p:sld>
+</file>
+
+<file path=ppt/slides/slide3.xml><?xml version="1.0" encoding="utf-8"?>
 <p:sld xmlns:a="http://schemas.openxmlformats.org/drawingml/2006/main" xmlns:r="http://schemas.openxmlformats.org/officeDocument/2006/relationships" xmlns:p="http://schemas.openxmlformats.org/presentationml/2006/main">
   <p:cSld>
     <p:spTree>
@@ -5808,7 +6626,12 @@
             <p:ph type="ctrTitle"/>
           </p:nvPr>
         </p:nvSpPr>
-        <p:spPr/>
+        <p:spPr>
+          <a:xfrm>
+            <a:off x="2679335" y="2498149"/>
+            <a:ext cx="6815669" cy="1515533"/>
+          </a:xfrm>
+        </p:spPr>
         <p:txBody>
           <a:bodyPr/>
           <a:lstStyle/>
@@ -5822,7 +6645,18 @@
             </a:br>
             <a:r>
               <a:rPr lang="en-US" dirty="0" smtClean="0"/>
-              <a:t>Semester 2</a:t>
+              <a:t>Semester </a:t>
+            </a:r>
+            <a:r>
+              <a:rPr lang="en-US" dirty="0" smtClean="0"/>
+              <a:t>3</a:t>
+            </a:r>
+            <a:br>
+              <a:rPr lang="en-US" dirty="0" smtClean="0"/>
+            </a:br>
+            <a:r>
+              <a:rPr lang="en-US" sz="2400" dirty="0" smtClean="0"/>
+              <a:t>Backend Web Developer</a:t>
             </a:r>
             <a:endParaRPr lang="en-US" dirty="0"/>
           </a:p>
@@ -5831,7 +6665,7 @@
     </p:spTree>
     <p:extLst>
       <p:ext uri="{BB962C8B-B14F-4D97-AF65-F5344CB8AC3E}">
-        <p14:creationId xmlns:p14="http://schemas.microsoft.com/office/powerpoint/2010/main" val="2826115447"/>
+        <p14:creationId xmlns:p14="http://schemas.microsoft.com/office/powerpoint/2010/main" val="111919915"/>
       </p:ext>
     </p:extLst>
   </p:cSld>
@@ -5848,7 +6682,7 @@
 </p:sld>
 </file>
 
-<file path=ppt/slides/slide2.xml><?xml version="1.0" encoding="utf-8"?>
+<file path=ppt/slides/slide4.xml><?xml version="1.0" encoding="utf-8"?>
 <p:sld xmlns:a="http://schemas.openxmlformats.org/drawingml/2006/main" xmlns:r="http://schemas.openxmlformats.org/officeDocument/2006/relationships" xmlns:p="http://schemas.openxmlformats.org/presentationml/2006/main">
   <p:cSld>
     <p:spTree>
@@ -5882,7 +6716,11 @@
           <a:p>
             <a:r>
               <a:rPr lang="en-US" b="1" dirty="0" smtClean="0"/>
-              <a:t>Agenda</a:t>
+              <a:t>Agenda – Semeste</a:t>
+            </a:r>
+            <a:r>
+              <a:rPr lang="en-US" b="1" dirty="0" smtClean="0"/>
+              <a:t>r 3, Week 1</a:t>
             </a:r>
             <a:endParaRPr lang="en-US" b="1" dirty="0"/>
           </a:p>
@@ -5900,19 +6738,27 @@
         </p:nvSpPr>
         <p:spPr/>
         <p:txBody>
-          <a:bodyPr/>
+          <a:bodyPr>
+            <a:normAutofit/>
+          </a:bodyPr>
           <a:lstStyle/>
           <a:p>
             <a:r>
               <a:rPr lang="en-US" dirty="0" smtClean="0"/>
-              <a:t>Weekly Goal?</a:t>
-            </a:r>
+              <a:t>Week 1 Activities: GitHub Branching, Difficult Conversations, Coding Practice – Implemented a “Stack”</a:t>
+            </a:r>
+            <a:endParaRPr lang="en-US" dirty="0" smtClean="0"/>
           </a:p>
           <a:p>
             <a:r>
               <a:rPr lang="en-US" dirty="0" smtClean="0"/>
-              <a:t>Status?</a:t>
-            </a:r>
+              <a:t>Status</a:t>
+            </a:r>
+            <a:r>
+              <a:rPr lang="en-US" dirty="0" smtClean="0"/>
+              <a:t>? Behind. Resolution Plan: Put in additional time after class today to push additional work, and may have to reschedule to next week.</a:t>
+            </a:r>
+            <a:endParaRPr lang="en-US" dirty="0" smtClean="0"/>
           </a:p>
           <a:p>
             <a:r>
@@ -5923,35 +6769,480 @@
           <a:p>
             <a:pPr lvl="1"/>
             <a:r>
-              <a:rPr lang="en-US" dirty="0" err="1" smtClean="0"/>
-              <a:t>Github</a:t>
-            </a:r>
-            <a:r>
               <a:rPr lang="en-US" dirty="0" smtClean="0"/>
-              <a:t> Page</a:t>
-            </a:r>
+              <a:t>Project Work: “Project Pulse” – Application to manage projects, clients, &amp; team work</a:t>
+            </a:r>
+            <a:endParaRPr lang="en-US" dirty="0" smtClean="0"/>
           </a:p>
           <a:p>
             <a:pPr lvl="1"/>
             <a:r>
               <a:rPr lang="en-US" dirty="0" smtClean="0"/>
-              <a:t>Monday Project Board</a:t>
-            </a:r>
-          </a:p>
-          <a:p>
-            <a:pPr lvl="1"/>
+              <a:t>Monday Project </a:t>
+            </a:r>
             <a:r>
               <a:rPr lang="en-US" dirty="0" smtClean="0"/>
-              <a:t>Project Plan – Technical Document</a:t>
-            </a:r>
-            <a:endParaRPr lang="en-US" dirty="0"/>
+              <a:t>Board</a:t>
+            </a:r>
+            <a:endParaRPr lang="en-US" dirty="0" smtClean="0"/>
           </a:p>
         </p:txBody>
       </p:sp>
     </p:spTree>
     <p:extLst>
       <p:ext uri="{BB962C8B-B14F-4D97-AF65-F5344CB8AC3E}">
-        <p14:creationId xmlns:p14="http://schemas.microsoft.com/office/powerpoint/2010/main" val="3593725805"/>
+        <p14:creationId xmlns:p14="http://schemas.microsoft.com/office/powerpoint/2010/main" val="3553170676"/>
+      </p:ext>
+    </p:extLst>
+  </p:cSld>
+  <p:clrMapOvr>
+    <a:masterClrMapping/>
+  </p:clrMapOvr>
+  <p:timing>
+    <p:tnLst>
+      <p:par>
+        <p:cTn id="1" dur="indefinite" restart="never" nodeType="tmRoot"/>
+      </p:par>
+    </p:tnLst>
+  </p:timing>
+</p:sld>
+</file>
+
+<file path=ppt/slides/slide5.xml><?xml version="1.0" encoding="utf-8"?>
+<p:sld xmlns:a="http://schemas.openxmlformats.org/drawingml/2006/main" xmlns:r="http://schemas.openxmlformats.org/officeDocument/2006/relationships" xmlns:p="http://schemas.openxmlformats.org/presentationml/2006/main">
+  <p:cSld>
+    <p:spTree>
+      <p:nvGrpSpPr>
+        <p:cNvPr id="1" name=""/>
+        <p:cNvGrpSpPr/>
+        <p:nvPr/>
+      </p:nvGrpSpPr>
+      <p:grpSpPr>
+        <a:xfrm>
+          <a:off x="0" y="0"/>
+          <a:ext cx="0" cy="0"/>
+          <a:chOff x="0" y="0"/>
+          <a:chExt cx="0" cy="0"/>
+        </a:xfrm>
+      </p:grpSpPr>
+      <p:sp>
+        <p:nvSpPr>
+          <p:cNvPr id="4" name="Title 1"/>
+          <p:cNvSpPr txBox="1">
+            <a:spLocks/>
+          </p:cNvSpPr>
+          <p:nvPr/>
+        </p:nvSpPr>
+        <p:spPr>
+          <a:xfrm>
+            <a:off x="746762" y="629434"/>
+            <a:ext cx="10160724" cy="1303867"/>
+          </a:xfrm>
+          <a:prstGeom prst="rect">
+            <a:avLst/>
+          </a:prstGeom>
+        </p:spPr>
+        <p:txBody>
+          <a:bodyPr/>
+          <a:lstStyle>
+            <a:lvl1pPr algn="ctr" defTabSz="457200" rtl="0" eaLnBrk="1" latinLnBrk="0" hangingPunct="1">
+              <a:spcBef>
+                <a:spcPct val="0"/>
+              </a:spcBef>
+              <a:buNone/>
+              <a:defRPr sz="4400" kern="1200" cap="none">
+                <a:ln w="3175" cmpd="sng">
+                  <a:noFill/>
+                </a:ln>
+                <a:solidFill>
+                  <a:schemeClr val="tx1">
+                    <a:lumMod val="85000"/>
+                    <a:lumOff val="15000"/>
+                  </a:schemeClr>
+                </a:solidFill>
+                <a:effectLst/>
+                <a:latin typeface="+mj-lt"/>
+                <a:ea typeface="+mj-ea"/>
+                <a:cs typeface="+mj-cs"/>
+              </a:defRPr>
+            </a:lvl1pPr>
+            <a:lvl2pPr eaLnBrk="1" hangingPunct="1">
+              <a:defRPr>
+                <a:solidFill>
+                  <a:schemeClr val="tx2"/>
+                </a:solidFill>
+              </a:defRPr>
+            </a:lvl2pPr>
+            <a:lvl3pPr eaLnBrk="1" hangingPunct="1">
+              <a:defRPr>
+                <a:solidFill>
+                  <a:schemeClr val="tx2"/>
+                </a:solidFill>
+              </a:defRPr>
+            </a:lvl3pPr>
+            <a:lvl4pPr eaLnBrk="1" hangingPunct="1">
+              <a:defRPr>
+                <a:solidFill>
+                  <a:schemeClr val="tx2"/>
+                </a:solidFill>
+              </a:defRPr>
+            </a:lvl4pPr>
+            <a:lvl5pPr eaLnBrk="1" hangingPunct="1">
+              <a:defRPr>
+                <a:solidFill>
+                  <a:schemeClr val="tx2"/>
+                </a:solidFill>
+              </a:defRPr>
+            </a:lvl5pPr>
+            <a:lvl6pPr eaLnBrk="1" hangingPunct="1">
+              <a:defRPr>
+                <a:solidFill>
+                  <a:schemeClr val="tx2"/>
+                </a:solidFill>
+              </a:defRPr>
+            </a:lvl6pPr>
+            <a:lvl7pPr eaLnBrk="1" hangingPunct="1">
+              <a:defRPr>
+                <a:solidFill>
+                  <a:schemeClr val="tx2"/>
+                </a:solidFill>
+              </a:defRPr>
+            </a:lvl7pPr>
+            <a:lvl8pPr eaLnBrk="1" hangingPunct="1">
+              <a:defRPr>
+                <a:solidFill>
+                  <a:schemeClr val="tx2"/>
+                </a:solidFill>
+              </a:defRPr>
+            </a:lvl8pPr>
+            <a:lvl9pPr eaLnBrk="1" hangingPunct="1">
+              <a:defRPr>
+                <a:solidFill>
+                  <a:schemeClr val="tx2"/>
+                </a:solidFill>
+              </a:defRPr>
+            </a:lvl9pPr>
+          </a:lstStyle>
+          <a:p>
+            <a:r>
+              <a:rPr lang="en-US" b="1" dirty="0" smtClean="0"/>
+              <a:t>Setting up the Backend</a:t>
+            </a:r>
+            <a:endParaRPr lang="en-US" b="1" dirty="0"/>
+          </a:p>
+        </p:txBody>
+      </p:sp>
+      <p:sp>
+        <p:nvSpPr>
+          <p:cNvPr id="9" name="TextBox 8"/>
+          <p:cNvSpPr txBox="1"/>
+          <p:nvPr/>
+        </p:nvSpPr>
+        <p:spPr>
+          <a:xfrm>
+            <a:off x="1084216" y="1763484"/>
+            <a:ext cx="10175967" cy="3477875"/>
+          </a:xfrm>
+          <a:prstGeom prst="rect">
+            <a:avLst/>
+          </a:prstGeom>
+          <a:noFill/>
+        </p:spPr>
+        <p:txBody>
+          <a:bodyPr wrap="square" rtlCol="0">
+            <a:spAutoFit/>
+          </a:bodyPr>
+          <a:lstStyle/>
+          <a:p>
+            <a:pPr marL="285750" indent="-285750">
+              <a:buFont typeface="Arial" panose="020B0604020202020204" pitchFamily="34" charset="0"/>
+              <a:buChar char="•"/>
+            </a:pPr>
+            <a:r>
+              <a:rPr lang="en-US" sz="2000" dirty="0"/>
+              <a:t>install </a:t>
+            </a:r>
+            <a:r>
+              <a:rPr lang="en-US" sz="2000" b="1" dirty="0"/>
+              <a:t>Express</a:t>
+            </a:r>
+            <a:r>
+              <a:rPr lang="en-US" sz="2000" dirty="0"/>
+              <a:t>: This installs Express.js, the most popular web framework for Node.js. It provides a robust set of features to build web applications and APIs, handling everything from routing to middleware</a:t>
+            </a:r>
+            <a:r>
+              <a:rPr lang="en-US" sz="2000" dirty="0" smtClean="0"/>
+              <a:t>.</a:t>
+            </a:r>
+          </a:p>
+          <a:p>
+            <a:pPr marL="285750" indent="-285750">
+              <a:buFont typeface="Arial" panose="020B0604020202020204" pitchFamily="34" charset="0"/>
+              <a:buChar char="•"/>
+            </a:pPr>
+            <a:endParaRPr lang="en-US" sz="2000" dirty="0"/>
+          </a:p>
+          <a:p>
+            <a:pPr marL="285750" indent="-285750">
+              <a:buFont typeface="Arial" panose="020B0604020202020204" pitchFamily="34" charset="0"/>
+              <a:buChar char="•"/>
+            </a:pPr>
+            <a:r>
+              <a:rPr lang="en-US" sz="2000" dirty="0"/>
+              <a:t>install </a:t>
+            </a:r>
+            <a:r>
+              <a:rPr lang="en-US" sz="2000" b="1" dirty="0" err="1"/>
+              <a:t>Sequelize</a:t>
+            </a:r>
+            <a:r>
+              <a:rPr lang="en-US" sz="2000" dirty="0"/>
+              <a:t>: This installs </a:t>
+            </a:r>
+            <a:r>
+              <a:rPr lang="en-US" sz="2000" dirty="0" err="1"/>
+              <a:t>Sequelize</a:t>
+            </a:r>
+            <a:r>
+              <a:rPr lang="en-US" sz="2000" dirty="0"/>
+              <a:t>, a Node.js Object-Relational Mapper (ORM). An ORM helps you interact with a database by mapping database tables to JavaScript objects, allowing you to perform database queries and manipulations with code instead of writing raw SQL</a:t>
+            </a:r>
+            <a:r>
+              <a:rPr lang="en-US" sz="2000" dirty="0" smtClean="0"/>
+              <a:t>.</a:t>
+            </a:r>
+          </a:p>
+          <a:p>
+            <a:pPr marL="285750" indent="-285750">
+              <a:buFont typeface="Arial" panose="020B0604020202020204" pitchFamily="34" charset="0"/>
+              <a:buChar char="•"/>
+            </a:pPr>
+            <a:endParaRPr lang="en-US" sz="2000" dirty="0"/>
+          </a:p>
+          <a:p>
+            <a:pPr marL="285750" indent="-285750">
+              <a:buFont typeface="Arial" panose="020B0604020202020204" pitchFamily="34" charset="0"/>
+              <a:buChar char="•"/>
+            </a:pPr>
+            <a:r>
+              <a:rPr lang="en-US" sz="2000" dirty="0"/>
+              <a:t>install </a:t>
+            </a:r>
+            <a:r>
+              <a:rPr lang="en-US" sz="2000" b="1" dirty="0"/>
+              <a:t>SQLite</a:t>
+            </a:r>
+            <a:r>
+              <a:rPr lang="en-US" sz="2000" dirty="0"/>
+              <a:t>: This installs the SQLite library, a driver that allows </a:t>
+            </a:r>
+            <a:r>
+              <a:rPr lang="en-US" sz="2000" dirty="0" err="1"/>
+              <a:t>Sequelize</a:t>
+            </a:r>
+            <a:r>
+              <a:rPr lang="en-US" sz="2000" dirty="0"/>
+              <a:t> to connect to an SQLite database. SQLite is a simple, file-based database, which is ideal for development and prototyping because it doesn't require a separate server process. </a:t>
+            </a:r>
+          </a:p>
+        </p:txBody>
+      </p:sp>
+    </p:spTree>
+    <p:extLst>
+      <p:ext uri="{BB962C8B-B14F-4D97-AF65-F5344CB8AC3E}">
+        <p14:creationId xmlns:p14="http://schemas.microsoft.com/office/powerpoint/2010/main" val="2661934999"/>
+      </p:ext>
+    </p:extLst>
+  </p:cSld>
+  <p:clrMapOvr>
+    <a:masterClrMapping/>
+  </p:clrMapOvr>
+  <p:timing>
+    <p:tnLst>
+      <p:par>
+        <p:cTn id="1" dur="indefinite" restart="never" nodeType="tmRoot"/>
+      </p:par>
+    </p:tnLst>
+  </p:timing>
+</p:sld>
+</file>
+
+<file path=ppt/slides/slide6.xml><?xml version="1.0" encoding="utf-8"?>
+<p:sld xmlns:a="http://schemas.openxmlformats.org/drawingml/2006/main" xmlns:r="http://schemas.openxmlformats.org/officeDocument/2006/relationships" xmlns:p="http://schemas.openxmlformats.org/presentationml/2006/main">
+  <p:cSld>
+    <p:spTree>
+      <p:nvGrpSpPr>
+        <p:cNvPr id="1" name=""/>
+        <p:cNvGrpSpPr/>
+        <p:nvPr/>
+      </p:nvGrpSpPr>
+      <p:grpSpPr>
+        <a:xfrm>
+          <a:off x="0" y="0"/>
+          <a:ext cx="0" cy="0"/>
+          <a:chOff x="0" y="0"/>
+          <a:chExt cx="0" cy="0"/>
+        </a:xfrm>
+      </p:grpSpPr>
+      <p:pic>
+        <p:nvPicPr>
+          <p:cNvPr id="2" name="Picture 1"/>
+          <p:cNvPicPr>
+            <a:picLocks noChangeAspect="1"/>
+          </p:cNvPicPr>
+          <p:nvPr/>
+        </p:nvPicPr>
+        <p:blipFill>
+          <a:blip r:embed="rId2"/>
+          <a:stretch>
+            <a:fillRect/>
+          </a:stretch>
+        </p:blipFill>
+        <p:spPr>
+          <a:xfrm>
+            <a:off x="4606698" y="714782"/>
+            <a:ext cx="6201768" cy="3909469"/>
+          </a:xfrm>
+          <a:prstGeom prst="rect">
+            <a:avLst/>
+          </a:prstGeom>
+        </p:spPr>
+      </p:pic>
+      <p:pic>
+        <p:nvPicPr>
+          <p:cNvPr id="3" name="Picture 2"/>
+          <p:cNvPicPr>
+            <a:picLocks noChangeAspect="1"/>
+          </p:cNvPicPr>
+          <p:nvPr/>
+        </p:nvPicPr>
+        <p:blipFill>
+          <a:blip r:embed="rId3"/>
+          <a:stretch>
+            <a:fillRect/>
+          </a:stretch>
+        </p:blipFill>
+        <p:spPr>
+          <a:xfrm>
+            <a:off x="5204820" y="4710144"/>
+            <a:ext cx="5323842" cy="1373571"/>
+          </a:xfrm>
+          <a:prstGeom prst="rect">
+            <a:avLst/>
+          </a:prstGeom>
+        </p:spPr>
+      </p:pic>
+      <p:sp>
+        <p:nvSpPr>
+          <p:cNvPr id="4" name="Title 1"/>
+          <p:cNvSpPr txBox="1">
+            <a:spLocks/>
+          </p:cNvSpPr>
+          <p:nvPr/>
+        </p:nvSpPr>
+        <p:spPr>
+          <a:xfrm>
+            <a:off x="1086396" y="2040223"/>
+            <a:ext cx="2466701" cy="1303867"/>
+          </a:xfrm>
+          <a:prstGeom prst="rect">
+            <a:avLst/>
+          </a:prstGeom>
+        </p:spPr>
+        <p:txBody>
+          <a:bodyPr/>
+          <a:lstStyle>
+            <a:lvl1pPr algn="ctr" defTabSz="457200" rtl="0" eaLnBrk="1" latinLnBrk="0" hangingPunct="1">
+              <a:spcBef>
+                <a:spcPct val="0"/>
+              </a:spcBef>
+              <a:buNone/>
+              <a:defRPr sz="4400" kern="1200" cap="none">
+                <a:ln w="3175" cmpd="sng">
+                  <a:noFill/>
+                </a:ln>
+                <a:solidFill>
+                  <a:schemeClr val="tx1">
+                    <a:lumMod val="85000"/>
+                    <a:lumOff val="15000"/>
+                  </a:schemeClr>
+                </a:solidFill>
+                <a:effectLst/>
+                <a:latin typeface="+mj-lt"/>
+                <a:ea typeface="+mj-ea"/>
+                <a:cs typeface="+mj-cs"/>
+              </a:defRPr>
+            </a:lvl1pPr>
+            <a:lvl2pPr eaLnBrk="1" hangingPunct="1">
+              <a:defRPr>
+                <a:solidFill>
+                  <a:schemeClr val="tx2"/>
+                </a:solidFill>
+              </a:defRPr>
+            </a:lvl2pPr>
+            <a:lvl3pPr eaLnBrk="1" hangingPunct="1">
+              <a:defRPr>
+                <a:solidFill>
+                  <a:schemeClr val="tx2"/>
+                </a:solidFill>
+              </a:defRPr>
+            </a:lvl3pPr>
+            <a:lvl4pPr eaLnBrk="1" hangingPunct="1">
+              <a:defRPr>
+                <a:solidFill>
+                  <a:schemeClr val="tx2"/>
+                </a:solidFill>
+              </a:defRPr>
+            </a:lvl4pPr>
+            <a:lvl5pPr eaLnBrk="1" hangingPunct="1">
+              <a:defRPr>
+                <a:solidFill>
+                  <a:schemeClr val="tx2"/>
+                </a:solidFill>
+              </a:defRPr>
+            </a:lvl5pPr>
+            <a:lvl6pPr eaLnBrk="1" hangingPunct="1">
+              <a:defRPr>
+                <a:solidFill>
+                  <a:schemeClr val="tx2"/>
+                </a:solidFill>
+              </a:defRPr>
+            </a:lvl6pPr>
+            <a:lvl7pPr eaLnBrk="1" hangingPunct="1">
+              <a:defRPr>
+                <a:solidFill>
+                  <a:schemeClr val="tx2"/>
+                </a:solidFill>
+              </a:defRPr>
+            </a:lvl7pPr>
+            <a:lvl8pPr eaLnBrk="1" hangingPunct="1">
+              <a:defRPr>
+                <a:solidFill>
+                  <a:schemeClr val="tx2"/>
+                </a:solidFill>
+              </a:defRPr>
+            </a:lvl8pPr>
+            <a:lvl9pPr eaLnBrk="1" hangingPunct="1">
+              <a:defRPr>
+                <a:solidFill>
+                  <a:schemeClr val="tx2"/>
+                </a:solidFill>
+              </a:defRPr>
+            </a:lvl9pPr>
+          </a:lstStyle>
+          <a:p>
+            <a:r>
+              <a:rPr lang="en-US" b="1" dirty="0" smtClean="0"/>
+              <a:t>Setting up the Backend</a:t>
+            </a:r>
+            <a:endParaRPr lang="en-US" b="1" dirty="0"/>
+          </a:p>
+        </p:txBody>
+      </p:sp>
+    </p:spTree>
+    <p:extLst>
+      <p:ext uri="{BB962C8B-B14F-4D97-AF65-F5344CB8AC3E}">
+        <p14:creationId xmlns:p14="http://schemas.microsoft.com/office/powerpoint/2010/main" val="675342947"/>
       </p:ext>
     </p:extLst>
   </p:cSld>
@@ -6199,4 +7490,265 @@
     </a:ext>
   </a:extLst>
 </a:theme>
+</file>
+
+<file path=ppt/theme/theme2.xml><?xml version="1.0" encoding="utf-8"?>
+<a:theme xmlns:a="http://schemas.openxmlformats.org/drawingml/2006/main" name="Office Theme">
+  <a:themeElements>
+    <a:clrScheme name="Office">
+      <a:dk1>
+        <a:sysClr val="windowText" lastClr="000000"/>
+      </a:dk1>
+      <a:lt1>
+        <a:sysClr val="window" lastClr="FFFFFF"/>
+      </a:lt1>
+      <a:dk2>
+        <a:srgbClr val="44546A"/>
+      </a:dk2>
+      <a:lt2>
+        <a:srgbClr val="E7E6E6"/>
+      </a:lt2>
+      <a:accent1>
+        <a:srgbClr val="5B9BD5"/>
+      </a:accent1>
+      <a:accent2>
+        <a:srgbClr val="ED7D31"/>
+      </a:accent2>
+      <a:accent3>
+        <a:srgbClr val="A5A5A5"/>
+      </a:accent3>
+      <a:accent4>
+        <a:srgbClr val="FFC000"/>
+      </a:accent4>
+      <a:accent5>
+        <a:srgbClr val="4472C4"/>
+      </a:accent5>
+      <a:accent6>
+        <a:srgbClr val="70AD47"/>
+      </a:accent6>
+      <a:hlink>
+        <a:srgbClr val="0563C1"/>
+      </a:hlink>
+      <a:folHlink>
+        <a:srgbClr val="954F72"/>
+      </a:folHlink>
+    </a:clrScheme>
+    <a:fontScheme name="Office">
+      <a:majorFont>
+        <a:latin typeface="Calibri Light" panose="020F0302020204030204"/>
+        <a:ea typeface=""/>
+        <a:cs typeface=""/>
+        <a:font script="Jpan" typeface="游ゴシック Light"/>
+        <a:font script="Hang" typeface="맑은 고딕"/>
+        <a:font script="Hans" typeface="等线 Light"/>
+        <a:font script="Hant" typeface="新細明體"/>
+        <a:font script="Arab" typeface="Times New Roman"/>
+        <a:font script="Hebr" typeface="Times New Roman"/>
+        <a:font script="Thai" typeface="Angsana New"/>
+        <a:font script="Ethi" typeface="Nyala"/>
+        <a:font script="Beng" typeface="Vrinda"/>
+        <a:font script="Gujr" typeface="Shruti"/>
+        <a:font script="Khmr" typeface="MoolBoran"/>
+        <a:font script="Knda" typeface="Tunga"/>
+        <a:font script="Guru" typeface="Raavi"/>
+        <a:font script="Cans" typeface="Euphemia"/>
+        <a:font script="Cher" typeface="Plantagenet Cherokee"/>
+        <a:font script="Yiii" typeface="Microsoft Yi Baiti"/>
+        <a:font script="Tibt" typeface="Microsoft Himalaya"/>
+        <a:font script="Thaa" typeface="MV Boli"/>
+        <a:font script="Deva" typeface="Mangal"/>
+        <a:font script="Telu" typeface="Gautami"/>
+        <a:font script="Taml" typeface="Latha"/>
+        <a:font script="Syrc" typeface="Estrangelo Edessa"/>
+        <a:font script="Orya" typeface="Kalinga"/>
+        <a:font script="Mlym" typeface="Kartika"/>
+        <a:font script="Laoo" typeface="DokChampa"/>
+        <a:font script="Sinh" typeface="Iskoola Pota"/>
+        <a:font script="Mong" typeface="Mongolian Baiti"/>
+        <a:font script="Viet" typeface="Times New Roman"/>
+        <a:font script="Uigh" typeface="Microsoft Uighur"/>
+        <a:font script="Geor" typeface="Sylfaen"/>
+      </a:majorFont>
+      <a:minorFont>
+        <a:latin typeface="Calibri" panose="020F0502020204030204"/>
+        <a:ea typeface=""/>
+        <a:cs typeface=""/>
+        <a:font script="Jpan" typeface="游ゴシック"/>
+        <a:font script="Hang" typeface="맑은 고딕"/>
+        <a:font script="Hans" typeface="等线"/>
+        <a:font script="Hant" typeface="新細明體"/>
+        <a:font script="Arab" typeface="Arial"/>
+        <a:font script="Hebr" typeface="Arial"/>
+        <a:font script="Thai" typeface="Cordia New"/>
+        <a:font script="Ethi" typeface="Nyala"/>
+        <a:font script="Beng" typeface="Vrinda"/>
+        <a:font script="Gujr" typeface="Shruti"/>
+        <a:font script="Khmr" typeface="DaunPenh"/>
+        <a:font script="Knda" typeface="Tunga"/>
+        <a:font script="Guru" typeface="Raavi"/>
+        <a:font script="Cans" typeface="Euphemia"/>
+        <a:font script="Cher" typeface="Plantagenet Cherokee"/>
+        <a:font script="Yiii" typeface="Microsoft Yi Baiti"/>
+        <a:font script="Tibt" typeface="Microsoft Himalaya"/>
+        <a:font script="Thaa" typeface="MV Boli"/>
+        <a:font script="Deva" typeface="Mangal"/>
+        <a:font script="Telu" typeface="Gautami"/>
+        <a:font script="Taml" typeface="Latha"/>
+        <a:font script="Syrc" typeface="Estrangelo Edessa"/>
+        <a:font script="Orya" typeface="Kalinga"/>
+        <a:font script="Mlym" typeface="Kartika"/>
+        <a:font script="Laoo" typeface="DokChampa"/>
+        <a:font script="Sinh" typeface="Iskoola Pota"/>
+        <a:font script="Mong" typeface="Mongolian Baiti"/>
+        <a:font script="Viet" typeface="Arial"/>
+        <a:font script="Uigh" typeface="Microsoft Uighur"/>
+        <a:font script="Geor" typeface="Sylfaen"/>
+      </a:minorFont>
+    </a:fontScheme>
+    <a:fmtScheme name="Office">
+      <a:fillStyleLst>
+        <a:solidFill>
+          <a:schemeClr val="phClr"/>
+        </a:solidFill>
+        <a:gradFill rotWithShape="1">
+          <a:gsLst>
+            <a:gs pos="0">
+              <a:schemeClr val="phClr">
+                <a:lumMod val="110000"/>
+                <a:satMod val="105000"/>
+                <a:tint val="67000"/>
+              </a:schemeClr>
+            </a:gs>
+            <a:gs pos="50000">
+              <a:schemeClr val="phClr">
+                <a:lumMod val="105000"/>
+                <a:satMod val="103000"/>
+                <a:tint val="73000"/>
+              </a:schemeClr>
+            </a:gs>
+            <a:gs pos="100000">
+              <a:schemeClr val="phClr">
+                <a:lumMod val="105000"/>
+                <a:satMod val="109000"/>
+                <a:tint val="81000"/>
+              </a:schemeClr>
+            </a:gs>
+          </a:gsLst>
+          <a:lin ang="5400000" scaled="0"/>
+        </a:gradFill>
+        <a:gradFill rotWithShape="1">
+          <a:gsLst>
+            <a:gs pos="0">
+              <a:schemeClr val="phClr">
+                <a:satMod val="103000"/>
+                <a:lumMod val="102000"/>
+                <a:tint val="94000"/>
+              </a:schemeClr>
+            </a:gs>
+            <a:gs pos="50000">
+              <a:schemeClr val="phClr">
+                <a:satMod val="110000"/>
+                <a:lumMod val="100000"/>
+                <a:shade val="100000"/>
+              </a:schemeClr>
+            </a:gs>
+            <a:gs pos="100000">
+              <a:schemeClr val="phClr">
+                <a:lumMod val="99000"/>
+                <a:satMod val="120000"/>
+                <a:shade val="78000"/>
+              </a:schemeClr>
+            </a:gs>
+          </a:gsLst>
+          <a:lin ang="5400000" scaled="0"/>
+        </a:gradFill>
+      </a:fillStyleLst>
+      <a:lnStyleLst>
+        <a:ln w="6350" cap="flat" cmpd="sng" algn="ctr">
+          <a:solidFill>
+            <a:schemeClr val="phClr"/>
+          </a:solidFill>
+          <a:prstDash val="solid"/>
+          <a:miter lim="800000"/>
+        </a:ln>
+        <a:ln w="12700" cap="flat" cmpd="sng" algn="ctr">
+          <a:solidFill>
+            <a:schemeClr val="phClr"/>
+          </a:solidFill>
+          <a:prstDash val="solid"/>
+          <a:miter lim="800000"/>
+        </a:ln>
+        <a:ln w="19050" cap="flat" cmpd="sng" algn="ctr">
+          <a:solidFill>
+            <a:schemeClr val="phClr"/>
+          </a:solidFill>
+          <a:prstDash val="solid"/>
+          <a:miter lim="800000"/>
+        </a:ln>
+      </a:lnStyleLst>
+      <a:effectStyleLst>
+        <a:effectStyle>
+          <a:effectLst/>
+        </a:effectStyle>
+        <a:effectStyle>
+          <a:effectLst/>
+        </a:effectStyle>
+        <a:effectStyle>
+          <a:effectLst>
+            <a:outerShdw blurRad="57150" dist="19050" dir="5400000" algn="ctr" rotWithShape="0">
+              <a:srgbClr val="000000">
+                <a:alpha val="63000"/>
+              </a:srgbClr>
+            </a:outerShdw>
+          </a:effectLst>
+        </a:effectStyle>
+      </a:effectStyleLst>
+      <a:bgFillStyleLst>
+        <a:solidFill>
+          <a:schemeClr val="phClr"/>
+        </a:solidFill>
+        <a:solidFill>
+          <a:schemeClr val="phClr">
+            <a:tint val="95000"/>
+            <a:satMod val="170000"/>
+          </a:schemeClr>
+        </a:solidFill>
+        <a:gradFill rotWithShape="1">
+          <a:gsLst>
+            <a:gs pos="0">
+              <a:schemeClr val="phClr">
+                <a:tint val="93000"/>
+                <a:satMod val="150000"/>
+                <a:shade val="98000"/>
+                <a:lumMod val="102000"/>
+              </a:schemeClr>
+            </a:gs>
+            <a:gs pos="50000">
+              <a:schemeClr val="phClr">
+                <a:tint val="98000"/>
+                <a:satMod val="130000"/>
+                <a:shade val="90000"/>
+                <a:lumMod val="103000"/>
+              </a:schemeClr>
+            </a:gs>
+            <a:gs pos="100000">
+              <a:schemeClr val="phClr">
+                <a:shade val="63000"/>
+                <a:satMod val="120000"/>
+              </a:schemeClr>
+            </a:gs>
+          </a:gsLst>
+          <a:lin ang="5400000" scaled="0"/>
+        </a:gradFill>
+      </a:bgFillStyleLst>
+    </a:fmtScheme>
+  </a:themeElements>
+  <a:objectDefaults/>
+  <a:extraClrSchemeLst/>
+  <a:extLst>
+    <a:ext uri="{05A4C25C-085E-4340-85A3-A5531E510DB2}">
+      <thm15:themeFamily xmlns:thm15="http://schemas.microsoft.com/office/thememl/2012/main" name="Office Theme" id="{62F939B6-93AF-4DB8-9C6B-D6C7DFDC589F}" vid="{4A3C46E8-61CC-4603-A589-7422A47A8E4A}"/>
+    </a:ext>
+  </a:extLst>
+</a:theme>
 </file>
</xml_diff>

<commit_message>
Add Week 3 deliverables and screenshots for report UI
</commit_message>
<xml_diff>
--- a/Other/Lisa’s Status Updates.pptx
+++ b/Other/Lisa’s Status Updates.pptx
@@ -5,7 +5,7 @@
     <p:sldMasterId id="2147483648" r:id="rId1"/>
   </p:sldMasterIdLst>
   <p:notesMasterIdLst>
-    <p:notesMasterId r:id="rId10"/>
+    <p:notesMasterId r:id="rId14"/>
   </p:notesMasterIdLst>
   <p:sldIdLst>
     <p:sldId id="256" r:id="rId2"/>
@@ -16,6 +16,10 @@
     <p:sldId id="261" r:id="rId7"/>
     <p:sldId id="262" r:id="rId8"/>
     <p:sldId id="263" r:id="rId9"/>
+    <p:sldId id="264" r:id="rId10"/>
+    <p:sldId id="265" r:id="rId11"/>
+    <p:sldId id="267" r:id="rId12"/>
+    <p:sldId id="266" r:id="rId13"/>
   </p:sldIdLst>
   <p:sldSz cx="12192000" cy="6858000"/>
   <p:notesSz cx="6858000" cy="9144000"/>
@@ -204,7 +208,7 @@
           <a:p>
             <a:fld id="{235E2641-94F1-4F41-BC64-DA1C34E512FB}" type="datetimeFigureOut">
               <a:rPr lang="en-US" smtClean="0"/>
-              <a:t>9/11/2025</a:t>
+              <a:t>9/18/2025</a:t>
             </a:fld>
             <a:endParaRPr lang="en-US"/>
           </a:p>
@@ -1058,6 +1062,90 @@
     <p:extLst>
       <p:ext uri="{BB962C8B-B14F-4D97-AF65-F5344CB8AC3E}">
         <p14:creationId xmlns:p14="http://schemas.microsoft.com/office/powerpoint/2010/main" val="3141548540"/>
+      </p:ext>
+    </p:extLst>
+  </p:cSld>
+  <p:clrMapOvr>
+    <a:masterClrMapping/>
+  </p:clrMapOvr>
+</p:notes>
+</file>
+
+<file path=ppt/notesSlides/notesSlide4.xml><?xml version="1.0" encoding="utf-8"?>
+<p:notes xmlns:a="http://schemas.openxmlformats.org/drawingml/2006/main" xmlns:r="http://schemas.openxmlformats.org/officeDocument/2006/relationships" xmlns:p="http://schemas.openxmlformats.org/presentationml/2006/main">
+  <p:cSld>
+    <p:spTree>
+      <p:nvGrpSpPr>
+        <p:cNvPr id="1" name=""/>
+        <p:cNvGrpSpPr/>
+        <p:nvPr/>
+      </p:nvGrpSpPr>
+      <p:grpSpPr>
+        <a:xfrm>
+          <a:off x="0" y="0"/>
+          <a:ext cx="0" cy="0"/>
+          <a:chOff x="0" y="0"/>
+          <a:chExt cx="0" cy="0"/>
+        </a:xfrm>
+      </p:grpSpPr>
+      <p:sp>
+        <p:nvSpPr>
+          <p:cNvPr id="2" name="Slide Image Placeholder 1"/>
+          <p:cNvSpPr>
+            <a:spLocks noGrp="1" noRot="1" noChangeAspect="1"/>
+          </p:cNvSpPr>
+          <p:nvPr>
+            <p:ph type="sldImg"/>
+          </p:nvPr>
+        </p:nvSpPr>
+        <p:spPr/>
+      </p:sp>
+      <p:sp>
+        <p:nvSpPr>
+          <p:cNvPr id="3" name="Notes Placeholder 2"/>
+          <p:cNvSpPr>
+            <a:spLocks noGrp="1"/>
+          </p:cNvSpPr>
+          <p:nvPr>
+            <p:ph type="body" idx="1"/>
+          </p:nvPr>
+        </p:nvSpPr>
+        <p:spPr/>
+        <p:txBody>
+          <a:bodyPr/>
+          <a:lstStyle/>
+          <a:p>
+            <a:endParaRPr lang="en-US" dirty="0"/>
+          </a:p>
+        </p:txBody>
+      </p:sp>
+      <p:sp>
+        <p:nvSpPr>
+          <p:cNvPr id="4" name="Slide Number Placeholder 3"/>
+          <p:cNvSpPr>
+            <a:spLocks noGrp="1"/>
+          </p:cNvSpPr>
+          <p:nvPr>
+            <p:ph type="sldNum" sz="quarter" idx="10"/>
+          </p:nvPr>
+        </p:nvSpPr>
+        <p:spPr/>
+        <p:txBody>
+          <a:bodyPr/>
+          <a:lstStyle/>
+          <a:p>
+            <a:fld id="{D195DE54-355A-4569-8D12-E453AA6D2C38}" type="slidenum">
+              <a:rPr lang="en-US" smtClean="0"/>
+              <a:t>10</a:t>
+            </a:fld>
+            <a:endParaRPr lang="en-US"/>
+          </a:p>
+        </p:txBody>
+      </p:sp>
+    </p:spTree>
+    <p:extLst>
+      <p:ext uri="{BB962C8B-B14F-4D97-AF65-F5344CB8AC3E}">
+        <p14:creationId xmlns:p14="http://schemas.microsoft.com/office/powerpoint/2010/main" val="1641646836"/>
       </p:ext>
     </p:extLst>
   </p:cSld>
@@ -1399,7 +1487,7 @@
             <a:fld id="{B61BEF0D-F0BB-DE4B-95CE-6DB70DBA9567}" type="datetimeFigureOut">
               <a:rPr lang="en-US" dirty="0"/>
               <a:pPr/>
-              <a:t>9/11/2025</a:t>
+              <a:t>9/18/2025</a:t>
             </a:fld>
             <a:endParaRPr lang="en-US" dirty="0"/>
           </a:p>
@@ -1720,7 +1808,7 @@
             <a:fld id="{B61BEF0D-F0BB-DE4B-95CE-6DB70DBA9567}" type="datetimeFigureOut">
               <a:rPr lang="en-US" dirty="0"/>
               <a:pPr/>
-              <a:t>9/11/2025</a:t>
+              <a:t>9/18/2025</a:t>
             </a:fld>
             <a:endParaRPr lang="en-US" dirty="0"/>
           </a:p>
@@ -1965,7 +2053,7 @@
             <a:fld id="{B61BEF0D-F0BB-DE4B-95CE-6DB70DBA9567}" type="datetimeFigureOut">
               <a:rPr lang="en-US" dirty="0"/>
               <a:pPr/>
-              <a:t>9/11/2025</a:t>
+              <a:t>9/18/2025</a:t>
             </a:fld>
             <a:endParaRPr lang="en-US" dirty="0"/>
           </a:p>
@@ -2301,7 +2389,7 @@
             <a:fld id="{B61BEF0D-F0BB-DE4B-95CE-6DB70DBA9567}" type="datetimeFigureOut">
               <a:rPr lang="en-US" dirty="0"/>
               <a:pPr/>
-              <a:t>9/11/2025</a:t>
+              <a:t>9/18/2025</a:t>
             </a:fld>
             <a:endParaRPr lang="en-US" dirty="0"/>
           </a:p>
@@ -2645,7 +2733,7 @@
             <a:fld id="{B61BEF0D-F0BB-DE4B-95CE-6DB70DBA9567}" type="datetimeFigureOut">
               <a:rPr lang="en-US" dirty="0"/>
               <a:pPr/>
-              <a:t>9/11/2025</a:t>
+              <a:t>9/18/2025</a:t>
             </a:fld>
             <a:endParaRPr lang="en-US" dirty="0"/>
           </a:p>
@@ -3016,7 +3104,7 @@
             <a:fld id="{B61BEF0D-F0BB-DE4B-95CE-6DB70DBA9567}" type="datetimeFigureOut">
               <a:rPr lang="en-US" dirty="0"/>
               <a:pPr/>
-              <a:t>9/11/2025</a:t>
+              <a:t>9/18/2025</a:t>
             </a:fld>
             <a:endParaRPr lang="en-US" dirty="0"/>
           </a:p>
@@ -3483,7 +3571,7 @@
             <a:fld id="{B61BEF0D-F0BB-DE4B-95CE-6DB70DBA9567}" type="datetimeFigureOut">
               <a:rPr lang="en-US" dirty="0"/>
               <a:pPr/>
-              <a:t>9/11/2025</a:t>
+              <a:t>9/18/2025</a:t>
             </a:fld>
             <a:endParaRPr lang="en-US" dirty="0"/>
           </a:p>
@@ -3685,7 +3773,7 @@
             <a:fld id="{B61BEF0D-F0BB-DE4B-95CE-6DB70DBA9567}" type="datetimeFigureOut">
               <a:rPr lang="en-US" dirty="0"/>
               <a:pPr/>
-              <a:t>9/11/2025</a:t>
+              <a:t>9/18/2025</a:t>
             </a:fld>
             <a:endParaRPr lang="en-US" dirty="0"/>
           </a:p>
@@ -3893,7 +3981,7 @@
             <a:fld id="{B61BEF0D-F0BB-DE4B-95CE-6DB70DBA9567}" type="datetimeFigureOut">
               <a:rPr lang="en-US" dirty="0"/>
               <a:pPr/>
-              <a:t>9/11/2025</a:t>
+              <a:t>9/18/2025</a:t>
             </a:fld>
             <a:endParaRPr lang="en-US" dirty="0"/>
           </a:p>
@@ -4121,7 +4209,7 @@
           <a:p>
             <a:fld id="{05BFA754-D5C3-4E66-96A6-867B257F58DC}" type="datetimeFigureOut">
               <a:rPr lang="en-US" dirty="0"/>
-              <a:t>9/11/2025</a:t>
+              <a:t>9/18/2025</a:t>
             </a:fld>
             <a:endParaRPr lang="en-US" dirty="0"/>
           </a:p>
@@ -4365,7 +4453,7 @@
             <a:fld id="{B61BEF0D-F0BB-DE4B-95CE-6DB70DBA9567}" type="datetimeFigureOut">
               <a:rPr lang="en-US" dirty="0"/>
               <a:pPr/>
-              <a:t>9/11/2025</a:t>
+              <a:t>9/18/2025</a:t>
             </a:fld>
             <a:endParaRPr lang="en-US" dirty="0"/>
           </a:p>
@@ -4628,7 +4716,7 @@
           <a:p>
             <a:fld id="{05BFA754-D5C3-4E66-96A6-867B257F58DC}" type="datetimeFigureOut">
               <a:rPr lang="en-US" dirty="0"/>
-              <a:t>9/11/2025</a:t>
+              <a:t>9/18/2025</a:t>
             </a:fld>
             <a:endParaRPr lang="en-US" dirty="0"/>
           </a:p>
@@ -5037,7 +5125,7 @@
             <a:fld id="{B61BEF0D-F0BB-DE4B-95CE-6DB70DBA9567}" type="datetimeFigureOut">
               <a:rPr lang="en-US" dirty="0"/>
               <a:pPr/>
-              <a:t>9/11/2025</a:t>
+              <a:t>9/18/2025</a:t>
             </a:fld>
             <a:endParaRPr lang="en-US" dirty="0"/>
           </a:p>
@@ -5183,7 +5271,7 @@
             <a:fld id="{B61BEF0D-F0BB-DE4B-95CE-6DB70DBA9567}" type="datetimeFigureOut">
               <a:rPr lang="en-US" dirty="0"/>
               <a:pPr/>
-              <a:t>9/11/2025</a:t>
+              <a:t>9/18/2025</a:t>
             </a:fld>
             <a:endParaRPr lang="en-US" dirty="0"/>
           </a:p>
@@ -5306,7 +5394,7 @@
             <a:fld id="{B61BEF0D-F0BB-DE4B-95CE-6DB70DBA9567}" type="datetimeFigureOut">
               <a:rPr lang="en-US" dirty="0"/>
               <a:pPr/>
-              <a:t>9/11/2025</a:t>
+              <a:t>9/18/2025</a:t>
             </a:fld>
             <a:endParaRPr lang="en-US" dirty="0"/>
           </a:p>
@@ -5558,7 +5646,7 @@
             <a:fld id="{B61BEF0D-F0BB-DE4B-95CE-6DB70DBA9567}" type="datetimeFigureOut">
               <a:rPr lang="en-US" dirty="0"/>
               <a:pPr/>
-              <a:t>9/11/2025</a:t>
+              <a:t>9/18/2025</a:t>
             </a:fld>
             <a:endParaRPr lang="en-US" dirty="0"/>
           </a:p>
@@ -5870,7 +5958,7 @@
             <a:fld id="{B61BEF0D-F0BB-DE4B-95CE-6DB70DBA9567}" type="datetimeFigureOut">
               <a:rPr lang="en-US" dirty="0"/>
               <a:pPr/>
-              <a:t>9/11/2025</a:t>
+              <a:t>9/18/2025</a:t>
             </a:fld>
             <a:endParaRPr lang="en-US" dirty="0"/>
           </a:p>
@@ -6218,7 +6306,7 @@
             <a:fld id="{B61BEF0D-F0BB-DE4B-95CE-6DB70DBA9567}" type="datetimeFigureOut">
               <a:rPr lang="en-US" dirty="0"/>
               <a:pPr/>
-              <a:t>9/11/2025</a:t>
+              <a:t>9/18/2025</a:t>
             </a:fld>
             <a:endParaRPr lang="en-US" dirty="0"/>
           </a:p>
@@ -6815,6 +6903,536 @@
 </p:sld>
 </file>
 
+<file path=ppt/slides/slide10.xml><?xml version="1.0" encoding="utf-8"?>
+<p:sld xmlns:a="http://schemas.openxmlformats.org/drawingml/2006/main" xmlns:r="http://schemas.openxmlformats.org/officeDocument/2006/relationships" xmlns:p="http://schemas.openxmlformats.org/presentationml/2006/main">
+  <p:cSld>
+    <p:spTree>
+      <p:nvGrpSpPr>
+        <p:cNvPr id="1" name=""/>
+        <p:cNvGrpSpPr/>
+        <p:nvPr/>
+      </p:nvGrpSpPr>
+      <p:grpSpPr>
+        <a:xfrm>
+          <a:off x="0" y="0"/>
+          <a:ext cx="0" cy="0"/>
+          <a:chOff x="0" y="0"/>
+          <a:chExt cx="0" cy="0"/>
+        </a:xfrm>
+      </p:grpSpPr>
+      <p:sp>
+        <p:nvSpPr>
+          <p:cNvPr id="2" name="Title 1"/>
+          <p:cNvSpPr>
+            <a:spLocks noGrp="1"/>
+          </p:cNvSpPr>
+          <p:nvPr>
+            <p:ph type="title"/>
+          </p:nvPr>
+        </p:nvSpPr>
+        <p:spPr/>
+        <p:txBody>
+          <a:bodyPr/>
+          <a:lstStyle/>
+          <a:p>
+            <a:r>
+              <a:rPr lang="en-US" b="1" dirty="0" smtClean="0"/>
+              <a:t>Agenda – Semester 3, Week </a:t>
+            </a:r>
+            <a:r>
+              <a:rPr lang="en-US" b="1" dirty="0" smtClean="0"/>
+              <a:t>3</a:t>
+            </a:r>
+            <a:endParaRPr lang="en-US" b="1" dirty="0"/>
+          </a:p>
+        </p:txBody>
+      </p:sp>
+      <p:sp>
+        <p:nvSpPr>
+          <p:cNvPr id="3" name="Content Placeholder 2"/>
+          <p:cNvSpPr>
+            <a:spLocks noGrp="1"/>
+          </p:cNvSpPr>
+          <p:nvPr>
+            <p:ph idx="1"/>
+          </p:nvPr>
+        </p:nvSpPr>
+        <p:spPr/>
+        <p:txBody>
+          <a:bodyPr>
+            <a:normAutofit/>
+          </a:bodyPr>
+          <a:lstStyle/>
+          <a:p>
+            <a:r>
+              <a:rPr lang="en-US" b="1" dirty="0" smtClean="0"/>
+              <a:t>Week </a:t>
+            </a:r>
+            <a:r>
+              <a:rPr lang="en-US" b="1" dirty="0" smtClean="0"/>
+              <a:t>3 </a:t>
+            </a:r>
+            <a:r>
+              <a:rPr lang="en-US" dirty="0" smtClean="0"/>
+              <a:t>Activities: </a:t>
+            </a:r>
+            <a:r>
+              <a:rPr lang="en-US" dirty="0" smtClean="0"/>
+              <a:t>GitHub status badge, Interview for coding practice “Sort a list”</a:t>
+            </a:r>
+            <a:endParaRPr lang="en-US" dirty="0" smtClean="0"/>
+          </a:p>
+          <a:p>
+            <a:r>
+              <a:rPr lang="en-US" b="1" dirty="0" smtClean="0"/>
+              <a:t>Project </a:t>
+            </a:r>
+            <a:r>
+              <a:rPr lang="en-US" b="1" dirty="0" smtClean="0"/>
+              <a:t>Work: </a:t>
+            </a:r>
+            <a:r>
+              <a:rPr lang="en-US" dirty="0" smtClean="0"/>
+              <a:t>“Project Pulse” &amp; Schoology SQL 1 &amp; 2</a:t>
+            </a:r>
+          </a:p>
+          <a:p>
+            <a:pPr lvl="1"/>
+            <a:r>
+              <a:rPr lang="en-US" b="1" dirty="0" smtClean="0"/>
+              <a:t>Status? </a:t>
+            </a:r>
+            <a:r>
+              <a:rPr lang="en-US" dirty="0" smtClean="0"/>
+              <a:t>Behind. </a:t>
+            </a:r>
+            <a:endParaRPr lang="en-US" dirty="0" smtClean="0"/>
+          </a:p>
+          <a:p>
+            <a:pPr lvl="1"/>
+            <a:r>
+              <a:rPr lang="en-US" b="1" dirty="0" smtClean="0"/>
+              <a:t>Resolution </a:t>
+            </a:r>
+            <a:r>
+              <a:rPr lang="en-US" b="1" dirty="0" smtClean="0"/>
+              <a:t>Plan: </a:t>
+            </a:r>
+            <a:r>
+              <a:rPr lang="en-US" dirty="0" smtClean="0"/>
+              <a:t>Wra</a:t>
+            </a:r>
+            <a:r>
+              <a:rPr lang="en-US" dirty="0" smtClean="0"/>
+              <a:t>p up project, and pivot to planning next Semester’s job related learning goals.</a:t>
+            </a:r>
+            <a:endParaRPr lang="en-US" dirty="0" smtClean="0"/>
+          </a:p>
+          <a:p>
+            <a:r>
+              <a:rPr lang="en-US" b="1" dirty="0" smtClean="0"/>
+              <a:t>Demo</a:t>
+            </a:r>
+            <a:endParaRPr lang="en-US" b="1" dirty="0" smtClean="0"/>
+          </a:p>
+        </p:txBody>
+      </p:sp>
+    </p:spTree>
+    <p:extLst>
+      <p:ext uri="{BB962C8B-B14F-4D97-AF65-F5344CB8AC3E}">
+        <p14:creationId xmlns:p14="http://schemas.microsoft.com/office/powerpoint/2010/main" val="2807818643"/>
+      </p:ext>
+    </p:extLst>
+  </p:cSld>
+  <p:clrMapOvr>
+    <a:masterClrMapping/>
+  </p:clrMapOvr>
+  <p:timing>
+    <p:tnLst>
+      <p:par>
+        <p:cTn id="1" dur="indefinite" restart="never" nodeType="tmRoot"/>
+      </p:par>
+    </p:tnLst>
+  </p:timing>
+</p:sld>
+</file>
+
+<file path=ppt/slides/slide11.xml><?xml version="1.0" encoding="utf-8"?>
+<p:sld xmlns:a="http://schemas.openxmlformats.org/drawingml/2006/main" xmlns:r="http://schemas.openxmlformats.org/officeDocument/2006/relationships" xmlns:p="http://schemas.openxmlformats.org/presentationml/2006/main">
+  <p:cSld>
+    <p:spTree>
+      <p:nvGrpSpPr>
+        <p:cNvPr id="1" name=""/>
+        <p:cNvGrpSpPr/>
+        <p:nvPr/>
+      </p:nvGrpSpPr>
+      <p:grpSpPr>
+        <a:xfrm>
+          <a:off x="0" y="0"/>
+          <a:ext cx="0" cy="0"/>
+          <a:chOff x="0" y="0"/>
+          <a:chExt cx="0" cy="0"/>
+        </a:xfrm>
+      </p:grpSpPr>
+      <p:sp>
+        <p:nvSpPr>
+          <p:cNvPr id="4" name="Title 1"/>
+          <p:cNvSpPr txBox="1">
+            <a:spLocks/>
+          </p:cNvSpPr>
+          <p:nvPr/>
+        </p:nvSpPr>
+        <p:spPr>
+          <a:xfrm>
+            <a:off x="1086396" y="2040223"/>
+            <a:ext cx="2466701" cy="2134212"/>
+          </a:xfrm>
+          <a:prstGeom prst="rect">
+            <a:avLst/>
+          </a:prstGeom>
+        </p:spPr>
+        <p:txBody>
+          <a:bodyPr/>
+          <a:lstStyle>
+            <a:lvl1pPr algn="ctr" defTabSz="457200" rtl="0" eaLnBrk="1" latinLnBrk="0" hangingPunct="1">
+              <a:spcBef>
+                <a:spcPct val="0"/>
+              </a:spcBef>
+              <a:buNone/>
+              <a:defRPr sz="4400" kern="1200" cap="none">
+                <a:ln w="3175" cmpd="sng">
+                  <a:noFill/>
+                </a:ln>
+                <a:solidFill>
+                  <a:schemeClr val="tx1">
+                    <a:lumMod val="85000"/>
+                    <a:lumOff val="15000"/>
+                  </a:schemeClr>
+                </a:solidFill>
+                <a:effectLst/>
+                <a:latin typeface="+mj-lt"/>
+                <a:ea typeface="+mj-ea"/>
+                <a:cs typeface="+mj-cs"/>
+              </a:defRPr>
+            </a:lvl1pPr>
+            <a:lvl2pPr eaLnBrk="1" hangingPunct="1">
+              <a:defRPr>
+                <a:solidFill>
+                  <a:schemeClr val="tx2"/>
+                </a:solidFill>
+              </a:defRPr>
+            </a:lvl2pPr>
+            <a:lvl3pPr eaLnBrk="1" hangingPunct="1">
+              <a:defRPr>
+                <a:solidFill>
+                  <a:schemeClr val="tx2"/>
+                </a:solidFill>
+              </a:defRPr>
+            </a:lvl3pPr>
+            <a:lvl4pPr eaLnBrk="1" hangingPunct="1">
+              <a:defRPr>
+                <a:solidFill>
+                  <a:schemeClr val="tx2"/>
+                </a:solidFill>
+              </a:defRPr>
+            </a:lvl4pPr>
+            <a:lvl5pPr eaLnBrk="1" hangingPunct="1">
+              <a:defRPr>
+                <a:solidFill>
+                  <a:schemeClr val="tx2"/>
+                </a:solidFill>
+              </a:defRPr>
+            </a:lvl5pPr>
+            <a:lvl6pPr eaLnBrk="1" hangingPunct="1">
+              <a:defRPr>
+                <a:solidFill>
+                  <a:schemeClr val="tx2"/>
+                </a:solidFill>
+              </a:defRPr>
+            </a:lvl6pPr>
+            <a:lvl7pPr eaLnBrk="1" hangingPunct="1">
+              <a:defRPr>
+                <a:solidFill>
+                  <a:schemeClr val="tx2"/>
+                </a:solidFill>
+              </a:defRPr>
+            </a:lvl7pPr>
+            <a:lvl8pPr eaLnBrk="1" hangingPunct="1">
+              <a:defRPr>
+                <a:solidFill>
+                  <a:schemeClr val="tx2"/>
+                </a:solidFill>
+              </a:defRPr>
+            </a:lvl8pPr>
+            <a:lvl9pPr eaLnBrk="1" hangingPunct="1">
+              <a:defRPr>
+                <a:solidFill>
+                  <a:schemeClr val="tx2"/>
+                </a:solidFill>
+              </a:defRPr>
+            </a:lvl9pPr>
+          </a:lstStyle>
+          <a:p>
+            <a:r>
+              <a:rPr lang="en-US" b="1" dirty="0" smtClean="0"/>
+              <a:t>GitHub Status Badge</a:t>
+            </a:r>
+            <a:endParaRPr lang="en-US" b="1" dirty="0"/>
+          </a:p>
+        </p:txBody>
+      </p:sp>
+      <p:pic>
+        <p:nvPicPr>
+          <p:cNvPr id="3" name="Picture 2"/>
+          <p:cNvPicPr>
+            <a:picLocks noChangeAspect="1"/>
+          </p:cNvPicPr>
+          <p:nvPr/>
+        </p:nvPicPr>
+        <p:blipFill>
+          <a:blip r:embed="rId2"/>
+          <a:stretch>
+            <a:fillRect/>
+          </a:stretch>
+        </p:blipFill>
+        <p:spPr>
+          <a:xfrm>
+            <a:off x="3553097" y="1688171"/>
+            <a:ext cx="7857025" cy="2486264"/>
+          </a:xfrm>
+          <a:prstGeom prst="rect">
+            <a:avLst/>
+          </a:prstGeom>
+        </p:spPr>
+      </p:pic>
+      <p:pic>
+        <p:nvPicPr>
+          <p:cNvPr id="6" name="Picture 5"/>
+          <p:cNvPicPr>
+            <a:picLocks noChangeAspect="1"/>
+          </p:cNvPicPr>
+          <p:nvPr/>
+        </p:nvPicPr>
+        <p:blipFill>
+          <a:blip r:embed="rId3"/>
+          <a:stretch>
+            <a:fillRect/>
+          </a:stretch>
+        </p:blipFill>
+        <p:spPr>
+          <a:xfrm>
+            <a:off x="875472" y="4751684"/>
+            <a:ext cx="10534650" cy="857250"/>
+          </a:xfrm>
+          <a:prstGeom prst="rect">
+            <a:avLst/>
+          </a:prstGeom>
+        </p:spPr>
+      </p:pic>
+    </p:spTree>
+    <p:extLst>
+      <p:ext uri="{BB962C8B-B14F-4D97-AF65-F5344CB8AC3E}">
+        <p14:creationId xmlns:p14="http://schemas.microsoft.com/office/powerpoint/2010/main" val="509872030"/>
+      </p:ext>
+    </p:extLst>
+  </p:cSld>
+  <p:clrMapOvr>
+    <a:masterClrMapping/>
+  </p:clrMapOvr>
+  <mc:AlternateContent xmlns:mc="http://schemas.openxmlformats.org/markup-compatibility/2006">
+    <mc:Choice xmlns:p14="http://schemas.microsoft.com/office/powerpoint/2010/main" Requires="p14">
+      <p:transition spd="slow" p14:dur="2000"/>
+    </mc:Choice>
+    <mc:Fallback>
+      <p:transition spd="slow"/>
+    </mc:Fallback>
+  </mc:AlternateContent>
+  <p:timing>
+    <p:tnLst>
+      <p:par>
+        <p:cTn id="1" dur="indefinite" restart="never" nodeType="tmRoot"/>
+      </p:par>
+    </p:tnLst>
+  </p:timing>
+</p:sld>
+</file>
+
+<file path=ppt/slides/slide12.xml><?xml version="1.0" encoding="utf-8"?>
+<p:sld xmlns:a="http://schemas.openxmlformats.org/drawingml/2006/main" xmlns:r="http://schemas.openxmlformats.org/officeDocument/2006/relationships" xmlns:p="http://schemas.openxmlformats.org/presentationml/2006/main">
+  <p:cSld>
+    <p:spTree>
+      <p:nvGrpSpPr>
+        <p:cNvPr id="1" name=""/>
+        <p:cNvGrpSpPr/>
+        <p:nvPr/>
+      </p:nvGrpSpPr>
+      <p:grpSpPr>
+        <a:xfrm>
+          <a:off x="0" y="0"/>
+          <a:ext cx="0" cy="0"/>
+          <a:chOff x="0" y="0"/>
+          <a:chExt cx="0" cy="0"/>
+        </a:xfrm>
+      </p:grpSpPr>
+      <p:sp>
+        <p:nvSpPr>
+          <p:cNvPr id="4" name="Title 1"/>
+          <p:cNvSpPr txBox="1">
+            <a:spLocks/>
+          </p:cNvSpPr>
+          <p:nvPr/>
+        </p:nvSpPr>
+        <p:spPr>
+          <a:xfrm>
+            <a:off x="1086396" y="2040223"/>
+            <a:ext cx="2466701" cy="2134212"/>
+          </a:xfrm>
+          <a:prstGeom prst="rect">
+            <a:avLst/>
+          </a:prstGeom>
+        </p:spPr>
+        <p:txBody>
+          <a:bodyPr/>
+          <a:lstStyle>
+            <a:lvl1pPr algn="ctr" defTabSz="457200" rtl="0" eaLnBrk="1" latinLnBrk="0" hangingPunct="1">
+              <a:spcBef>
+                <a:spcPct val="0"/>
+              </a:spcBef>
+              <a:buNone/>
+              <a:defRPr sz="4400" kern="1200" cap="none">
+                <a:ln w="3175" cmpd="sng">
+                  <a:noFill/>
+                </a:ln>
+                <a:solidFill>
+                  <a:schemeClr val="tx1">
+                    <a:lumMod val="85000"/>
+                    <a:lumOff val="15000"/>
+                  </a:schemeClr>
+                </a:solidFill>
+                <a:effectLst/>
+                <a:latin typeface="+mj-lt"/>
+                <a:ea typeface="+mj-ea"/>
+                <a:cs typeface="+mj-cs"/>
+              </a:defRPr>
+            </a:lvl1pPr>
+            <a:lvl2pPr eaLnBrk="1" hangingPunct="1">
+              <a:defRPr>
+                <a:solidFill>
+                  <a:schemeClr val="tx2"/>
+                </a:solidFill>
+              </a:defRPr>
+            </a:lvl2pPr>
+            <a:lvl3pPr eaLnBrk="1" hangingPunct="1">
+              <a:defRPr>
+                <a:solidFill>
+                  <a:schemeClr val="tx2"/>
+                </a:solidFill>
+              </a:defRPr>
+            </a:lvl3pPr>
+            <a:lvl4pPr eaLnBrk="1" hangingPunct="1">
+              <a:defRPr>
+                <a:solidFill>
+                  <a:schemeClr val="tx2"/>
+                </a:solidFill>
+              </a:defRPr>
+            </a:lvl4pPr>
+            <a:lvl5pPr eaLnBrk="1" hangingPunct="1">
+              <a:defRPr>
+                <a:solidFill>
+                  <a:schemeClr val="tx2"/>
+                </a:solidFill>
+              </a:defRPr>
+            </a:lvl5pPr>
+            <a:lvl6pPr eaLnBrk="1" hangingPunct="1">
+              <a:defRPr>
+                <a:solidFill>
+                  <a:schemeClr val="tx2"/>
+                </a:solidFill>
+              </a:defRPr>
+            </a:lvl6pPr>
+            <a:lvl7pPr eaLnBrk="1" hangingPunct="1">
+              <a:defRPr>
+                <a:solidFill>
+                  <a:schemeClr val="tx2"/>
+                </a:solidFill>
+              </a:defRPr>
+            </a:lvl7pPr>
+            <a:lvl8pPr eaLnBrk="1" hangingPunct="1">
+              <a:defRPr>
+                <a:solidFill>
+                  <a:schemeClr val="tx2"/>
+                </a:solidFill>
+              </a:defRPr>
+            </a:lvl8pPr>
+            <a:lvl9pPr eaLnBrk="1" hangingPunct="1">
+              <a:defRPr>
+                <a:solidFill>
+                  <a:schemeClr val="tx2"/>
+                </a:solidFill>
+              </a:defRPr>
+            </a:lvl9pPr>
+          </a:lstStyle>
+          <a:p>
+            <a:r>
+              <a:rPr lang="en-US" b="1" dirty="0" smtClean="0"/>
+              <a:t>Coding Practice: Sort a List</a:t>
+            </a:r>
+            <a:endParaRPr lang="en-US" b="1" dirty="0"/>
+          </a:p>
+        </p:txBody>
+      </p:sp>
+      <p:pic>
+        <p:nvPicPr>
+          <p:cNvPr id="5" name="Picture 4"/>
+          <p:cNvPicPr>
+            <a:picLocks noChangeAspect="1"/>
+          </p:cNvPicPr>
+          <p:nvPr/>
+        </p:nvPicPr>
+        <p:blipFill>
+          <a:blip r:embed="rId2"/>
+          <a:stretch>
+            <a:fillRect/>
+          </a:stretch>
+        </p:blipFill>
+        <p:spPr>
+          <a:xfrm>
+            <a:off x="4900405" y="784984"/>
+            <a:ext cx="5197751" cy="5248275"/>
+          </a:xfrm>
+          <a:prstGeom prst="rect">
+            <a:avLst/>
+          </a:prstGeom>
+        </p:spPr>
+      </p:pic>
+    </p:spTree>
+    <p:extLst>
+      <p:ext uri="{BB962C8B-B14F-4D97-AF65-F5344CB8AC3E}">
+        <p14:creationId xmlns:p14="http://schemas.microsoft.com/office/powerpoint/2010/main" val="2561902732"/>
+      </p:ext>
+    </p:extLst>
+  </p:cSld>
+  <p:clrMapOvr>
+    <a:masterClrMapping/>
+  </p:clrMapOvr>
+  <mc:AlternateContent xmlns:mc="http://schemas.openxmlformats.org/markup-compatibility/2006">
+    <mc:Choice xmlns:p14="http://schemas.microsoft.com/office/powerpoint/2010/main" Requires="p14">
+      <p:transition spd="slow" p14:dur="2000"/>
+    </mc:Choice>
+    <mc:Fallback>
+      <p:transition spd="slow"/>
+    </mc:Fallback>
+  </mc:AlternateContent>
+  <p:timing>
+    <p:tnLst>
+      <p:par>
+        <p:cTn id="1" dur="indefinite" restart="never" nodeType="tmRoot"/>
+      </p:par>
+    </p:tnLst>
+  </p:timing>
+</p:sld>
+</file>
+
 <file path=ppt/slides/slide2.xml><?xml version="1.0" encoding="utf-8"?>
 <p:sld xmlns:a="http://schemas.openxmlformats.org/drawingml/2006/main" xmlns:r="http://schemas.openxmlformats.org/officeDocument/2006/relationships" xmlns:p="http://schemas.openxmlformats.org/presentationml/2006/main" show="0">
   <p:cSld>
@@ -7012,11 +7630,11 @@
   <p:clrMapOvr>
     <a:masterClrMapping/>
   </p:clrMapOvr>
-  <mc:AlternateContent xmlns:mc="http://schemas.openxmlformats.org/markup-compatibility/2006">
-    <mc:Choice xmlns:p14="http://schemas.microsoft.com/office/powerpoint/2010/main" Requires="p14">
+  <mc:AlternateContent xmlns:mc="http://schemas.openxmlformats.org/markup-compatibility/2006" xmlns:p14="http://schemas.microsoft.com/office/powerpoint/2010/main">
+    <mc:Choice Requires="p14">
       <p:transition spd="slow" p14:dur="2000"/>
     </mc:Choice>
-    <mc:Fallback>
+    <mc:Fallback xmlns="">
       <p:transition spd="slow"/>
     </mc:Fallback>
   </mc:AlternateContent>
@@ -7130,11 +7748,11 @@
   <p:clrMapOvr>
     <a:masterClrMapping/>
   </p:clrMapOvr>
-  <mc:AlternateContent xmlns:mc="http://schemas.openxmlformats.org/markup-compatibility/2006">
-    <mc:Choice xmlns:p14="http://schemas.microsoft.com/office/powerpoint/2010/main" Requires="p14">
+  <mc:AlternateContent xmlns:mc="http://schemas.openxmlformats.org/markup-compatibility/2006" xmlns:p14="http://schemas.microsoft.com/office/powerpoint/2010/main">
+    <mc:Choice Requires="p14">
       <p:transition spd="slow" p14:dur="2000"/>
     </mc:Choice>
-    <mc:Fallback>
+    <mc:Fallback xmlns="">
       <p:transition spd="slow"/>
     </mc:Fallback>
   </mc:AlternateContent>
@@ -7397,11 +8015,11 @@
   <p:clrMapOvr>
     <a:masterClrMapping/>
   </p:clrMapOvr>
-  <mc:AlternateContent xmlns:mc="http://schemas.openxmlformats.org/markup-compatibility/2006">
-    <mc:Choice xmlns:p14="http://schemas.microsoft.com/office/powerpoint/2010/main" Requires="p14">
+  <mc:AlternateContent xmlns:mc="http://schemas.openxmlformats.org/markup-compatibility/2006" xmlns:p14="http://schemas.microsoft.com/office/powerpoint/2010/main">
+    <mc:Choice Requires="p14">
       <p:transition spd="slow" p14:dur="2000"/>
     </mc:Choice>
-    <mc:Fallback>
+    <mc:Fallback xmlns="">
       <p:transition spd="slow"/>
     </mc:Fallback>
   </mc:AlternateContent>
@@ -7597,6 +8215,93 @@
   <p:clrMapOvr>
     <a:masterClrMapping/>
   </p:clrMapOvr>
+  <mc:AlternateContent xmlns:mc="http://schemas.openxmlformats.org/markup-compatibility/2006" xmlns:p14="http://schemas.microsoft.com/office/powerpoint/2010/main">
+    <mc:Choice Requires="p14">
+      <p:transition spd="slow" p14:dur="2000"/>
+    </mc:Choice>
+    <mc:Fallback xmlns="">
+      <p:transition spd="slow"/>
+    </mc:Fallback>
+  </mc:AlternateContent>
+  <p:timing>
+    <p:tnLst>
+      <p:par>
+        <p:cTn id="1" dur="indefinite" restart="never" nodeType="tmRoot"/>
+      </p:par>
+    </p:tnLst>
+  </p:timing>
+</p:sld>
+</file>
+
+<file path=ppt/slides/slide7.xml><?xml version="1.0" encoding="utf-8"?>
+<p:sld xmlns:a="http://schemas.openxmlformats.org/drawingml/2006/main" xmlns:r="http://schemas.openxmlformats.org/officeDocument/2006/relationships" xmlns:p="http://schemas.openxmlformats.org/presentationml/2006/main" show="0">
+  <p:cSld>
+    <p:spTree>
+      <p:nvGrpSpPr>
+        <p:cNvPr id="1" name=""/>
+        <p:cNvGrpSpPr/>
+        <p:nvPr/>
+      </p:nvGrpSpPr>
+      <p:grpSpPr>
+        <a:xfrm>
+          <a:off x="0" y="0"/>
+          <a:ext cx="0" cy="0"/>
+          <a:chOff x="0" y="0"/>
+          <a:chExt cx="0" cy="0"/>
+        </a:xfrm>
+      </p:grpSpPr>
+      <p:sp>
+        <p:nvSpPr>
+          <p:cNvPr id="2" name="Title 1"/>
+          <p:cNvSpPr>
+            <a:spLocks noGrp="1"/>
+          </p:cNvSpPr>
+          <p:nvPr>
+            <p:ph type="ctrTitle"/>
+          </p:nvPr>
+        </p:nvSpPr>
+        <p:spPr>
+          <a:xfrm>
+            <a:off x="2679335" y="2498149"/>
+            <a:ext cx="6815669" cy="1515533"/>
+          </a:xfrm>
+        </p:spPr>
+        <p:txBody>
+          <a:bodyPr/>
+          <a:lstStyle/>
+          <a:p>
+            <a:r>
+              <a:rPr lang="en-US" dirty="0" smtClean="0"/>
+              <a:t>Lisa’s Status Updates</a:t>
+            </a:r>
+            <a:br>
+              <a:rPr lang="en-US" dirty="0" smtClean="0"/>
+            </a:br>
+            <a:r>
+              <a:rPr lang="en-US" dirty="0" smtClean="0"/>
+              <a:t>Semester 3</a:t>
+            </a:r>
+            <a:br>
+              <a:rPr lang="en-US" dirty="0" smtClean="0"/>
+            </a:br>
+            <a:r>
+              <a:rPr lang="en-US" sz="2400" dirty="0" smtClean="0"/>
+              <a:t>Backend Web Developer</a:t>
+            </a:r>
+            <a:endParaRPr lang="en-US" dirty="0"/>
+          </a:p>
+        </p:txBody>
+      </p:sp>
+    </p:spTree>
+    <p:extLst>
+      <p:ext uri="{BB962C8B-B14F-4D97-AF65-F5344CB8AC3E}">
+        <p14:creationId xmlns:p14="http://schemas.microsoft.com/office/powerpoint/2010/main" val="77997234"/>
+      </p:ext>
+    </p:extLst>
+  </p:cSld>
+  <p:clrMapOvr>
+    <a:masterClrMapping/>
+  </p:clrMapOvr>
   <mc:AlternateContent xmlns:mc="http://schemas.openxmlformats.org/markup-compatibility/2006">
     <mc:Choice xmlns:p14="http://schemas.microsoft.com/office/powerpoint/2010/main" Requires="p14">
       <p:transition spd="slow" p14:dur="2000"/>
@@ -7615,7 +8320,131 @@
 </p:sld>
 </file>
 
-<file path=ppt/slides/slide7.xml><?xml version="1.0" encoding="utf-8"?>
+<file path=ppt/slides/slide8.xml><?xml version="1.0" encoding="utf-8"?>
+<p:sld xmlns:a="http://schemas.openxmlformats.org/drawingml/2006/main" xmlns:r="http://schemas.openxmlformats.org/officeDocument/2006/relationships" xmlns:p="http://schemas.openxmlformats.org/presentationml/2006/main" show="0">
+  <p:cSld>
+    <p:spTree>
+      <p:nvGrpSpPr>
+        <p:cNvPr id="1" name=""/>
+        <p:cNvGrpSpPr/>
+        <p:nvPr/>
+      </p:nvGrpSpPr>
+      <p:grpSpPr>
+        <a:xfrm>
+          <a:off x="0" y="0"/>
+          <a:ext cx="0" cy="0"/>
+          <a:chOff x="0" y="0"/>
+          <a:chExt cx="0" cy="0"/>
+        </a:xfrm>
+      </p:grpSpPr>
+      <p:sp>
+        <p:nvSpPr>
+          <p:cNvPr id="2" name="Title 1"/>
+          <p:cNvSpPr>
+            <a:spLocks noGrp="1"/>
+          </p:cNvSpPr>
+          <p:nvPr>
+            <p:ph type="title"/>
+          </p:nvPr>
+        </p:nvSpPr>
+        <p:spPr/>
+        <p:txBody>
+          <a:bodyPr/>
+          <a:lstStyle/>
+          <a:p>
+            <a:r>
+              <a:rPr lang="en-US" b="1" dirty="0" smtClean="0"/>
+              <a:t>Agenda – Semester 3, Week 2</a:t>
+            </a:r>
+            <a:endParaRPr lang="en-US" b="1" dirty="0"/>
+          </a:p>
+        </p:txBody>
+      </p:sp>
+      <p:sp>
+        <p:nvSpPr>
+          <p:cNvPr id="3" name="Content Placeholder 2"/>
+          <p:cNvSpPr>
+            <a:spLocks noGrp="1"/>
+          </p:cNvSpPr>
+          <p:nvPr>
+            <p:ph idx="1"/>
+          </p:nvPr>
+        </p:nvSpPr>
+        <p:spPr/>
+        <p:txBody>
+          <a:bodyPr>
+            <a:normAutofit/>
+          </a:bodyPr>
+          <a:lstStyle/>
+          <a:p>
+            <a:r>
+              <a:rPr lang="en-US" dirty="0" smtClean="0"/>
+              <a:t>Week 2 Activities: ADR (Architectural Design Review), Contributing.md file, RCA (Root Cause Analysis) file</a:t>
+            </a:r>
+          </a:p>
+          <a:p>
+            <a:r>
+              <a:rPr lang="en-US" dirty="0" smtClean="0"/>
+              <a:t>Project Work “Project Pulse” &amp; Schoology SQL 1 &amp; 2</a:t>
+            </a:r>
+          </a:p>
+          <a:p>
+            <a:r>
+              <a:rPr lang="en-US" dirty="0" smtClean="0"/>
+              <a:t>Status? Behind. Resolution Plan: Reschedule and adapt for next week.</a:t>
+            </a:r>
+          </a:p>
+          <a:p>
+            <a:r>
+              <a:rPr lang="en-US" dirty="0" smtClean="0"/>
+              <a:t>Demo:</a:t>
+            </a:r>
+          </a:p>
+          <a:p>
+            <a:pPr lvl="1"/>
+            <a:r>
+              <a:rPr lang="en-US" dirty="0" smtClean="0"/>
+              <a:t>ADR, contributing.md, root-cause-analysis file, SQL 2 deliverables</a:t>
+            </a:r>
+          </a:p>
+          <a:p>
+            <a:pPr lvl="1"/>
+            <a:r>
+              <a:rPr lang="en-US" dirty="0" smtClean="0"/>
+              <a:t>Monday Project Board</a:t>
+            </a:r>
+          </a:p>
+        </p:txBody>
+      </p:sp>
+    </p:spTree>
+    <p:extLst>
+      <p:ext uri="{BB962C8B-B14F-4D97-AF65-F5344CB8AC3E}">
+        <p14:creationId xmlns:p14="http://schemas.microsoft.com/office/powerpoint/2010/main" val="3035586449"/>
+      </p:ext>
+    </p:extLst>
+  </p:cSld>
+  <p:clrMapOvr>
+    <a:masterClrMapping/>
+  </p:clrMapOvr>
+  <mc:AlternateContent xmlns:mc="http://schemas.openxmlformats.org/markup-compatibility/2006">
+    <mc:Choice xmlns:p14="http://schemas.microsoft.com/office/powerpoint/2010/main" Requires="p14">
+      <p:transition spd="slow" p14:dur="2000"/>
+    </mc:Choice>
+    <mc:Fallback>
+      <p:transition spd="slow"/>
+    </mc:Fallback>
+  </mc:AlternateContent>
+  <p:timing>
+    <p:tnLst>
+      <p:par>
+        <p:cTn id="1" dur="indefinite" restart="never" nodeType="tmRoot"/>
+      </p:par>
+    </p:tnLst>
+  </p:timing>
+</p:sld>
+</file>
+
+<file path=ppt/slides/slide9.xml><?xml version="1.0" encoding="utf-8"?>
 <p:sld xmlns:a="http://schemas.openxmlformats.org/drawingml/2006/main" xmlns:r="http://schemas.openxmlformats.org/officeDocument/2006/relationships" xmlns:p="http://schemas.openxmlformats.org/presentationml/2006/main">
   <p:cSld>
     <p:spTree>
@@ -7677,160 +8506,7 @@
     </p:spTree>
     <p:extLst>
       <p:ext uri="{BB962C8B-B14F-4D97-AF65-F5344CB8AC3E}">
-        <p14:creationId xmlns:p14="http://schemas.microsoft.com/office/powerpoint/2010/main" val="77997234"/>
-      </p:ext>
-    </p:extLst>
-  </p:cSld>
-  <p:clrMapOvr>
-    <a:masterClrMapping/>
-  </p:clrMapOvr>
-  <p:timing>
-    <p:tnLst>
-      <p:par>
-        <p:cTn id="1" dur="indefinite" restart="never" nodeType="tmRoot"/>
-      </p:par>
-    </p:tnLst>
-  </p:timing>
-</p:sld>
-</file>
-
-<file path=ppt/slides/slide8.xml><?xml version="1.0" encoding="utf-8"?>
-<p:sld xmlns:a="http://schemas.openxmlformats.org/drawingml/2006/main" xmlns:r="http://schemas.openxmlformats.org/officeDocument/2006/relationships" xmlns:p="http://schemas.openxmlformats.org/presentationml/2006/main">
-  <p:cSld>
-    <p:spTree>
-      <p:nvGrpSpPr>
-        <p:cNvPr id="1" name=""/>
-        <p:cNvGrpSpPr/>
-        <p:nvPr/>
-      </p:nvGrpSpPr>
-      <p:grpSpPr>
-        <a:xfrm>
-          <a:off x="0" y="0"/>
-          <a:ext cx="0" cy="0"/>
-          <a:chOff x="0" y="0"/>
-          <a:chExt cx="0" cy="0"/>
-        </a:xfrm>
-      </p:grpSpPr>
-      <p:sp>
-        <p:nvSpPr>
-          <p:cNvPr id="2" name="Title 1"/>
-          <p:cNvSpPr>
-            <a:spLocks noGrp="1"/>
-          </p:cNvSpPr>
-          <p:nvPr>
-            <p:ph type="title"/>
-          </p:nvPr>
-        </p:nvSpPr>
-        <p:spPr/>
-        <p:txBody>
-          <a:bodyPr/>
-          <a:lstStyle/>
-          <a:p>
-            <a:r>
-              <a:rPr lang="en-US" b="1" dirty="0" smtClean="0"/>
-              <a:t>Agenda – Semester 3, Week </a:t>
-            </a:r>
-            <a:r>
-              <a:rPr lang="en-US" b="1" dirty="0" smtClean="0"/>
-              <a:t>2</a:t>
-            </a:r>
-            <a:endParaRPr lang="en-US" b="1" dirty="0"/>
-          </a:p>
-        </p:txBody>
-      </p:sp>
-      <p:sp>
-        <p:nvSpPr>
-          <p:cNvPr id="3" name="Content Placeholder 2"/>
-          <p:cNvSpPr>
-            <a:spLocks noGrp="1"/>
-          </p:cNvSpPr>
-          <p:nvPr>
-            <p:ph idx="1"/>
-          </p:nvPr>
-        </p:nvSpPr>
-        <p:spPr/>
-        <p:txBody>
-          <a:bodyPr>
-            <a:normAutofit/>
-          </a:bodyPr>
-          <a:lstStyle/>
-          <a:p>
-            <a:r>
-              <a:rPr lang="en-US" dirty="0" smtClean="0"/>
-              <a:t>Week </a:t>
-            </a:r>
-            <a:r>
-              <a:rPr lang="en-US" dirty="0" smtClean="0"/>
-              <a:t>2 </a:t>
-            </a:r>
-            <a:r>
-              <a:rPr lang="en-US" dirty="0" smtClean="0"/>
-              <a:t>Activities: </a:t>
-            </a:r>
-            <a:r>
-              <a:rPr lang="en-US" dirty="0" smtClean="0"/>
-              <a:t>ADR (Architectural Design Review), Contributing.md file, RCA (Root Cause Analysis) file</a:t>
-            </a:r>
-          </a:p>
-          <a:p>
-            <a:r>
-              <a:rPr lang="en-US" dirty="0" smtClean="0"/>
-              <a:t>Project Work “Project Pulse” &amp; Schoology SQL 1 &amp; 2</a:t>
-            </a:r>
-          </a:p>
-          <a:p>
-            <a:r>
-              <a:rPr lang="en-US" dirty="0" smtClean="0"/>
-              <a:t>Status</a:t>
-            </a:r>
-            <a:r>
-              <a:rPr lang="en-US" dirty="0" smtClean="0"/>
-              <a:t>? Behind. Resolution Plan: </a:t>
-            </a:r>
-            <a:r>
-              <a:rPr lang="en-US" dirty="0" smtClean="0"/>
-              <a:t>Reschedule and adapt for next </a:t>
-            </a:r>
-            <a:r>
-              <a:rPr lang="en-US" dirty="0" smtClean="0"/>
-              <a:t>week.</a:t>
-            </a:r>
-          </a:p>
-          <a:p>
-            <a:r>
-              <a:rPr lang="en-US" dirty="0" smtClean="0"/>
-              <a:t>Demo</a:t>
-            </a:r>
-            <a:r>
-              <a:rPr lang="en-US" dirty="0" smtClean="0"/>
-              <a:t>:</a:t>
-            </a:r>
-          </a:p>
-          <a:p>
-            <a:pPr lvl="1"/>
-            <a:r>
-              <a:rPr lang="en-US" dirty="0" smtClean="0"/>
-              <a:t>ADR, contributing.md, root-cause-analysis file, SQL 2 delivera</a:t>
-            </a:r>
-            <a:r>
-              <a:rPr lang="en-US" dirty="0" smtClean="0"/>
-              <a:t>bles</a:t>
-            </a:r>
-            <a:endParaRPr lang="en-US" dirty="0" smtClean="0"/>
-          </a:p>
-          <a:p>
-            <a:pPr lvl="1"/>
-            <a:r>
-              <a:rPr lang="en-US" dirty="0" smtClean="0"/>
-              <a:t>Monday Project Board</a:t>
-            </a:r>
-          </a:p>
-        </p:txBody>
-      </p:sp>
-    </p:spTree>
-    <p:extLst>
-      <p:ext uri="{BB962C8B-B14F-4D97-AF65-F5344CB8AC3E}">
-        <p14:creationId xmlns:p14="http://schemas.microsoft.com/office/powerpoint/2010/main" val="3035586449"/>
+        <p14:creationId xmlns:p14="http://schemas.microsoft.com/office/powerpoint/2010/main" val="3024903164"/>
       </p:ext>
     </p:extLst>
   </p:cSld>

</xml_diff>

<commit_message>
Add Project Pulse app files
</commit_message>
<xml_diff>
--- a/Other/Lisa’s Status Updates.pptx
+++ b/Other/Lisa’s Status Updates.pptx
@@ -5,7 +5,7 @@
     <p:sldMasterId id="2147483648" r:id="rId1"/>
   </p:sldMasterIdLst>
   <p:notesMasterIdLst>
-    <p:notesMasterId r:id="rId14"/>
+    <p:notesMasterId r:id="rId31"/>
   </p:notesMasterIdLst>
   <p:sldIdLst>
     <p:sldId id="256" r:id="rId2"/>
@@ -20,6 +20,23 @@
     <p:sldId id="265" r:id="rId11"/>
     <p:sldId id="267" r:id="rId12"/>
     <p:sldId id="266" r:id="rId13"/>
+    <p:sldId id="268" r:id="rId14"/>
+    <p:sldId id="269" r:id="rId15"/>
+    <p:sldId id="273" r:id="rId16"/>
+    <p:sldId id="270" r:id="rId17"/>
+    <p:sldId id="272" r:id="rId18"/>
+    <p:sldId id="271" r:id="rId19"/>
+    <p:sldId id="285" r:id="rId20"/>
+    <p:sldId id="284" r:id="rId21"/>
+    <p:sldId id="274" r:id="rId22"/>
+    <p:sldId id="280" r:id="rId23"/>
+    <p:sldId id="275" r:id="rId24"/>
+    <p:sldId id="279" r:id="rId25"/>
+    <p:sldId id="276" r:id="rId26"/>
+    <p:sldId id="277" r:id="rId27"/>
+    <p:sldId id="281" r:id="rId28"/>
+    <p:sldId id="282" r:id="rId29"/>
+    <p:sldId id="283" r:id="rId30"/>
   </p:sldIdLst>
   <p:sldSz cx="12192000" cy="6858000"/>
   <p:notesSz cx="6858000" cy="9144000"/>
@@ -208,7 +225,7 @@
           <a:p>
             <a:fld id="{235E2641-94F1-4F41-BC64-DA1C34E512FB}" type="datetimeFigureOut">
               <a:rPr lang="en-US" smtClean="0"/>
-              <a:t>9/18/2025</a:t>
+              <a:t>9/25/2025</a:t>
             </a:fld>
             <a:endParaRPr lang="en-US"/>
           </a:p>
@@ -1146,6 +1163,90 @@
     <p:extLst>
       <p:ext uri="{BB962C8B-B14F-4D97-AF65-F5344CB8AC3E}">
         <p14:creationId xmlns:p14="http://schemas.microsoft.com/office/powerpoint/2010/main" val="1641646836"/>
+      </p:ext>
+    </p:extLst>
+  </p:cSld>
+  <p:clrMapOvr>
+    <a:masterClrMapping/>
+  </p:clrMapOvr>
+</p:notes>
+</file>
+
+<file path=ppt/notesSlides/notesSlide5.xml><?xml version="1.0" encoding="utf-8"?>
+<p:notes xmlns:a="http://schemas.openxmlformats.org/drawingml/2006/main" xmlns:r="http://schemas.openxmlformats.org/officeDocument/2006/relationships" xmlns:p="http://schemas.openxmlformats.org/presentationml/2006/main">
+  <p:cSld>
+    <p:spTree>
+      <p:nvGrpSpPr>
+        <p:cNvPr id="1" name=""/>
+        <p:cNvGrpSpPr/>
+        <p:nvPr/>
+      </p:nvGrpSpPr>
+      <p:grpSpPr>
+        <a:xfrm>
+          <a:off x="0" y="0"/>
+          <a:ext cx="0" cy="0"/>
+          <a:chOff x="0" y="0"/>
+          <a:chExt cx="0" cy="0"/>
+        </a:xfrm>
+      </p:grpSpPr>
+      <p:sp>
+        <p:nvSpPr>
+          <p:cNvPr id="2" name="Slide Image Placeholder 1"/>
+          <p:cNvSpPr>
+            <a:spLocks noGrp="1" noRot="1" noChangeAspect="1"/>
+          </p:cNvSpPr>
+          <p:nvPr>
+            <p:ph type="sldImg"/>
+          </p:nvPr>
+        </p:nvSpPr>
+        <p:spPr/>
+      </p:sp>
+      <p:sp>
+        <p:nvSpPr>
+          <p:cNvPr id="3" name="Notes Placeholder 2"/>
+          <p:cNvSpPr>
+            <a:spLocks noGrp="1"/>
+          </p:cNvSpPr>
+          <p:nvPr>
+            <p:ph type="body" idx="1"/>
+          </p:nvPr>
+        </p:nvSpPr>
+        <p:spPr/>
+        <p:txBody>
+          <a:bodyPr/>
+          <a:lstStyle/>
+          <a:p>
+            <a:endParaRPr lang="en-US" dirty="0"/>
+          </a:p>
+        </p:txBody>
+      </p:sp>
+      <p:sp>
+        <p:nvSpPr>
+          <p:cNvPr id="4" name="Slide Number Placeholder 3"/>
+          <p:cNvSpPr>
+            <a:spLocks noGrp="1"/>
+          </p:cNvSpPr>
+          <p:nvPr>
+            <p:ph type="sldNum" sz="quarter" idx="10"/>
+          </p:nvPr>
+        </p:nvSpPr>
+        <p:spPr/>
+        <p:txBody>
+          <a:bodyPr/>
+          <a:lstStyle/>
+          <a:p>
+            <a:fld id="{D195DE54-355A-4569-8D12-E453AA6D2C38}" type="slidenum">
+              <a:rPr lang="en-US" smtClean="0"/>
+              <a:t>14</a:t>
+            </a:fld>
+            <a:endParaRPr lang="en-US"/>
+          </a:p>
+        </p:txBody>
+      </p:sp>
+    </p:spTree>
+    <p:extLst>
+      <p:ext uri="{BB962C8B-B14F-4D97-AF65-F5344CB8AC3E}">
+        <p14:creationId xmlns:p14="http://schemas.microsoft.com/office/powerpoint/2010/main" val="166078417"/>
       </p:ext>
     </p:extLst>
   </p:cSld>
@@ -1487,7 +1588,7 @@
             <a:fld id="{B61BEF0D-F0BB-DE4B-95CE-6DB70DBA9567}" type="datetimeFigureOut">
               <a:rPr lang="en-US" dirty="0"/>
               <a:pPr/>
-              <a:t>9/18/2025</a:t>
+              <a:t>9/25/2025</a:t>
             </a:fld>
             <a:endParaRPr lang="en-US" dirty="0"/>
           </a:p>
@@ -1808,7 +1909,7 @@
             <a:fld id="{B61BEF0D-F0BB-DE4B-95CE-6DB70DBA9567}" type="datetimeFigureOut">
               <a:rPr lang="en-US" dirty="0"/>
               <a:pPr/>
-              <a:t>9/18/2025</a:t>
+              <a:t>9/25/2025</a:t>
             </a:fld>
             <a:endParaRPr lang="en-US" dirty="0"/>
           </a:p>
@@ -2053,7 +2154,7 @@
             <a:fld id="{B61BEF0D-F0BB-DE4B-95CE-6DB70DBA9567}" type="datetimeFigureOut">
               <a:rPr lang="en-US" dirty="0"/>
               <a:pPr/>
-              <a:t>9/18/2025</a:t>
+              <a:t>9/25/2025</a:t>
             </a:fld>
             <a:endParaRPr lang="en-US" dirty="0"/>
           </a:p>
@@ -2389,7 +2490,7 @@
             <a:fld id="{B61BEF0D-F0BB-DE4B-95CE-6DB70DBA9567}" type="datetimeFigureOut">
               <a:rPr lang="en-US" dirty="0"/>
               <a:pPr/>
-              <a:t>9/18/2025</a:t>
+              <a:t>9/25/2025</a:t>
             </a:fld>
             <a:endParaRPr lang="en-US" dirty="0"/>
           </a:p>
@@ -2733,7 +2834,7 @@
             <a:fld id="{B61BEF0D-F0BB-DE4B-95CE-6DB70DBA9567}" type="datetimeFigureOut">
               <a:rPr lang="en-US" dirty="0"/>
               <a:pPr/>
-              <a:t>9/18/2025</a:t>
+              <a:t>9/25/2025</a:t>
             </a:fld>
             <a:endParaRPr lang="en-US" dirty="0"/>
           </a:p>
@@ -3104,7 +3205,7 @@
             <a:fld id="{B61BEF0D-F0BB-DE4B-95CE-6DB70DBA9567}" type="datetimeFigureOut">
               <a:rPr lang="en-US" dirty="0"/>
               <a:pPr/>
-              <a:t>9/18/2025</a:t>
+              <a:t>9/25/2025</a:t>
             </a:fld>
             <a:endParaRPr lang="en-US" dirty="0"/>
           </a:p>
@@ -3571,7 +3672,7 @@
             <a:fld id="{B61BEF0D-F0BB-DE4B-95CE-6DB70DBA9567}" type="datetimeFigureOut">
               <a:rPr lang="en-US" dirty="0"/>
               <a:pPr/>
-              <a:t>9/18/2025</a:t>
+              <a:t>9/25/2025</a:t>
             </a:fld>
             <a:endParaRPr lang="en-US" dirty="0"/>
           </a:p>
@@ -3773,7 +3874,7 @@
             <a:fld id="{B61BEF0D-F0BB-DE4B-95CE-6DB70DBA9567}" type="datetimeFigureOut">
               <a:rPr lang="en-US" dirty="0"/>
               <a:pPr/>
-              <a:t>9/18/2025</a:t>
+              <a:t>9/25/2025</a:t>
             </a:fld>
             <a:endParaRPr lang="en-US" dirty="0"/>
           </a:p>
@@ -3981,7 +4082,7 @@
             <a:fld id="{B61BEF0D-F0BB-DE4B-95CE-6DB70DBA9567}" type="datetimeFigureOut">
               <a:rPr lang="en-US" dirty="0"/>
               <a:pPr/>
-              <a:t>9/18/2025</a:t>
+              <a:t>9/25/2025</a:t>
             </a:fld>
             <a:endParaRPr lang="en-US" dirty="0"/>
           </a:p>
@@ -4209,7 +4310,7 @@
           <a:p>
             <a:fld id="{05BFA754-D5C3-4E66-96A6-867B257F58DC}" type="datetimeFigureOut">
               <a:rPr lang="en-US" dirty="0"/>
-              <a:t>9/18/2025</a:t>
+              <a:t>9/25/2025</a:t>
             </a:fld>
             <a:endParaRPr lang="en-US" dirty="0"/>
           </a:p>
@@ -4453,7 +4554,7 @@
             <a:fld id="{B61BEF0D-F0BB-DE4B-95CE-6DB70DBA9567}" type="datetimeFigureOut">
               <a:rPr lang="en-US" dirty="0"/>
               <a:pPr/>
-              <a:t>9/18/2025</a:t>
+              <a:t>9/25/2025</a:t>
             </a:fld>
             <a:endParaRPr lang="en-US" dirty="0"/>
           </a:p>
@@ -4716,7 +4817,7 @@
           <a:p>
             <a:fld id="{05BFA754-D5C3-4E66-96A6-867B257F58DC}" type="datetimeFigureOut">
               <a:rPr lang="en-US" dirty="0"/>
-              <a:t>9/18/2025</a:t>
+              <a:t>9/25/2025</a:t>
             </a:fld>
             <a:endParaRPr lang="en-US" dirty="0"/>
           </a:p>
@@ -5125,7 +5226,7 @@
             <a:fld id="{B61BEF0D-F0BB-DE4B-95CE-6DB70DBA9567}" type="datetimeFigureOut">
               <a:rPr lang="en-US" dirty="0"/>
               <a:pPr/>
-              <a:t>9/18/2025</a:t>
+              <a:t>9/25/2025</a:t>
             </a:fld>
             <a:endParaRPr lang="en-US" dirty="0"/>
           </a:p>
@@ -5271,7 +5372,7 @@
             <a:fld id="{B61BEF0D-F0BB-DE4B-95CE-6DB70DBA9567}" type="datetimeFigureOut">
               <a:rPr lang="en-US" dirty="0"/>
               <a:pPr/>
-              <a:t>9/18/2025</a:t>
+              <a:t>9/25/2025</a:t>
             </a:fld>
             <a:endParaRPr lang="en-US" dirty="0"/>
           </a:p>
@@ -5394,7 +5495,7 @@
             <a:fld id="{B61BEF0D-F0BB-DE4B-95CE-6DB70DBA9567}" type="datetimeFigureOut">
               <a:rPr lang="en-US" dirty="0"/>
               <a:pPr/>
-              <a:t>9/18/2025</a:t>
+              <a:t>9/25/2025</a:t>
             </a:fld>
             <a:endParaRPr lang="en-US" dirty="0"/>
           </a:p>
@@ -5646,7 +5747,7 @@
             <a:fld id="{B61BEF0D-F0BB-DE4B-95CE-6DB70DBA9567}" type="datetimeFigureOut">
               <a:rPr lang="en-US" dirty="0"/>
               <a:pPr/>
-              <a:t>9/18/2025</a:t>
+              <a:t>9/25/2025</a:t>
             </a:fld>
             <a:endParaRPr lang="en-US" dirty="0"/>
           </a:p>
@@ -5958,7 +6059,7 @@
             <a:fld id="{B61BEF0D-F0BB-DE4B-95CE-6DB70DBA9567}" type="datetimeFigureOut">
               <a:rPr lang="en-US" dirty="0"/>
               <a:pPr/>
-              <a:t>9/18/2025</a:t>
+              <a:t>9/25/2025</a:t>
             </a:fld>
             <a:endParaRPr lang="en-US" dirty="0"/>
           </a:p>
@@ -6306,7 +6407,7 @@
             <a:fld id="{B61BEF0D-F0BB-DE4B-95CE-6DB70DBA9567}" type="datetimeFigureOut">
               <a:rPr lang="en-US" dirty="0"/>
               <a:pPr/>
-              <a:t>9/18/2025</a:t>
+              <a:t>9/25/2025</a:t>
             </a:fld>
             <a:endParaRPr lang="en-US" dirty="0"/>
           </a:p>
@@ -6904,7 +7005,7 @@
 </file>
 
 <file path=ppt/slides/slide10.xml><?xml version="1.0" encoding="utf-8"?>
-<p:sld xmlns:a="http://schemas.openxmlformats.org/drawingml/2006/main" xmlns:r="http://schemas.openxmlformats.org/officeDocument/2006/relationships" xmlns:p="http://schemas.openxmlformats.org/presentationml/2006/main">
+<p:sld xmlns:a="http://schemas.openxmlformats.org/drawingml/2006/main" xmlns:r="http://schemas.openxmlformats.org/officeDocument/2006/relationships" xmlns:p="http://schemas.openxmlformats.org/presentationml/2006/main" show="0">
   <p:cSld>
     <p:spTree>
       <p:nvGrpSpPr>
@@ -6937,11 +7038,7 @@
           <a:p>
             <a:r>
               <a:rPr lang="en-US" b="1" dirty="0" smtClean="0"/>
-              <a:t>Agenda – Semester 3, Week </a:t>
-            </a:r>
-            <a:r>
-              <a:rPr lang="en-US" b="1" dirty="0" smtClean="0"/>
-              <a:t>3</a:t>
+              <a:t>Agenda – Semester 3, Week 3</a:t>
             </a:r>
             <a:endParaRPr lang="en-US" b="1" dirty="0"/>
           </a:p>
@@ -6966,30 +7063,17 @@
           <a:p>
             <a:r>
               <a:rPr lang="en-US" b="1" dirty="0" smtClean="0"/>
-              <a:t>Week </a:t>
-            </a:r>
+              <a:t>Week 3 </a:t>
+            </a:r>
+            <a:r>
+              <a:rPr lang="en-US" dirty="0" smtClean="0"/>
+              <a:t>Activities: GitHub status badge, Interview for coding practice “Sort a list”</a:t>
+            </a:r>
+          </a:p>
+          <a:p>
             <a:r>
               <a:rPr lang="en-US" b="1" dirty="0" smtClean="0"/>
-              <a:t>3 </a:t>
-            </a:r>
-            <a:r>
-              <a:rPr lang="en-US" dirty="0" smtClean="0"/>
-              <a:t>Activities: </a:t>
-            </a:r>
-            <a:r>
-              <a:rPr lang="en-US" dirty="0" smtClean="0"/>
-              <a:t>GitHub status badge, Interview for coding practice “Sort a list”</a:t>
-            </a:r>
-            <a:endParaRPr lang="en-US" dirty="0" smtClean="0"/>
-          </a:p>
-          <a:p>
-            <a:r>
-              <a:rPr lang="en-US" b="1" dirty="0" smtClean="0"/>
-              <a:t>Project </a:t>
-            </a:r>
-            <a:r>
-              <a:rPr lang="en-US" b="1" dirty="0" smtClean="0"/>
-              <a:t>Work: </a:t>
+              <a:t>Project Work: </a:t>
             </a:r>
             <a:r>
               <a:rPr lang="en-US" dirty="0" smtClean="0"/>
@@ -7006,34 +7090,23 @@
               <a:rPr lang="en-US" dirty="0" smtClean="0"/>
               <a:t>Behind. </a:t>
             </a:r>
-            <a:endParaRPr lang="en-US" dirty="0" smtClean="0"/>
           </a:p>
           <a:p>
             <a:pPr lvl="1"/>
             <a:r>
               <a:rPr lang="en-US" b="1" dirty="0" smtClean="0"/>
-              <a:t>Resolution </a:t>
-            </a:r>
-            <a:r>
-              <a:rPr lang="en-US" b="1" dirty="0" smtClean="0"/>
-              <a:t>Plan: </a:t>
+              <a:t>Resolution Plan: </a:t>
             </a:r>
             <a:r>
               <a:rPr lang="en-US" dirty="0" smtClean="0"/>
-              <a:t>Wra</a:t>
-            </a:r>
-            <a:r>
-              <a:rPr lang="en-US" dirty="0" smtClean="0"/>
-              <a:t>p up project, and pivot to planning next Semester’s job related learning goals.</a:t>
-            </a:r>
-            <a:endParaRPr lang="en-US" dirty="0" smtClean="0"/>
+              <a:t>Wrap up project, and pivot to planning next Semester’s job related learning goals.</a:t>
+            </a:r>
           </a:p>
           <a:p>
             <a:r>
               <a:rPr lang="en-US" b="1" dirty="0" smtClean="0"/>
               <a:t>Demo</a:t>
             </a:r>
-            <a:endParaRPr lang="en-US" b="1" dirty="0" smtClean="0"/>
           </a:p>
         </p:txBody>
       </p:sp>
@@ -7047,6 +7120,14 @@
   <p:clrMapOvr>
     <a:masterClrMapping/>
   </p:clrMapOvr>
+  <mc:AlternateContent xmlns:mc="http://schemas.openxmlformats.org/markup-compatibility/2006">
+    <mc:Choice xmlns:p14="http://schemas.microsoft.com/office/powerpoint/2010/main" Requires="p14">
+      <p:transition spd="slow" p14:dur="2000"/>
+    </mc:Choice>
+    <mc:Fallback>
+      <p:transition spd="slow"/>
+    </mc:Fallback>
+  </mc:AlternateContent>
   <p:timing>
     <p:tnLst>
       <p:par>
@@ -7058,7 +7139,7 @@
 </file>
 
 <file path=ppt/slides/slide11.xml><?xml version="1.0" encoding="utf-8"?>
-<p:sld xmlns:a="http://schemas.openxmlformats.org/drawingml/2006/main" xmlns:r="http://schemas.openxmlformats.org/officeDocument/2006/relationships" xmlns:p="http://schemas.openxmlformats.org/presentationml/2006/main">
+<p:sld xmlns:a="http://schemas.openxmlformats.org/drawingml/2006/main" xmlns:r="http://schemas.openxmlformats.org/officeDocument/2006/relationships" xmlns:p="http://schemas.openxmlformats.org/presentationml/2006/main" show="0">
   <p:cSld>
     <p:spTree>
       <p:nvGrpSpPr>
@@ -7258,7 +7339,7 @@
 </file>
 
 <file path=ppt/slides/slide12.xml><?xml version="1.0" encoding="utf-8"?>
-<p:sld xmlns:a="http://schemas.openxmlformats.org/drawingml/2006/main" xmlns:r="http://schemas.openxmlformats.org/officeDocument/2006/relationships" xmlns:p="http://schemas.openxmlformats.org/presentationml/2006/main">
+<p:sld xmlns:a="http://schemas.openxmlformats.org/drawingml/2006/main" xmlns:r="http://schemas.openxmlformats.org/officeDocument/2006/relationships" xmlns:p="http://schemas.openxmlformats.org/presentationml/2006/main" show="0">
   <p:cSld>
     <p:spTree>
       <p:nvGrpSpPr>
@@ -7433,6 +7514,1231 @@
 </p:sld>
 </file>
 
+<file path=ppt/slides/slide13.xml><?xml version="1.0" encoding="utf-8"?>
+<p:sld xmlns:a="http://schemas.openxmlformats.org/drawingml/2006/main" xmlns:r="http://schemas.openxmlformats.org/officeDocument/2006/relationships" xmlns:p="http://schemas.openxmlformats.org/presentationml/2006/main">
+  <p:cSld>
+    <p:spTree>
+      <p:nvGrpSpPr>
+        <p:cNvPr id="1" name=""/>
+        <p:cNvGrpSpPr/>
+        <p:nvPr/>
+      </p:nvGrpSpPr>
+      <p:grpSpPr>
+        <a:xfrm>
+          <a:off x="0" y="0"/>
+          <a:ext cx="0" cy="0"/>
+          <a:chOff x="0" y="0"/>
+          <a:chExt cx="0" cy="0"/>
+        </a:xfrm>
+      </p:grpSpPr>
+      <p:sp>
+        <p:nvSpPr>
+          <p:cNvPr id="2" name="Title 1"/>
+          <p:cNvSpPr>
+            <a:spLocks noGrp="1"/>
+          </p:cNvSpPr>
+          <p:nvPr>
+            <p:ph type="ctrTitle"/>
+          </p:nvPr>
+        </p:nvSpPr>
+        <p:spPr>
+          <a:xfrm>
+            <a:off x="2679335" y="2498149"/>
+            <a:ext cx="6815669" cy="1515533"/>
+          </a:xfrm>
+        </p:spPr>
+        <p:txBody>
+          <a:bodyPr/>
+          <a:lstStyle/>
+          <a:p>
+            <a:r>
+              <a:rPr lang="en-US" dirty="0" smtClean="0"/>
+              <a:t>Lisa’s Semester 3</a:t>
+            </a:r>
+            <a:br>
+              <a:rPr lang="en-US" dirty="0" smtClean="0"/>
+            </a:br>
+            <a:r>
+              <a:rPr lang="en-US" dirty="0" smtClean="0"/>
+              <a:t>Presentation</a:t>
+            </a:r>
+            <a:r>
+              <a:rPr lang="en-US" dirty="0" smtClean="0"/>
+              <a:t/>
+            </a:r>
+            <a:br>
+              <a:rPr lang="en-US" dirty="0" smtClean="0"/>
+            </a:br>
+            <a:r>
+              <a:rPr lang="en-US" sz="2400" dirty="0" smtClean="0"/>
+              <a:t>Backend Web Developer</a:t>
+            </a:r>
+            <a:endParaRPr lang="en-US" dirty="0"/>
+          </a:p>
+        </p:txBody>
+      </p:sp>
+    </p:spTree>
+    <p:extLst>
+      <p:ext uri="{BB962C8B-B14F-4D97-AF65-F5344CB8AC3E}">
+        <p14:creationId xmlns:p14="http://schemas.microsoft.com/office/powerpoint/2010/main" val="198743477"/>
+      </p:ext>
+    </p:extLst>
+  </p:cSld>
+  <p:clrMapOvr>
+    <a:masterClrMapping/>
+  </p:clrMapOvr>
+  <p:timing>
+    <p:tnLst>
+      <p:par>
+        <p:cTn id="1" dur="indefinite" restart="never" nodeType="tmRoot"/>
+      </p:par>
+    </p:tnLst>
+  </p:timing>
+</p:sld>
+</file>
+
+<file path=ppt/slides/slide14.xml><?xml version="1.0" encoding="utf-8"?>
+<p:sld xmlns:a="http://schemas.openxmlformats.org/drawingml/2006/main" xmlns:r="http://schemas.openxmlformats.org/officeDocument/2006/relationships" xmlns:p="http://schemas.openxmlformats.org/presentationml/2006/main">
+  <p:cSld>
+    <p:spTree>
+      <p:nvGrpSpPr>
+        <p:cNvPr id="1" name=""/>
+        <p:cNvGrpSpPr/>
+        <p:nvPr/>
+      </p:nvGrpSpPr>
+      <p:grpSpPr>
+        <a:xfrm>
+          <a:off x="0" y="0"/>
+          <a:ext cx="0" cy="0"/>
+          <a:chOff x="0" y="0"/>
+          <a:chExt cx="0" cy="0"/>
+        </a:xfrm>
+      </p:grpSpPr>
+      <p:sp>
+        <p:nvSpPr>
+          <p:cNvPr id="2" name="Title 1"/>
+          <p:cNvSpPr>
+            <a:spLocks noGrp="1"/>
+          </p:cNvSpPr>
+          <p:nvPr>
+            <p:ph type="title"/>
+          </p:nvPr>
+        </p:nvSpPr>
+        <p:spPr/>
+        <p:txBody>
+          <a:bodyPr/>
+          <a:lstStyle/>
+          <a:p>
+            <a:r>
+              <a:rPr lang="en-US" b="1" dirty="0" smtClean="0"/>
+              <a:t>Agenda – Semester 3, </a:t>
+            </a:r>
+            <a:r>
+              <a:rPr lang="en-US" b="1" dirty="0" smtClean="0"/>
+              <a:t>Presentation</a:t>
+            </a:r>
+            <a:endParaRPr lang="en-US" b="1" dirty="0"/>
+          </a:p>
+        </p:txBody>
+      </p:sp>
+      <p:sp>
+        <p:nvSpPr>
+          <p:cNvPr id="3" name="Content Placeholder 2"/>
+          <p:cNvSpPr>
+            <a:spLocks noGrp="1"/>
+          </p:cNvSpPr>
+          <p:nvPr>
+            <p:ph idx="1"/>
+          </p:nvPr>
+        </p:nvSpPr>
+        <p:spPr/>
+        <p:txBody>
+          <a:bodyPr>
+            <a:normAutofit/>
+          </a:bodyPr>
+          <a:lstStyle/>
+          <a:p>
+            <a:r>
+              <a:rPr lang="en-US" b="1" dirty="0" smtClean="0"/>
+              <a:t>Week 4 </a:t>
+            </a:r>
+            <a:r>
+              <a:rPr lang="en-US" dirty="0" smtClean="0"/>
+              <a:t>Activities: README.md file, Implement a Stack</a:t>
+            </a:r>
+            <a:endParaRPr lang="en-US" dirty="0" smtClean="0"/>
+          </a:p>
+          <a:p>
+            <a:r>
+              <a:rPr lang="en-US" b="1" dirty="0"/>
+              <a:t>Schoology</a:t>
+            </a:r>
+            <a:r>
+              <a:rPr lang="en-US" dirty="0"/>
+              <a:t> SQL 1 &amp; 2</a:t>
+            </a:r>
+          </a:p>
+          <a:p>
+            <a:r>
+              <a:rPr lang="en-US" b="1" dirty="0" smtClean="0"/>
+              <a:t>Project </a:t>
+            </a:r>
+            <a:r>
+              <a:rPr lang="en-US" b="1" dirty="0" smtClean="0"/>
+              <a:t>Work: </a:t>
+            </a:r>
+            <a:r>
+              <a:rPr lang="en-US" dirty="0" smtClean="0"/>
+              <a:t>“Project Pulse</a:t>
+            </a:r>
+            <a:r>
+              <a:rPr lang="en-US" dirty="0" smtClean="0"/>
+              <a:t>”</a:t>
+            </a:r>
+          </a:p>
+          <a:p>
+            <a:r>
+              <a:rPr lang="en-US" b="1" dirty="0" smtClean="0"/>
+              <a:t>Status</a:t>
+            </a:r>
+            <a:r>
+              <a:rPr lang="en-US" b="1" dirty="0" smtClean="0"/>
+              <a:t>? </a:t>
+            </a:r>
+            <a:r>
+              <a:rPr lang="en-US" dirty="0" smtClean="0"/>
+              <a:t>Complete</a:t>
+            </a:r>
+          </a:p>
+          <a:p>
+            <a:r>
+              <a:rPr lang="en-US" b="1" dirty="0" smtClean="0"/>
+              <a:t>Demo</a:t>
+            </a:r>
+            <a:endParaRPr lang="en-US" b="1" dirty="0" smtClean="0"/>
+          </a:p>
+        </p:txBody>
+      </p:sp>
+    </p:spTree>
+    <p:extLst>
+      <p:ext uri="{BB962C8B-B14F-4D97-AF65-F5344CB8AC3E}">
+        <p14:creationId xmlns:p14="http://schemas.microsoft.com/office/powerpoint/2010/main" val="2768731661"/>
+      </p:ext>
+    </p:extLst>
+  </p:cSld>
+  <p:clrMapOvr>
+    <a:masterClrMapping/>
+  </p:clrMapOvr>
+  <p:timing>
+    <p:tnLst>
+      <p:par>
+        <p:cTn id="1" dur="indefinite" restart="never" nodeType="tmRoot"/>
+      </p:par>
+    </p:tnLst>
+  </p:timing>
+</p:sld>
+</file>
+
+<file path=ppt/slides/slide15.xml><?xml version="1.0" encoding="utf-8"?>
+<p:sld xmlns:a="http://schemas.openxmlformats.org/drawingml/2006/main" xmlns:r="http://schemas.openxmlformats.org/officeDocument/2006/relationships" xmlns:p="http://schemas.openxmlformats.org/presentationml/2006/main">
+  <p:cSld>
+    <p:spTree>
+      <p:nvGrpSpPr>
+        <p:cNvPr id="1" name=""/>
+        <p:cNvGrpSpPr/>
+        <p:nvPr/>
+      </p:nvGrpSpPr>
+      <p:grpSpPr>
+        <a:xfrm>
+          <a:off x="0" y="0"/>
+          <a:ext cx="0" cy="0"/>
+          <a:chOff x="0" y="0"/>
+          <a:chExt cx="0" cy="0"/>
+        </a:xfrm>
+      </p:grpSpPr>
+      <p:sp>
+        <p:nvSpPr>
+          <p:cNvPr id="4" name="Title 1"/>
+          <p:cNvSpPr txBox="1">
+            <a:spLocks/>
+          </p:cNvSpPr>
+          <p:nvPr/>
+        </p:nvSpPr>
+        <p:spPr>
+          <a:xfrm>
+            <a:off x="4170558" y="1049978"/>
+            <a:ext cx="3485605" cy="1663872"/>
+          </a:xfrm>
+          <a:prstGeom prst="rect">
+            <a:avLst/>
+          </a:prstGeom>
+        </p:spPr>
+        <p:txBody>
+          <a:bodyPr/>
+          <a:lstStyle>
+            <a:lvl1pPr algn="ctr" defTabSz="457200" rtl="0" eaLnBrk="1" latinLnBrk="0" hangingPunct="1">
+              <a:spcBef>
+                <a:spcPct val="0"/>
+              </a:spcBef>
+              <a:buNone/>
+              <a:defRPr sz="4400" kern="1200" cap="none">
+                <a:ln w="3175" cmpd="sng">
+                  <a:noFill/>
+                </a:ln>
+                <a:solidFill>
+                  <a:schemeClr val="tx1">
+                    <a:lumMod val="85000"/>
+                    <a:lumOff val="15000"/>
+                  </a:schemeClr>
+                </a:solidFill>
+                <a:effectLst/>
+                <a:latin typeface="+mj-lt"/>
+                <a:ea typeface="+mj-ea"/>
+                <a:cs typeface="+mj-cs"/>
+              </a:defRPr>
+            </a:lvl1pPr>
+            <a:lvl2pPr eaLnBrk="1" hangingPunct="1">
+              <a:defRPr>
+                <a:solidFill>
+                  <a:schemeClr val="tx2"/>
+                </a:solidFill>
+              </a:defRPr>
+            </a:lvl2pPr>
+            <a:lvl3pPr eaLnBrk="1" hangingPunct="1">
+              <a:defRPr>
+                <a:solidFill>
+                  <a:schemeClr val="tx2"/>
+                </a:solidFill>
+              </a:defRPr>
+            </a:lvl3pPr>
+            <a:lvl4pPr eaLnBrk="1" hangingPunct="1">
+              <a:defRPr>
+                <a:solidFill>
+                  <a:schemeClr val="tx2"/>
+                </a:solidFill>
+              </a:defRPr>
+            </a:lvl4pPr>
+            <a:lvl5pPr eaLnBrk="1" hangingPunct="1">
+              <a:defRPr>
+                <a:solidFill>
+                  <a:schemeClr val="tx2"/>
+                </a:solidFill>
+              </a:defRPr>
+            </a:lvl5pPr>
+            <a:lvl6pPr eaLnBrk="1" hangingPunct="1">
+              <a:defRPr>
+                <a:solidFill>
+                  <a:schemeClr val="tx2"/>
+                </a:solidFill>
+              </a:defRPr>
+            </a:lvl6pPr>
+            <a:lvl7pPr eaLnBrk="1" hangingPunct="1">
+              <a:defRPr>
+                <a:solidFill>
+                  <a:schemeClr val="tx2"/>
+                </a:solidFill>
+              </a:defRPr>
+            </a:lvl7pPr>
+            <a:lvl8pPr eaLnBrk="1" hangingPunct="1">
+              <a:defRPr>
+                <a:solidFill>
+                  <a:schemeClr val="tx2"/>
+                </a:solidFill>
+              </a:defRPr>
+            </a:lvl8pPr>
+            <a:lvl9pPr eaLnBrk="1" hangingPunct="1">
+              <a:defRPr>
+                <a:solidFill>
+                  <a:schemeClr val="tx2"/>
+                </a:solidFill>
+              </a:defRPr>
+            </a:lvl9pPr>
+          </a:lstStyle>
+          <a:p>
+            <a:r>
+              <a:rPr lang="en-US" sz="3200" b="1" dirty="0" smtClean="0"/>
+              <a:t>README.md</a:t>
+            </a:r>
+            <a:endParaRPr lang="en-US" sz="3200" b="1" dirty="0"/>
+          </a:p>
+        </p:txBody>
+      </p:sp>
+      <p:pic>
+        <p:nvPicPr>
+          <p:cNvPr id="2" name="Picture 1"/>
+          <p:cNvPicPr>
+            <a:picLocks noChangeAspect="1"/>
+          </p:cNvPicPr>
+          <p:nvPr/>
+        </p:nvPicPr>
+        <p:blipFill>
+          <a:blip r:embed="rId2"/>
+          <a:stretch>
+            <a:fillRect/>
+          </a:stretch>
+        </p:blipFill>
+        <p:spPr>
+          <a:xfrm>
+            <a:off x="1534978" y="2021400"/>
+            <a:ext cx="7098021" cy="2745461"/>
+          </a:xfrm>
+          <a:prstGeom prst="rect">
+            <a:avLst/>
+          </a:prstGeom>
+        </p:spPr>
+      </p:pic>
+    </p:spTree>
+    <p:extLst>
+      <p:ext uri="{BB962C8B-B14F-4D97-AF65-F5344CB8AC3E}">
+        <p14:creationId xmlns:p14="http://schemas.microsoft.com/office/powerpoint/2010/main" val="3338340074"/>
+      </p:ext>
+    </p:extLst>
+  </p:cSld>
+  <p:clrMapOvr>
+    <a:masterClrMapping/>
+  </p:clrMapOvr>
+  <mc:AlternateContent xmlns:mc="http://schemas.openxmlformats.org/markup-compatibility/2006" xmlns:p14="http://schemas.microsoft.com/office/powerpoint/2010/main">
+    <mc:Choice Requires="p14">
+      <p:transition spd="slow" p14:dur="2000"/>
+    </mc:Choice>
+    <mc:Fallback xmlns="">
+      <p:transition spd="slow"/>
+    </mc:Fallback>
+  </mc:AlternateContent>
+  <p:timing>
+    <p:tnLst>
+      <p:par>
+        <p:cTn id="1" dur="indefinite" restart="never" nodeType="tmRoot"/>
+      </p:par>
+    </p:tnLst>
+  </p:timing>
+</p:sld>
+</file>
+
+<file path=ppt/slides/slide16.xml><?xml version="1.0" encoding="utf-8"?>
+<p:sld xmlns:a="http://schemas.openxmlformats.org/drawingml/2006/main" xmlns:r="http://schemas.openxmlformats.org/officeDocument/2006/relationships" xmlns:p="http://schemas.openxmlformats.org/presentationml/2006/main">
+  <p:cSld>
+    <p:spTree>
+      <p:nvGrpSpPr>
+        <p:cNvPr id="1" name=""/>
+        <p:cNvGrpSpPr/>
+        <p:nvPr/>
+      </p:nvGrpSpPr>
+      <p:grpSpPr>
+        <a:xfrm>
+          <a:off x="0" y="0"/>
+          <a:ext cx="0" cy="0"/>
+          <a:chOff x="0" y="0"/>
+          <a:chExt cx="0" cy="0"/>
+        </a:xfrm>
+      </p:grpSpPr>
+      <p:sp>
+        <p:nvSpPr>
+          <p:cNvPr id="4" name="Title 1"/>
+          <p:cNvSpPr txBox="1">
+            <a:spLocks/>
+          </p:cNvSpPr>
+          <p:nvPr/>
+        </p:nvSpPr>
+        <p:spPr>
+          <a:xfrm>
+            <a:off x="1086396" y="2040223"/>
+            <a:ext cx="2075258" cy="1663872"/>
+          </a:xfrm>
+          <a:prstGeom prst="rect">
+            <a:avLst/>
+          </a:prstGeom>
+        </p:spPr>
+        <p:txBody>
+          <a:bodyPr/>
+          <a:lstStyle>
+            <a:lvl1pPr algn="ctr" defTabSz="457200" rtl="0" eaLnBrk="1" latinLnBrk="0" hangingPunct="1">
+              <a:spcBef>
+                <a:spcPct val="0"/>
+              </a:spcBef>
+              <a:buNone/>
+              <a:defRPr sz="4400" kern="1200" cap="none">
+                <a:ln w="3175" cmpd="sng">
+                  <a:noFill/>
+                </a:ln>
+                <a:solidFill>
+                  <a:schemeClr val="tx1">
+                    <a:lumMod val="85000"/>
+                    <a:lumOff val="15000"/>
+                  </a:schemeClr>
+                </a:solidFill>
+                <a:effectLst/>
+                <a:latin typeface="+mj-lt"/>
+                <a:ea typeface="+mj-ea"/>
+                <a:cs typeface="+mj-cs"/>
+              </a:defRPr>
+            </a:lvl1pPr>
+            <a:lvl2pPr eaLnBrk="1" hangingPunct="1">
+              <a:defRPr>
+                <a:solidFill>
+                  <a:schemeClr val="tx2"/>
+                </a:solidFill>
+              </a:defRPr>
+            </a:lvl2pPr>
+            <a:lvl3pPr eaLnBrk="1" hangingPunct="1">
+              <a:defRPr>
+                <a:solidFill>
+                  <a:schemeClr val="tx2"/>
+                </a:solidFill>
+              </a:defRPr>
+            </a:lvl3pPr>
+            <a:lvl4pPr eaLnBrk="1" hangingPunct="1">
+              <a:defRPr>
+                <a:solidFill>
+                  <a:schemeClr val="tx2"/>
+                </a:solidFill>
+              </a:defRPr>
+            </a:lvl4pPr>
+            <a:lvl5pPr eaLnBrk="1" hangingPunct="1">
+              <a:defRPr>
+                <a:solidFill>
+                  <a:schemeClr val="tx2"/>
+                </a:solidFill>
+              </a:defRPr>
+            </a:lvl5pPr>
+            <a:lvl6pPr eaLnBrk="1" hangingPunct="1">
+              <a:defRPr>
+                <a:solidFill>
+                  <a:schemeClr val="tx2"/>
+                </a:solidFill>
+              </a:defRPr>
+            </a:lvl6pPr>
+            <a:lvl7pPr eaLnBrk="1" hangingPunct="1">
+              <a:defRPr>
+                <a:solidFill>
+                  <a:schemeClr val="tx2"/>
+                </a:solidFill>
+              </a:defRPr>
+            </a:lvl7pPr>
+            <a:lvl8pPr eaLnBrk="1" hangingPunct="1">
+              <a:defRPr>
+                <a:solidFill>
+                  <a:schemeClr val="tx2"/>
+                </a:solidFill>
+              </a:defRPr>
+            </a:lvl8pPr>
+            <a:lvl9pPr eaLnBrk="1" hangingPunct="1">
+              <a:defRPr>
+                <a:solidFill>
+                  <a:schemeClr val="tx2"/>
+                </a:solidFill>
+              </a:defRPr>
+            </a:lvl9pPr>
+          </a:lstStyle>
+          <a:p>
+            <a:r>
+              <a:rPr lang="en-US" sz="3200" b="1" dirty="0" smtClean="0"/>
+              <a:t>README.md</a:t>
+            </a:r>
+            <a:endParaRPr lang="en-US" sz="3200" b="1" dirty="0"/>
+          </a:p>
+        </p:txBody>
+      </p:sp>
+      <p:pic>
+        <p:nvPicPr>
+          <p:cNvPr id="5" name="Picture 4"/>
+          <p:cNvPicPr>
+            <a:picLocks noChangeAspect="1"/>
+          </p:cNvPicPr>
+          <p:nvPr/>
+        </p:nvPicPr>
+        <p:blipFill>
+          <a:blip r:embed="rId2"/>
+          <a:stretch>
+            <a:fillRect/>
+          </a:stretch>
+        </p:blipFill>
+        <p:spPr>
+          <a:xfrm>
+            <a:off x="3415842" y="867905"/>
+            <a:ext cx="7938451" cy="5176514"/>
+          </a:xfrm>
+          <a:prstGeom prst="rect">
+            <a:avLst/>
+          </a:prstGeom>
+        </p:spPr>
+      </p:pic>
+    </p:spTree>
+    <p:extLst>
+      <p:ext uri="{BB962C8B-B14F-4D97-AF65-F5344CB8AC3E}">
+        <p14:creationId xmlns:p14="http://schemas.microsoft.com/office/powerpoint/2010/main" val="3491045782"/>
+      </p:ext>
+    </p:extLst>
+  </p:cSld>
+  <p:clrMapOvr>
+    <a:masterClrMapping/>
+  </p:clrMapOvr>
+  <mc:AlternateContent xmlns:mc="http://schemas.openxmlformats.org/markup-compatibility/2006" xmlns:p14="http://schemas.microsoft.com/office/powerpoint/2010/main">
+    <mc:Choice Requires="p14">
+      <p:transition spd="slow" p14:dur="2000"/>
+    </mc:Choice>
+    <mc:Fallback xmlns="">
+      <p:transition spd="slow"/>
+    </mc:Fallback>
+  </mc:AlternateContent>
+  <p:timing>
+    <p:tnLst>
+      <p:par>
+        <p:cTn id="1" dur="indefinite" restart="never" nodeType="tmRoot"/>
+      </p:par>
+    </p:tnLst>
+  </p:timing>
+</p:sld>
+</file>
+
+<file path=ppt/slides/slide17.xml><?xml version="1.0" encoding="utf-8"?>
+<p:sld xmlns:a="http://schemas.openxmlformats.org/drawingml/2006/main" xmlns:r="http://schemas.openxmlformats.org/officeDocument/2006/relationships" xmlns:p="http://schemas.openxmlformats.org/presentationml/2006/main">
+  <p:cSld>
+    <p:spTree>
+      <p:nvGrpSpPr>
+        <p:cNvPr id="1" name=""/>
+        <p:cNvGrpSpPr/>
+        <p:nvPr/>
+      </p:nvGrpSpPr>
+      <p:grpSpPr>
+        <a:xfrm>
+          <a:off x="0" y="0"/>
+          <a:ext cx="0" cy="0"/>
+          <a:chOff x="0" y="0"/>
+          <a:chExt cx="0" cy="0"/>
+        </a:xfrm>
+      </p:grpSpPr>
+      <p:sp>
+        <p:nvSpPr>
+          <p:cNvPr id="4" name="Title 1"/>
+          <p:cNvSpPr txBox="1">
+            <a:spLocks/>
+          </p:cNvSpPr>
+          <p:nvPr/>
+        </p:nvSpPr>
+        <p:spPr>
+          <a:xfrm>
+            <a:off x="1086396" y="2040223"/>
+            <a:ext cx="2075258" cy="1663872"/>
+          </a:xfrm>
+          <a:prstGeom prst="rect">
+            <a:avLst/>
+          </a:prstGeom>
+        </p:spPr>
+        <p:txBody>
+          <a:bodyPr/>
+          <a:lstStyle>
+            <a:lvl1pPr algn="ctr" defTabSz="457200" rtl="0" eaLnBrk="1" latinLnBrk="0" hangingPunct="1">
+              <a:spcBef>
+                <a:spcPct val="0"/>
+              </a:spcBef>
+              <a:buNone/>
+              <a:defRPr sz="4400" kern="1200" cap="none">
+                <a:ln w="3175" cmpd="sng">
+                  <a:noFill/>
+                </a:ln>
+                <a:solidFill>
+                  <a:schemeClr val="tx1">
+                    <a:lumMod val="85000"/>
+                    <a:lumOff val="15000"/>
+                  </a:schemeClr>
+                </a:solidFill>
+                <a:effectLst/>
+                <a:latin typeface="+mj-lt"/>
+                <a:ea typeface="+mj-ea"/>
+                <a:cs typeface="+mj-cs"/>
+              </a:defRPr>
+            </a:lvl1pPr>
+            <a:lvl2pPr eaLnBrk="1" hangingPunct="1">
+              <a:defRPr>
+                <a:solidFill>
+                  <a:schemeClr val="tx2"/>
+                </a:solidFill>
+              </a:defRPr>
+            </a:lvl2pPr>
+            <a:lvl3pPr eaLnBrk="1" hangingPunct="1">
+              <a:defRPr>
+                <a:solidFill>
+                  <a:schemeClr val="tx2"/>
+                </a:solidFill>
+              </a:defRPr>
+            </a:lvl3pPr>
+            <a:lvl4pPr eaLnBrk="1" hangingPunct="1">
+              <a:defRPr>
+                <a:solidFill>
+                  <a:schemeClr val="tx2"/>
+                </a:solidFill>
+              </a:defRPr>
+            </a:lvl4pPr>
+            <a:lvl5pPr eaLnBrk="1" hangingPunct="1">
+              <a:defRPr>
+                <a:solidFill>
+                  <a:schemeClr val="tx2"/>
+                </a:solidFill>
+              </a:defRPr>
+            </a:lvl5pPr>
+            <a:lvl6pPr eaLnBrk="1" hangingPunct="1">
+              <a:defRPr>
+                <a:solidFill>
+                  <a:schemeClr val="tx2"/>
+                </a:solidFill>
+              </a:defRPr>
+            </a:lvl6pPr>
+            <a:lvl7pPr eaLnBrk="1" hangingPunct="1">
+              <a:defRPr>
+                <a:solidFill>
+                  <a:schemeClr val="tx2"/>
+                </a:solidFill>
+              </a:defRPr>
+            </a:lvl7pPr>
+            <a:lvl8pPr eaLnBrk="1" hangingPunct="1">
+              <a:defRPr>
+                <a:solidFill>
+                  <a:schemeClr val="tx2"/>
+                </a:solidFill>
+              </a:defRPr>
+            </a:lvl8pPr>
+            <a:lvl9pPr eaLnBrk="1" hangingPunct="1">
+              <a:defRPr>
+                <a:solidFill>
+                  <a:schemeClr val="tx2"/>
+                </a:solidFill>
+              </a:defRPr>
+            </a:lvl9pPr>
+          </a:lstStyle>
+          <a:p>
+            <a:r>
+              <a:rPr lang="en-US" sz="3200" b="1" dirty="0" smtClean="0"/>
+              <a:t>README.md</a:t>
+            </a:r>
+            <a:endParaRPr lang="en-US" sz="3200" b="1" dirty="0"/>
+          </a:p>
+        </p:txBody>
+      </p:sp>
+      <p:pic>
+        <p:nvPicPr>
+          <p:cNvPr id="3" name="Picture 2"/>
+          <p:cNvPicPr>
+            <a:picLocks noChangeAspect="1"/>
+          </p:cNvPicPr>
+          <p:nvPr/>
+        </p:nvPicPr>
+        <p:blipFill>
+          <a:blip r:embed="rId2"/>
+          <a:stretch>
+            <a:fillRect/>
+          </a:stretch>
+        </p:blipFill>
+        <p:spPr>
+          <a:xfrm>
+            <a:off x="3641779" y="712921"/>
+            <a:ext cx="4913285" cy="5394459"/>
+          </a:xfrm>
+          <a:prstGeom prst="rect">
+            <a:avLst/>
+          </a:prstGeom>
+        </p:spPr>
+      </p:pic>
+    </p:spTree>
+    <p:extLst>
+      <p:ext uri="{BB962C8B-B14F-4D97-AF65-F5344CB8AC3E}">
+        <p14:creationId xmlns:p14="http://schemas.microsoft.com/office/powerpoint/2010/main" val="2281696463"/>
+      </p:ext>
+    </p:extLst>
+  </p:cSld>
+  <p:clrMapOvr>
+    <a:masterClrMapping/>
+  </p:clrMapOvr>
+  <mc:AlternateContent xmlns:mc="http://schemas.openxmlformats.org/markup-compatibility/2006" xmlns:p14="http://schemas.microsoft.com/office/powerpoint/2010/main">
+    <mc:Choice Requires="p14">
+      <p:transition spd="slow" p14:dur="2000"/>
+    </mc:Choice>
+    <mc:Fallback xmlns="">
+      <p:transition spd="slow"/>
+    </mc:Fallback>
+  </mc:AlternateContent>
+  <p:timing>
+    <p:tnLst>
+      <p:par>
+        <p:cTn id="1" dur="indefinite" restart="never" nodeType="tmRoot"/>
+      </p:par>
+    </p:tnLst>
+  </p:timing>
+</p:sld>
+</file>
+
+<file path=ppt/slides/slide18.xml><?xml version="1.0" encoding="utf-8"?>
+<p:sld xmlns:a="http://schemas.openxmlformats.org/drawingml/2006/main" xmlns:r="http://schemas.openxmlformats.org/officeDocument/2006/relationships" xmlns:p="http://schemas.openxmlformats.org/presentationml/2006/main">
+  <p:cSld>
+    <p:spTree>
+      <p:nvGrpSpPr>
+        <p:cNvPr id="1" name=""/>
+        <p:cNvGrpSpPr/>
+        <p:nvPr/>
+      </p:nvGrpSpPr>
+      <p:grpSpPr>
+        <a:xfrm>
+          <a:off x="0" y="0"/>
+          <a:ext cx="0" cy="0"/>
+          <a:chOff x="0" y="0"/>
+          <a:chExt cx="0" cy="0"/>
+        </a:xfrm>
+      </p:grpSpPr>
+      <p:sp>
+        <p:nvSpPr>
+          <p:cNvPr id="4" name="Title 1"/>
+          <p:cNvSpPr txBox="1">
+            <a:spLocks/>
+          </p:cNvSpPr>
+          <p:nvPr/>
+        </p:nvSpPr>
+        <p:spPr>
+          <a:xfrm>
+            <a:off x="543955" y="691871"/>
+            <a:ext cx="2788180" cy="2134212"/>
+          </a:xfrm>
+          <a:prstGeom prst="rect">
+            <a:avLst/>
+          </a:prstGeom>
+        </p:spPr>
+        <p:txBody>
+          <a:bodyPr/>
+          <a:lstStyle>
+            <a:lvl1pPr algn="ctr" defTabSz="457200" rtl="0" eaLnBrk="1" latinLnBrk="0" hangingPunct="1">
+              <a:spcBef>
+                <a:spcPct val="0"/>
+              </a:spcBef>
+              <a:buNone/>
+              <a:defRPr sz="4400" kern="1200" cap="none">
+                <a:ln w="3175" cmpd="sng">
+                  <a:noFill/>
+                </a:ln>
+                <a:solidFill>
+                  <a:schemeClr val="tx1">
+                    <a:lumMod val="85000"/>
+                    <a:lumOff val="15000"/>
+                  </a:schemeClr>
+                </a:solidFill>
+                <a:effectLst/>
+                <a:latin typeface="+mj-lt"/>
+                <a:ea typeface="+mj-ea"/>
+                <a:cs typeface="+mj-cs"/>
+              </a:defRPr>
+            </a:lvl1pPr>
+            <a:lvl2pPr eaLnBrk="1" hangingPunct="1">
+              <a:defRPr>
+                <a:solidFill>
+                  <a:schemeClr val="tx2"/>
+                </a:solidFill>
+              </a:defRPr>
+            </a:lvl2pPr>
+            <a:lvl3pPr eaLnBrk="1" hangingPunct="1">
+              <a:defRPr>
+                <a:solidFill>
+                  <a:schemeClr val="tx2"/>
+                </a:solidFill>
+              </a:defRPr>
+            </a:lvl3pPr>
+            <a:lvl4pPr eaLnBrk="1" hangingPunct="1">
+              <a:defRPr>
+                <a:solidFill>
+                  <a:schemeClr val="tx2"/>
+                </a:solidFill>
+              </a:defRPr>
+            </a:lvl4pPr>
+            <a:lvl5pPr eaLnBrk="1" hangingPunct="1">
+              <a:defRPr>
+                <a:solidFill>
+                  <a:schemeClr val="tx2"/>
+                </a:solidFill>
+              </a:defRPr>
+            </a:lvl5pPr>
+            <a:lvl6pPr eaLnBrk="1" hangingPunct="1">
+              <a:defRPr>
+                <a:solidFill>
+                  <a:schemeClr val="tx2"/>
+                </a:solidFill>
+              </a:defRPr>
+            </a:lvl6pPr>
+            <a:lvl7pPr eaLnBrk="1" hangingPunct="1">
+              <a:defRPr>
+                <a:solidFill>
+                  <a:schemeClr val="tx2"/>
+                </a:solidFill>
+              </a:defRPr>
+            </a:lvl7pPr>
+            <a:lvl8pPr eaLnBrk="1" hangingPunct="1">
+              <a:defRPr>
+                <a:solidFill>
+                  <a:schemeClr val="tx2"/>
+                </a:solidFill>
+              </a:defRPr>
+            </a:lvl8pPr>
+            <a:lvl9pPr eaLnBrk="1" hangingPunct="1">
+              <a:defRPr>
+                <a:solidFill>
+                  <a:schemeClr val="tx2"/>
+                </a:solidFill>
+              </a:defRPr>
+            </a:lvl9pPr>
+          </a:lstStyle>
+          <a:p>
+            <a:r>
+              <a:rPr lang="en-US" b="1" dirty="0" smtClean="0"/>
+              <a:t>STACK</a:t>
+            </a:r>
+            <a:endParaRPr lang="en-US" b="1" dirty="0"/>
+          </a:p>
+        </p:txBody>
+      </p:sp>
+      <p:pic>
+        <p:nvPicPr>
+          <p:cNvPr id="2" name="Picture 1"/>
+          <p:cNvPicPr>
+            <a:picLocks noChangeAspect="1"/>
+          </p:cNvPicPr>
+          <p:nvPr/>
+        </p:nvPicPr>
+        <p:blipFill>
+          <a:blip r:embed="rId2"/>
+          <a:stretch>
+            <a:fillRect/>
+          </a:stretch>
+        </p:blipFill>
+        <p:spPr>
+          <a:xfrm>
+            <a:off x="869073" y="1518511"/>
+            <a:ext cx="8972916" cy="1503658"/>
+          </a:xfrm>
+          <a:prstGeom prst="rect">
+            <a:avLst/>
+          </a:prstGeom>
+        </p:spPr>
+      </p:pic>
+      <p:pic>
+        <p:nvPicPr>
+          <p:cNvPr id="3" name="Picture 2"/>
+          <p:cNvPicPr>
+            <a:picLocks noChangeAspect="1"/>
+          </p:cNvPicPr>
+          <p:nvPr/>
+        </p:nvPicPr>
+        <p:blipFill>
+          <a:blip r:embed="rId3"/>
+          <a:stretch>
+            <a:fillRect/>
+          </a:stretch>
+        </p:blipFill>
+        <p:spPr>
+          <a:xfrm>
+            <a:off x="1008762" y="3020191"/>
+            <a:ext cx="2552534" cy="373938"/>
+          </a:xfrm>
+          <a:prstGeom prst="rect">
+            <a:avLst/>
+          </a:prstGeom>
+        </p:spPr>
+      </p:pic>
+      <p:pic>
+        <p:nvPicPr>
+          <p:cNvPr id="5" name="Picture 4"/>
+          <p:cNvPicPr>
+            <a:picLocks noChangeAspect="1"/>
+          </p:cNvPicPr>
+          <p:nvPr/>
+        </p:nvPicPr>
+        <p:blipFill>
+          <a:blip r:embed="rId4"/>
+          <a:stretch>
+            <a:fillRect/>
+          </a:stretch>
+        </p:blipFill>
+        <p:spPr>
+          <a:xfrm>
+            <a:off x="1008762" y="3416164"/>
+            <a:ext cx="3253272" cy="2391206"/>
+          </a:xfrm>
+          <a:prstGeom prst="rect">
+            <a:avLst/>
+          </a:prstGeom>
+        </p:spPr>
+      </p:pic>
+      <p:pic>
+        <p:nvPicPr>
+          <p:cNvPr id="6" name="Picture 5"/>
+          <p:cNvPicPr>
+            <a:picLocks noChangeAspect="1"/>
+          </p:cNvPicPr>
+          <p:nvPr/>
+        </p:nvPicPr>
+        <p:blipFill>
+          <a:blip r:embed="rId5"/>
+          <a:stretch>
+            <a:fillRect/>
+          </a:stretch>
+        </p:blipFill>
+        <p:spPr>
+          <a:xfrm>
+            <a:off x="4510579" y="3416164"/>
+            <a:ext cx="3636520" cy="1031850"/>
+          </a:xfrm>
+          <a:prstGeom prst="rect">
+            <a:avLst/>
+          </a:prstGeom>
+        </p:spPr>
+      </p:pic>
+      <p:pic>
+        <p:nvPicPr>
+          <p:cNvPr id="7" name="Picture 6"/>
+          <p:cNvPicPr>
+            <a:picLocks noChangeAspect="1"/>
+          </p:cNvPicPr>
+          <p:nvPr/>
+        </p:nvPicPr>
+        <p:blipFill>
+          <a:blip r:embed="rId6"/>
+          <a:stretch>
+            <a:fillRect/>
+          </a:stretch>
+        </p:blipFill>
+        <p:spPr>
+          <a:xfrm>
+            <a:off x="8858182" y="3104325"/>
+            <a:ext cx="1967614" cy="289804"/>
+          </a:xfrm>
+          <a:prstGeom prst="rect">
+            <a:avLst/>
+          </a:prstGeom>
+        </p:spPr>
+      </p:pic>
+      <p:pic>
+        <p:nvPicPr>
+          <p:cNvPr id="8" name="Picture 7"/>
+          <p:cNvPicPr>
+            <a:picLocks noChangeAspect="1"/>
+          </p:cNvPicPr>
+          <p:nvPr/>
+        </p:nvPicPr>
+        <p:blipFill>
+          <a:blip r:embed="rId7"/>
+          <a:stretch>
+            <a:fillRect/>
+          </a:stretch>
+        </p:blipFill>
+        <p:spPr>
+          <a:xfrm>
+            <a:off x="8322263" y="3544751"/>
+            <a:ext cx="3106850" cy="779276"/>
+          </a:xfrm>
+          <a:prstGeom prst="rect">
+            <a:avLst/>
+          </a:prstGeom>
+        </p:spPr>
+      </p:pic>
+    </p:spTree>
+    <p:extLst>
+      <p:ext uri="{BB962C8B-B14F-4D97-AF65-F5344CB8AC3E}">
+        <p14:creationId xmlns:p14="http://schemas.microsoft.com/office/powerpoint/2010/main" val="730813173"/>
+      </p:ext>
+    </p:extLst>
+  </p:cSld>
+  <p:clrMapOvr>
+    <a:masterClrMapping/>
+  </p:clrMapOvr>
+  <mc:AlternateContent xmlns:mc="http://schemas.openxmlformats.org/markup-compatibility/2006" xmlns:p14="http://schemas.microsoft.com/office/powerpoint/2010/main">
+    <mc:Choice Requires="p14">
+      <p:transition spd="slow" p14:dur="2000"/>
+    </mc:Choice>
+    <mc:Fallback xmlns="">
+      <p:transition spd="slow"/>
+    </mc:Fallback>
+  </mc:AlternateContent>
+  <p:timing>
+    <p:tnLst>
+      <p:par>
+        <p:cTn id="1" dur="indefinite" restart="never" nodeType="tmRoot"/>
+      </p:par>
+    </p:tnLst>
+  </p:timing>
+</p:sld>
+</file>
+
+<file path=ppt/slides/slide19.xml><?xml version="1.0" encoding="utf-8"?>
+<p:sld xmlns:a="http://schemas.openxmlformats.org/drawingml/2006/main" xmlns:r="http://schemas.openxmlformats.org/officeDocument/2006/relationships" xmlns:p="http://schemas.openxmlformats.org/presentationml/2006/main">
+  <p:cSld>
+    <p:spTree>
+      <p:nvGrpSpPr>
+        <p:cNvPr id="1" name=""/>
+        <p:cNvGrpSpPr/>
+        <p:nvPr/>
+      </p:nvGrpSpPr>
+      <p:grpSpPr>
+        <a:xfrm>
+          <a:off x="0" y="0"/>
+          <a:ext cx="0" cy="0"/>
+          <a:chOff x="0" y="0"/>
+          <a:chExt cx="0" cy="0"/>
+        </a:xfrm>
+      </p:grpSpPr>
+      <p:sp>
+        <p:nvSpPr>
+          <p:cNvPr id="4" name="Title 1"/>
+          <p:cNvSpPr txBox="1">
+            <a:spLocks/>
+          </p:cNvSpPr>
+          <p:nvPr/>
+        </p:nvSpPr>
+        <p:spPr>
+          <a:xfrm>
+            <a:off x="543955" y="691871"/>
+            <a:ext cx="2788180" cy="2134212"/>
+          </a:xfrm>
+          <a:prstGeom prst="rect">
+            <a:avLst/>
+          </a:prstGeom>
+        </p:spPr>
+        <p:txBody>
+          <a:bodyPr/>
+          <a:lstStyle>
+            <a:lvl1pPr algn="ctr" defTabSz="457200" rtl="0" eaLnBrk="1" latinLnBrk="0" hangingPunct="1">
+              <a:spcBef>
+                <a:spcPct val="0"/>
+              </a:spcBef>
+              <a:buNone/>
+              <a:defRPr sz="4400" kern="1200" cap="none">
+                <a:ln w="3175" cmpd="sng">
+                  <a:noFill/>
+                </a:ln>
+                <a:solidFill>
+                  <a:schemeClr val="tx1">
+                    <a:lumMod val="85000"/>
+                    <a:lumOff val="15000"/>
+                  </a:schemeClr>
+                </a:solidFill>
+                <a:effectLst/>
+                <a:latin typeface="+mj-lt"/>
+                <a:ea typeface="+mj-ea"/>
+                <a:cs typeface="+mj-cs"/>
+              </a:defRPr>
+            </a:lvl1pPr>
+            <a:lvl2pPr eaLnBrk="1" hangingPunct="1">
+              <a:defRPr>
+                <a:solidFill>
+                  <a:schemeClr val="tx2"/>
+                </a:solidFill>
+              </a:defRPr>
+            </a:lvl2pPr>
+            <a:lvl3pPr eaLnBrk="1" hangingPunct="1">
+              <a:defRPr>
+                <a:solidFill>
+                  <a:schemeClr val="tx2"/>
+                </a:solidFill>
+              </a:defRPr>
+            </a:lvl3pPr>
+            <a:lvl4pPr eaLnBrk="1" hangingPunct="1">
+              <a:defRPr>
+                <a:solidFill>
+                  <a:schemeClr val="tx2"/>
+                </a:solidFill>
+              </a:defRPr>
+            </a:lvl4pPr>
+            <a:lvl5pPr eaLnBrk="1" hangingPunct="1">
+              <a:defRPr>
+                <a:solidFill>
+                  <a:schemeClr val="tx2"/>
+                </a:solidFill>
+              </a:defRPr>
+            </a:lvl5pPr>
+            <a:lvl6pPr eaLnBrk="1" hangingPunct="1">
+              <a:defRPr>
+                <a:solidFill>
+                  <a:schemeClr val="tx2"/>
+                </a:solidFill>
+              </a:defRPr>
+            </a:lvl6pPr>
+            <a:lvl7pPr eaLnBrk="1" hangingPunct="1">
+              <a:defRPr>
+                <a:solidFill>
+                  <a:schemeClr val="tx2"/>
+                </a:solidFill>
+              </a:defRPr>
+            </a:lvl7pPr>
+            <a:lvl8pPr eaLnBrk="1" hangingPunct="1">
+              <a:defRPr>
+                <a:solidFill>
+                  <a:schemeClr val="tx2"/>
+                </a:solidFill>
+              </a:defRPr>
+            </a:lvl8pPr>
+            <a:lvl9pPr eaLnBrk="1" hangingPunct="1">
+              <a:defRPr>
+                <a:solidFill>
+                  <a:schemeClr val="tx2"/>
+                </a:solidFill>
+              </a:defRPr>
+            </a:lvl9pPr>
+          </a:lstStyle>
+          <a:p>
+            <a:r>
+              <a:rPr lang="en-US" b="1" dirty="0" smtClean="0"/>
+              <a:t>STACK</a:t>
+            </a:r>
+            <a:endParaRPr lang="en-US" b="1" dirty="0"/>
+          </a:p>
+        </p:txBody>
+      </p:sp>
+      <p:pic>
+        <p:nvPicPr>
+          <p:cNvPr id="9" name="Picture 8"/>
+          <p:cNvPicPr>
+            <a:picLocks noChangeAspect="1"/>
+          </p:cNvPicPr>
+          <p:nvPr/>
+        </p:nvPicPr>
+        <p:blipFill>
+          <a:blip r:embed="rId2"/>
+          <a:stretch>
+            <a:fillRect/>
+          </a:stretch>
+        </p:blipFill>
+        <p:spPr>
+          <a:xfrm>
+            <a:off x="826091" y="146103"/>
+            <a:ext cx="7171034" cy="6589037"/>
+          </a:xfrm>
+          <a:prstGeom prst="rect">
+            <a:avLst/>
+          </a:prstGeom>
+        </p:spPr>
+      </p:pic>
+    </p:spTree>
+    <p:extLst>
+      <p:ext uri="{BB962C8B-B14F-4D97-AF65-F5344CB8AC3E}">
+        <p14:creationId xmlns:p14="http://schemas.microsoft.com/office/powerpoint/2010/main" val="2922888641"/>
+      </p:ext>
+    </p:extLst>
+  </p:cSld>
+  <p:clrMapOvr>
+    <a:masterClrMapping/>
+  </p:clrMapOvr>
+  <mc:AlternateContent xmlns:mc="http://schemas.openxmlformats.org/markup-compatibility/2006" xmlns:p14="http://schemas.microsoft.com/office/powerpoint/2010/main">
+    <mc:Choice Requires="p14">
+      <p:transition spd="slow" p14:dur="2000"/>
+    </mc:Choice>
+    <mc:Fallback xmlns="">
+      <p:transition spd="slow"/>
+    </mc:Fallback>
+  </mc:AlternateContent>
+  <p:timing>
+    <p:tnLst>
+      <p:par>
+        <p:cTn id="1" dur="indefinite" restart="never" nodeType="tmRoot"/>
+      </p:par>
+    </p:tnLst>
+  </p:timing>
+</p:sld>
+</file>
+
 <file path=ppt/slides/slide2.xml><?xml version="1.0" encoding="utf-8"?>
 <p:sld xmlns:a="http://schemas.openxmlformats.org/drawingml/2006/main" xmlns:r="http://schemas.openxmlformats.org/officeDocument/2006/relationships" xmlns:p="http://schemas.openxmlformats.org/presentationml/2006/main" show="0">
   <p:cSld>
@@ -7558,6 +8864,1793 @@
       </p:par>
     </p:tnLst>
   </p:timing>
+</p:sld>
+</file>
+
+<file path=ppt/slides/slide20.xml><?xml version="1.0" encoding="utf-8"?>
+<p:sld xmlns:a="http://schemas.openxmlformats.org/drawingml/2006/main" xmlns:r="http://schemas.openxmlformats.org/officeDocument/2006/relationships" xmlns:p="http://schemas.openxmlformats.org/presentationml/2006/main">
+  <p:cSld>
+    <p:spTree>
+      <p:nvGrpSpPr>
+        <p:cNvPr id="1" name=""/>
+        <p:cNvGrpSpPr/>
+        <p:nvPr/>
+      </p:nvGrpSpPr>
+      <p:grpSpPr>
+        <a:xfrm>
+          <a:off x="0" y="0"/>
+          <a:ext cx="0" cy="0"/>
+          <a:chOff x="0" y="0"/>
+          <a:chExt cx="0" cy="0"/>
+        </a:xfrm>
+      </p:grpSpPr>
+      <p:sp>
+        <p:nvSpPr>
+          <p:cNvPr id="4" name="Title 1"/>
+          <p:cNvSpPr txBox="1">
+            <a:spLocks/>
+          </p:cNvSpPr>
+          <p:nvPr/>
+        </p:nvSpPr>
+        <p:spPr>
+          <a:xfrm>
+            <a:off x="543955" y="691871"/>
+            <a:ext cx="2788180" cy="2134212"/>
+          </a:xfrm>
+          <a:prstGeom prst="rect">
+            <a:avLst/>
+          </a:prstGeom>
+        </p:spPr>
+        <p:txBody>
+          <a:bodyPr/>
+          <a:lstStyle>
+            <a:lvl1pPr algn="ctr" defTabSz="457200" rtl="0" eaLnBrk="1" latinLnBrk="0" hangingPunct="1">
+              <a:spcBef>
+                <a:spcPct val="0"/>
+              </a:spcBef>
+              <a:buNone/>
+              <a:defRPr sz="4400" kern="1200" cap="none">
+                <a:ln w="3175" cmpd="sng">
+                  <a:noFill/>
+                </a:ln>
+                <a:solidFill>
+                  <a:schemeClr val="tx1">
+                    <a:lumMod val="85000"/>
+                    <a:lumOff val="15000"/>
+                  </a:schemeClr>
+                </a:solidFill>
+                <a:effectLst/>
+                <a:latin typeface="+mj-lt"/>
+                <a:ea typeface="+mj-ea"/>
+                <a:cs typeface="+mj-cs"/>
+              </a:defRPr>
+            </a:lvl1pPr>
+            <a:lvl2pPr eaLnBrk="1" hangingPunct="1">
+              <a:defRPr>
+                <a:solidFill>
+                  <a:schemeClr val="tx2"/>
+                </a:solidFill>
+              </a:defRPr>
+            </a:lvl2pPr>
+            <a:lvl3pPr eaLnBrk="1" hangingPunct="1">
+              <a:defRPr>
+                <a:solidFill>
+                  <a:schemeClr val="tx2"/>
+                </a:solidFill>
+              </a:defRPr>
+            </a:lvl3pPr>
+            <a:lvl4pPr eaLnBrk="1" hangingPunct="1">
+              <a:defRPr>
+                <a:solidFill>
+                  <a:schemeClr val="tx2"/>
+                </a:solidFill>
+              </a:defRPr>
+            </a:lvl4pPr>
+            <a:lvl5pPr eaLnBrk="1" hangingPunct="1">
+              <a:defRPr>
+                <a:solidFill>
+                  <a:schemeClr val="tx2"/>
+                </a:solidFill>
+              </a:defRPr>
+            </a:lvl5pPr>
+            <a:lvl6pPr eaLnBrk="1" hangingPunct="1">
+              <a:defRPr>
+                <a:solidFill>
+                  <a:schemeClr val="tx2"/>
+                </a:solidFill>
+              </a:defRPr>
+            </a:lvl6pPr>
+            <a:lvl7pPr eaLnBrk="1" hangingPunct="1">
+              <a:defRPr>
+                <a:solidFill>
+                  <a:schemeClr val="tx2"/>
+                </a:solidFill>
+              </a:defRPr>
+            </a:lvl7pPr>
+            <a:lvl8pPr eaLnBrk="1" hangingPunct="1">
+              <a:defRPr>
+                <a:solidFill>
+                  <a:schemeClr val="tx2"/>
+                </a:solidFill>
+              </a:defRPr>
+            </a:lvl8pPr>
+            <a:lvl9pPr eaLnBrk="1" hangingPunct="1">
+              <a:defRPr>
+                <a:solidFill>
+                  <a:schemeClr val="tx2"/>
+                </a:solidFill>
+              </a:defRPr>
+            </a:lvl9pPr>
+          </a:lstStyle>
+          <a:p>
+            <a:r>
+              <a:rPr lang="en-US" b="1" dirty="0" smtClean="0"/>
+              <a:t>STACK</a:t>
+            </a:r>
+            <a:endParaRPr lang="en-US" b="1" dirty="0"/>
+          </a:p>
+        </p:txBody>
+      </p:sp>
+      <p:pic>
+        <p:nvPicPr>
+          <p:cNvPr id="9" name="Picture 8"/>
+          <p:cNvPicPr>
+            <a:picLocks noChangeAspect="1"/>
+          </p:cNvPicPr>
+          <p:nvPr/>
+        </p:nvPicPr>
+        <p:blipFill>
+          <a:blip r:embed="rId2"/>
+          <a:stretch>
+            <a:fillRect/>
+          </a:stretch>
+        </p:blipFill>
+        <p:spPr>
+          <a:xfrm>
+            <a:off x="799696" y="691871"/>
+            <a:ext cx="9972675" cy="5572125"/>
+          </a:xfrm>
+          <a:prstGeom prst="rect">
+            <a:avLst/>
+          </a:prstGeom>
+        </p:spPr>
+      </p:pic>
+    </p:spTree>
+    <p:extLst>
+      <p:ext uri="{BB962C8B-B14F-4D97-AF65-F5344CB8AC3E}">
+        <p14:creationId xmlns:p14="http://schemas.microsoft.com/office/powerpoint/2010/main" val="3272484737"/>
+      </p:ext>
+    </p:extLst>
+  </p:cSld>
+  <p:clrMapOvr>
+    <a:masterClrMapping/>
+  </p:clrMapOvr>
+  <mc:AlternateContent xmlns:mc="http://schemas.openxmlformats.org/markup-compatibility/2006" xmlns:p14="http://schemas.microsoft.com/office/powerpoint/2010/main">
+    <mc:Choice Requires="p14">
+      <p:transition spd="slow" p14:dur="2000"/>
+    </mc:Choice>
+    <mc:Fallback xmlns="">
+      <p:transition spd="slow"/>
+    </mc:Fallback>
+  </mc:AlternateContent>
+  <p:timing>
+    <p:tnLst>
+      <p:par>
+        <p:cTn id="1" dur="indefinite" restart="never" nodeType="tmRoot"/>
+      </p:par>
+    </p:tnLst>
+  </p:timing>
+</p:sld>
+</file>
+
+<file path=ppt/slides/slide21.xml><?xml version="1.0" encoding="utf-8"?>
+<p:sld xmlns:a="http://schemas.openxmlformats.org/drawingml/2006/main" xmlns:r="http://schemas.openxmlformats.org/officeDocument/2006/relationships" xmlns:p="http://schemas.openxmlformats.org/presentationml/2006/main">
+  <p:cSld>
+    <p:spTree>
+      <p:nvGrpSpPr>
+        <p:cNvPr id="1" name=""/>
+        <p:cNvGrpSpPr/>
+        <p:nvPr/>
+      </p:nvGrpSpPr>
+      <p:grpSpPr>
+        <a:xfrm>
+          <a:off x="0" y="0"/>
+          <a:ext cx="0" cy="0"/>
+          <a:chOff x="0" y="0"/>
+          <a:chExt cx="0" cy="0"/>
+        </a:xfrm>
+      </p:grpSpPr>
+      <p:sp>
+        <p:nvSpPr>
+          <p:cNvPr id="4" name="Title 1"/>
+          <p:cNvSpPr txBox="1">
+            <a:spLocks/>
+          </p:cNvSpPr>
+          <p:nvPr/>
+        </p:nvSpPr>
+        <p:spPr>
+          <a:xfrm>
+            <a:off x="543954" y="691871"/>
+            <a:ext cx="9514445" cy="2134212"/>
+          </a:xfrm>
+          <a:prstGeom prst="rect">
+            <a:avLst/>
+          </a:prstGeom>
+        </p:spPr>
+        <p:txBody>
+          <a:bodyPr/>
+          <a:lstStyle>
+            <a:lvl1pPr algn="ctr" defTabSz="457200" rtl="0" eaLnBrk="1" latinLnBrk="0" hangingPunct="1">
+              <a:spcBef>
+                <a:spcPct val="0"/>
+              </a:spcBef>
+              <a:buNone/>
+              <a:defRPr sz="4400" kern="1200" cap="none">
+                <a:ln w="3175" cmpd="sng">
+                  <a:noFill/>
+                </a:ln>
+                <a:solidFill>
+                  <a:schemeClr val="tx1">
+                    <a:lumMod val="85000"/>
+                    <a:lumOff val="15000"/>
+                  </a:schemeClr>
+                </a:solidFill>
+                <a:effectLst/>
+                <a:latin typeface="+mj-lt"/>
+                <a:ea typeface="+mj-ea"/>
+                <a:cs typeface="+mj-cs"/>
+              </a:defRPr>
+            </a:lvl1pPr>
+            <a:lvl2pPr eaLnBrk="1" hangingPunct="1">
+              <a:defRPr>
+                <a:solidFill>
+                  <a:schemeClr val="tx2"/>
+                </a:solidFill>
+              </a:defRPr>
+            </a:lvl2pPr>
+            <a:lvl3pPr eaLnBrk="1" hangingPunct="1">
+              <a:defRPr>
+                <a:solidFill>
+                  <a:schemeClr val="tx2"/>
+                </a:solidFill>
+              </a:defRPr>
+            </a:lvl3pPr>
+            <a:lvl4pPr eaLnBrk="1" hangingPunct="1">
+              <a:defRPr>
+                <a:solidFill>
+                  <a:schemeClr val="tx2"/>
+                </a:solidFill>
+              </a:defRPr>
+            </a:lvl4pPr>
+            <a:lvl5pPr eaLnBrk="1" hangingPunct="1">
+              <a:defRPr>
+                <a:solidFill>
+                  <a:schemeClr val="tx2"/>
+                </a:solidFill>
+              </a:defRPr>
+            </a:lvl5pPr>
+            <a:lvl6pPr eaLnBrk="1" hangingPunct="1">
+              <a:defRPr>
+                <a:solidFill>
+                  <a:schemeClr val="tx2"/>
+                </a:solidFill>
+              </a:defRPr>
+            </a:lvl6pPr>
+            <a:lvl7pPr eaLnBrk="1" hangingPunct="1">
+              <a:defRPr>
+                <a:solidFill>
+                  <a:schemeClr val="tx2"/>
+                </a:solidFill>
+              </a:defRPr>
+            </a:lvl7pPr>
+            <a:lvl8pPr eaLnBrk="1" hangingPunct="1">
+              <a:defRPr>
+                <a:solidFill>
+                  <a:schemeClr val="tx2"/>
+                </a:solidFill>
+              </a:defRPr>
+            </a:lvl8pPr>
+            <a:lvl9pPr eaLnBrk="1" hangingPunct="1">
+              <a:defRPr>
+                <a:solidFill>
+                  <a:schemeClr val="tx2"/>
+                </a:solidFill>
+              </a:defRPr>
+            </a:lvl9pPr>
+          </a:lstStyle>
+          <a:p>
+            <a:r>
+              <a:rPr lang="en-US" b="1" dirty="0" smtClean="0"/>
+              <a:t>Schoology: SQL 1 &amp; 2</a:t>
+            </a:r>
+            <a:endParaRPr lang="en-US" b="1" dirty="0"/>
+          </a:p>
+        </p:txBody>
+      </p:sp>
+      <p:pic>
+        <p:nvPicPr>
+          <p:cNvPr id="9" name="Picture 8"/>
+          <p:cNvPicPr>
+            <a:picLocks noChangeAspect="1"/>
+          </p:cNvPicPr>
+          <p:nvPr/>
+        </p:nvPicPr>
+        <p:blipFill>
+          <a:blip r:embed="rId2"/>
+          <a:stretch>
+            <a:fillRect/>
+          </a:stretch>
+        </p:blipFill>
+        <p:spPr>
+          <a:xfrm>
+            <a:off x="1282889" y="1634989"/>
+            <a:ext cx="8884000" cy="3862609"/>
+          </a:xfrm>
+          <a:prstGeom prst="rect">
+            <a:avLst/>
+          </a:prstGeom>
+        </p:spPr>
+      </p:pic>
+    </p:spTree>
+    <p:extLst>
+      <p:ext uri="{BB962C8B-B14F-4D97-AF65-F5344CB8AC3E}">
+        <p14:creationId xmlns:p14="http://schemas.microsoft.com/office/powerpoint/2010/main" val="2751754371"/>
+      </p:ext>
+    </p:extLst>
+  </p:cSld>
+  <p:clrMapOvr>
+    <a:masterClrMapping/>
+  </p:clrMapOvr>
+  <mc:AlternateContent xmlns:mc="http://schemas.openxmlformats.org/markup-compatibility/2006" xmlns:p14="http://schemas.microsoft.com/office/powerpoint/2010/main">
+    <mc:Choice Requires="p14">
+      <p:transition spd="slow" p14:dur="2000"/>
+    </mc:Choice>
+    <mc:Fallback xmlns="">
+      <p:transition spd="slow"/>
+    </mc:Fallback>
+  </mc:AlternateContent>
+  <p:timing>
+    <p:tnLst>
+      <p:par>
+        <p:cTn id="1" dur="indefinite" restart="never" nodeType="tmRoot"/>
+      </p:par>
+    </p:tnLst>
+  </p:timing>
+</p:sld>
+</file>
+
+<file path=ppt/slides/slide22.xml><?xml version="1.0" encoding="utf-8"?>
+<p:sld xmlns:a="http://schemas.openxmlformats.org/drawingml/2006/main" xmlns:r="http://schemas.openxmlformats.org/officeDocument/2006/relationships" xmlns:p="http://schemas.openxmlformats.org/presentationml/2006/main">
+  <p:cSld>
+    <p:spTree>
+      <p:nvGrpSpPr>
+        <p:cNvPr id="1" name=""/>
+        <p:cNvGrpSpPr/>
+        <p:nvPr/>
+      </p:nvGrpSpPr>
+      <p:grpSpPr>
+        <a:xfrm>
+          <a:off x="0" y="0"/>
+          <a:ext cx="0" cy="0"/>
+          <a:chOff x="0" y="0"/>
+          <a:chExt cx="0" cy="0"/>
+        </a:xfrm>
+      </p:grpSpPr>
+      <p:sp>
+        <p:nvSpPr>
+          <p:cNvPr id="5" name="Title 1"/>
+          <p:cNvSpPr txBox="1">
+            <a:spLocks/>
+          </p:cNvSpPr>
+          <p:nvPr/>
+        </p:nvSpPr>
+        <p:spPr>
+          <a:xfrm>
+            <a:off x="590449" y="927977"/>
+            <a:ext cx="9514445" cy="1012943"/>
+          </a:xfrm>
+          <a:prstGeom prst="rect">
+            <a:avLst/>
+          </a:prstGeom>
+        </p:spPr>
+        <p:txBody>
+          <a:bodyPr/>
+          <a:lstStyle>
+            <a:lvl1pPr algn="ctr" defTabSz="457200" rtl="0" eaLnBrk="1" latinLnBrk="0" hangingPunct="1">
+              <a:spcBef>
+                <a:spcPct val="0"/>
+              </a:spcBef>
+              <a:buNone/>
+              <a:defRPr sz="4400" kern="1200" cap="none">
+                <a:ln w="3175" cmpd="sng">
+                  <a:noFill/>
+                </a:ln>
+                <a:solidFill>
+                  <a:schemeClr val="tx1">
+                    <a:lumMod val="85000"/>
+                    <a:lumOff val="15000"/>
+                  </a:schemeClr>
+                </a:solidFill>
+                <a:effectLst/>
+                <a:latin typeface="+mj-lt"/>
+                <a:ea typeface="+mj-ea"/>
+                <a:cs typeface="+mj-cs"/>
+              </a:defRPr>
+            </a:lvl1pPr>
+            <a:lvl2pPr eaLnBrk="1" hangingPunct="1">
+              <a:defRPr>
+                <a:solidFill>
+                  <a:schemeClr val="tx2"/>
+                </a:solidFill>
+              </a:defRPr>
+            </a:lvl2pPr>
+            <a:lvl3pPr eaLnBrk="1" hangingPunct="1">
+              <a:defRPr>
+                <a:solidFill>
+                  <a:schemeClr val="tx2"/>
+                </a:solidFill>
+              </a:defRPr>
+            </a:lvl3pPr>
+            <a:lvl4pPr eaLnBrk="1" hangingPunct="1">
+              <a:defRPr>
+                <a:solidFill>
+                  <a:schemeClr val="tx2"/>
+                </a:solidFill>
+              </a:defRPr>
+            </a:lvl4pPr>
+            <a:lvl5pPr eaLnBrk="1" hangingPunct="1">
+              <a:defRPr>
+                <a:solidFill>
+                  <a:schemeClr val="tx2"/>
+                </a:solidFill>
+              </a:defRPr>
+            </a:lvl5pPr>
+            <a:lvl6pPr eaLnBrk="1" hangingPunct="1">
+              <a:defRPr>
+                <a:solidFill>
+                  <a:schemeClr val="tx2"/>
+                </a:solidFill>
+              </a:defRPr>
+            </a:lvl6pPr>
+            <a:lvl7pPr eaLnBrk="1" hangingPunct="1">
+              <a:defRPr>
+                <a:solidFill>
+                  <a:schemeClr val="tx2"/>
+                </a:solidFill>
+              </a:defRPr>
+            </a:lvl7pPr>
+            <a:lvl8pPr eaLnBrk="1" hangingPunct="1">
+              <a:defRPr>
+                <a:solidFill>
+                  <a:schemeClr val="tx2"/>
+                </a:solidFill>
+              </a:defRPr>
+            </a:lvl8pPr>
+            <a:lvl9pPr eaLnBrk="1" hangingPunct="1">
+              <a:defRPr>
+                <a:solidFill>
+                  <a:schemeClr val="tx2"/>
+                </a:solidFill>
+              </a:defRPr>
+            </a:lvl9pPr>
+          </a:lstStyle>
+          <a:p>
+            <a:r>
+              <a:rPr lang="en-US" b="1" dirty="0" smtClean="0"/>
+              <a:t>Project Pulse – Backend</a:t>
+            </a:r>
+            <a:endParaRPr lang="en-US" b="1" dirty="0"/>
+          </a:p>
+        </p:txBody>
+      </p:sp>
+      <p:pic>
+        <p:nvPicPr>
+          <p:cNvPr id="2" name="Picture 1"/>
+          <p:cNvPicPr>
+            <a:picLocks noChangeAspect="1"/>
+          </p:cNvPicPr>
+          <p:nvPr/>
+        </p:nvPicPr>
+        <p:blipFill>
+          <a:blip r:embed="rId2"/>
+          <a:stretch>
+            <a:fillRect/>
+          </a:stretch>
+        </p:blipFill>
+        <p:spPr>
+          <a:xfrm>
+            <a:off x="590449" y="1691817"/>
+            <a:ext cx="5855469" cy="2322242"/>
+          </a:xfrm>
+          <a:prstGeom prst="rect">
+            <a:avLst/>
+          </a:prstGeom>
+        </p:spPr>
+      </p:pic>
+      <p:pic>
+        <p:nvPicPr>
+          <p:cNvPr id="3" name="Picture 2"/>
+          <p:cNvPicPr>
+            <a:picLocks noChangeAspect="1"/>
+          </p:cNvPicPr>
+          <p:nvPr/>
+        </p:nvPicPr>
+        <p:blipFill>
+          <a:blip r:embed="rId3"/>
+          <a:stretch>
+            <a:fillRect/>
+          </a:stretch>
+        </p:blipFill>
+        <p:spPr>
+          <a:xfrm>
+            <a:off x="5738005" y="4014059"/>
+            <a:ext cx="5994212" cy="2404973"/>
+          </a:xfrm>
+          <a:prstGeom prst="rect">
+            <a:avLst/>
+          </a:prstGeom>
+        </p:spPr>
+      </p:pic>
+    </p:spTree>
+    <p:extLst>
+      <p:ext uri="{BB962C8B-B14F-4D97-AF65-F5344CB8AC3E}">
+        <p14:creationId xmlns:p14="http://schemas.microsoft.com/office/powerpoint/2010/main" val="2914263309"/>
+      </p:ext>
+    </p:extLst>
+  </p:cSld>
+  <p:clrMapOvr>
+    <a:masterClrMapping/>
+  </p:clrMapOvr>
+  <mc:AlternateContent xmlns:mc="http://schemas.openxmlformats.org/markup-compatibility/2006" xmlns:p14="http://schemas.microsoft.com/office/powerpoint/2010/main">
+    <mc:Choice Requires="p14">
+      <p:transition spd="slow" p14:dur="2000"/>
+    </mc:Choice>
+    <mc:Fallback xmlns="">
+      <p:transition spd="slow"/>
+    </mc:Fallback>
+  </mc:AlternateContent>
+  <p:timing>
+    <p:tnLst>
+      <p:par>
+        <p:cTn id="1" dur="indefinite" restart="never" nodeType="tmRoot"/>
+      </p:par>
+    </p:tnLst>
+  </p:timing>
+</p:sld>
+</file>
+
+<file path=ppt/slides/slide23.xml><?xml version="1.0" encoding="utf-8"?>
+<p:sld xmlns:a="http://schemas.openxmlformats.org/drawingml/2006/main" xmlns:r="http://schemas.openxmlformats.org/officeDocument/2006/relationships" xmlns:p="http://schemas.openxmlformats.org/presentationml/2006/main">
+  <p:cSld>
+    <p:spTree>
+      <p:nvGrpSpPr>
+        <p:cNvPr id="1" name=""/>
+        <p:cNvGrpSpPr/>
+        <p:nvPr/>
+      </p:nvGrpSpPr>
+      <p:grpSpPr>
+        <a:xfrm>
+          <a:off x="0" y="0"/>
+          <a:ext cx="0" cy="0"/>
+          <a:chOff x="0" y="0"/>
+          <a:chExt cx="0" cy="0"/>
+        </a:xfrm>
+      </p:grpSpPr>
+      <p:sp>
+        <p:nvSpPr>
+          <p:cNvPr id="5" name="Title 1"/>
+          <p:cNvSpPr txBox="1">
+            <a:spLocks/>
+          </p:cNvSpPr>
+          <p:nvPr/>
+        </p:nvSpPr>
+        <p:spPr>
+          <a:xfrm>
+            <a:off x="590449" y="927977"/>
+            <a:ext cx="9514445" cy="1012943"/>
+          </a:xfrm>
+          <a:prstGeom prst="rect">
+            <a:avLst/>
+          </a:prstGeom>
+        </p:spPr>
+        <p:txBody>
+          <a:bodyPr/>
+          <a:lstStyle>
+            <a:lvl1pPr algn="ctr" defTabSz="457200" rtl="0" eaLnBrk="1" latinLnBrk="0" hangingPunct="1">
+              <a:spcBef>
+                <a:spcPct val="0"/>
+              </a:spcBef>
+              <a:buNone/>
+              <a:defRPr sz="4400" kern="1200" cap="none">
+                <a:ln w="3175" cmpd="sng">
+                  <a:noFill/>
+                </a:ln>
+                <a:solidFill>
+                  <a:schemeClr val="tx1">
+                    <a:lumMod val="85000"/>
+                    <a:lumOff val="15000"/>
+                  </a:schemeClr>
+                </a:solidFill>
+                <a:effectLst/>
+                <a:latin typeface="+mj-lt"/>
+                <a:ea typeface="+mj-ea"/>
+                <a:cs typeface="+mj-cs"/>
+              </a:defRPr>
+            </a:lvl1pPr>
+            <a:lvl2pPr eaLnBrk="1" hangingPunct="1">
+              <a:defRPr>
+                <a:solidFill>
+                  <a:schemeClr val="tx2"/>
+                </a:solidFill>
+              </a:defRPr>
+            </a:lvl2pPr>
+            <a:lvl3pPr eaLnBrk="1" hangingPunct="1">
+              <a:defRPr>
+                <a:solidFill>
+                  <a:schemeClr val="tx2"/>
+                </a:solidFill>
+              </a:defRPr>
+            </a:lvl3pPr>
+            <a:lvl4pPr eaLnBrk="1" hangingPunct="1">
+              <a:defRPr>
+                <a:solidFill>
+                  <a:schemeClr val="tx2"/>
+                </a:solidFill>
+              </a:defRPr>
+            </a:lvl4pPr>
+            <a:lvl5pPr eaLnBrk="1" hangingPunct="1">
+              <a:defRPr>
+                <a:solidFill>
+                  <a:schemeClr val="tx2"/>
+                </a:solidFill>
+              </a:defRPr>
+            </a:lvl5pPr>
+            <a:lvl6pPr eaLnBrk="1" hangingPunct="1">
+              <a:defRPr>
+                <a:solidFill>
+                  <a:schemeClr val="tx2"/>
+                </a:solidFill>
+              </a:defRPr>
+            </a:lvl6pPr>
+            <a:lvl7pPr eaLnBrk="1" hangingPunct="1">
+              <a:defRPr>
+                <a:solidFill>
+                  <a:schemeClr val="tx2"/>
+                </a:solidFill>
+              </a:defRPr>
+            </a:lvl7pPr>
+            <a:lvl8pPr eaLnBrk="1" hangingPunct="1">
+              <a:defRPr>
+                <a:solidFill>
+                  <a:schemeClr val="tx2"/>
+                </a:solidFill>
+              </a:defRPr>
+            </a:lvl8pPr>
+            <a:lvl9pPr eaLnBrk="1" hangingPunct="1">
+              <a:defRPr>
+                <a:solidFill>
+                  <a:schemeClr val="tx2"/>
+                </a:solidFill>
+              </a:defRPr>
+            </a:lvl9pPr>
+          </a:lstStyle>
+          <a:p>
+            <a:r>
+              <a:rPr lang="en-US" b="1" dirty="0" smtClean="0"/>
+              <a:t>Project Pulse – Backend</a:t>
+            </a:r>
+            <a:endParaRPr lang="en-US" b="1" dirty="0"/>
+          </a:p>
+        </p:txBody>
+      </p:sp>
+      <p:pic>
+        <p:nvPicPr>
+          <p:cNvPr id="6" name="Picture 5"/>
+          <p:cNvPicPr>
+            <a:picLocks noChangeAspect="1"/>
+          </p:cNvPicPr>
+          <p:nvPr/>
+        </p:nvPicPr>
+        <p:blipFill>
+          <a:blip r:embed="rId2"/>
+          <a:stretch>
+            <a:fillRect/>
+          </a:stretch>
+        </p:blipFill>
+        <p:spPr>
+          <a:xfrm>
+            <a:off x="1269408" y="2157896"/>
+            <a:ext cx="9837044" cy="2972043"/>
+          </a:xfrm>
+          <a:prstGeom prst="rect">
+            <a:avLst/>
+          </a:prstGeom>
+        </p:spPr>
+      </p:pic>
+    </p:spTree>
+    <p:extLst>
+      <p:ext uri="{BB962C8B-B14F-4D97-AF65-F5344CB8AC3E}">
+        <p14:creationId xmlns:p14="http://schemas.microsoft.com/office/powerpoint/2010/main" val="1409139051"/>
+      </p:ext>
+    </p:extLst>
+  </p:cSld>
+  <p:clrMapOvr>
+    <a:masterClrMapping/>
+  </p:clrMapOvr>
+  <mc:AlternateContent xmlns:mc="http://schemas.openxmlformats.org/markup-compatibility/2006" xmlns:p14="http://schemas.microsoft.com/office/powerpoint/2010/main">
+    <mc:Choice Requires="p14">
+      <p:transition spd="slow" p14:dur="2000"/>
+    </mc:Choice>
+    <mc:Fallback xmlns="">
+      <p:transition spd="slow"/>
+    </mc:Fallback>
+  </mc:AlternateContent>
+  <p:timing>
+    <p:tnLst>
+      <p:par>
+        <p:cTn id="1" dur="indefinite" restart="never" nodeType="tmRoot"/>
+      </p:par>
+    </p:tnLst>
+  </p:timing>
+</p:sld>
+</file>
+
+<file path=ppt/slides/slide24.xml><?xml version="1.0" encoding="utf-8"?>
+<p:sld xmlns:a="http://schemas.openxmlformats.org/drawingml/2006/main" xmlns:r="http://schemas.openxmlformats.org/officeDocument/2006/relationships" xmlns:p="http://schemas.openxmlformats.org/presentationml/2006/main">
+  <p:cSld>
+    <p:spTree>
+      <p:nvGrpSpPr>
+        <p:cNvPr id="1" name=""/>
+        <p:cNvGrpSpPr/>
+        <p:nvPr/>
+      </p:nvGrpSpPr>
+      <p:grpSpPr>
+        <a:xfrm>
+          <a:off x="0" y="0"/>
+          <a:ext cx="0" cy="0"/>
+          <a:chOff x="0" y="0"/>
+          <a:chExt cx="0" cy="0"/>
+        </a:xfrm>
+      </p:grpSpPr>
+      <p:sp>
+        <p:nvSpPr>
+          <p:cNvPr id="5" name="Title 1"/>
+          <p:cNvSpPr txBox="1">
+            <a:spLocks/>
+          </p:cNvSpPr>
+          <p:nvPr/>
+        </p:nvSpPr>
+        <p:spPr>
+          <a:xfrm>
+            <a:off x="590449" y="927977"/>
+            <a:ext cx="9514445" cy="1012943"/>
+          </a:xfrm>
+          <a:prstGeom prst="rect">
+            <a:avLst/>
+          </a:prstGeom>
+        </p:spPr>
+        <p:txBody>
+          <a:bodyPr/>
+          <a:lstStyle>
+            <a:lvl1pPr algn="ctr" defTabSz="457200" rtl="0" eaLnBrk="1" latinLnBrk="0" hangingPunct="1">
+              <a:spcBef>
+                <a:spcPct val="0"/>
+              </a:spcBef>
+              <a:buNone/>
+              <a:defRPr sz="4400" kern="1200" cap="none">
+                <a:ln w="3175" cmpd="sng">
+                  <a:noFill/>
+                </a:ln>
+                <a:solidFill>
+                  <a:schemeClr val="tx1">
+                    <a:lumMod val="85000"/>
+                    <a:lumOff val="15000"/>
+                  </a:schemeClr>
+                </a:solidFill>
+                <a:effectLst/>
+                <a:latin typeface="+mj-lt"/>
+                <a:ea typeface="+mj-ea"/>
+                <a:cs typeface="+mj-cs"/>
+              </a:defRPr>
+            </a:lvl1pPr>
+            <a:lvl2pPr eaLnBrk="1" hangingPunct="1">
+              <a:defRPr>
+                <a:solidFill>
+                  <a:schemeClr val="tx2"/>
+                </a:solidFill>
+              </a:defRPr>
+            </a:lvl2pPr>
+            <a:lvl3pPr eaLnBrk="1" hangingPunct="1">
+              <a:defRPr>
+                <a:solidFill>
+                  <a:schemeClr val="tx2"/>
+                </a:solidFill>
+              </a:defRPr>
+            </a:lvl3pPr>
+            <a:lvl4pPr eaLnBrk="1" hangingPunct="1">
+              <a:defRPr>
+                <a:solidFill>
+                  <a:schemeClr val="tx2"/>
+                </a:solidFill>
+              </a:defRPr>
+            </a:lvl4pPr>
+            <a:lvl5pPr eaLnBrk="1" hangingPunct="1">
+              <a:defRPr>
+                <a:solidFill>
+                  <a:schemeClr val="tx2"/>
+                </a:solidFill>
+              </a:defRPr>
+            </a:lvl5pPr>
+            <a:lvl6pPr eaLnBrk="1" hangingPunct="1">
+              <a:defRPr>
+                <a:solidFill>
+                  <a:schemeClr val="tx2"/>
+                </a:solidFill>
+              </a:defRPr>
+            </a:lvl6pPr>
+            <a:lvl7pPr eaLnBrk="1" hangingPunct="1">
+              <a:defRPr>
+                <a:solidFill>
+                  <a:schemeClr val="tx2"/>
+                </a:solidFill>
+              </a:defRPr>
+            </a:lvl7pPr>
+            <a:lvl8pPr eaLnBrk="1" hangingPunct="1">
+              <a:defRPr>
+                <a:solidFill>
+                  <a:schemeClr val="tx2"/>
+                </a:solidFill>
+              </a:defRPr>
+            </a:lvl8pPr>
+            <a:lvl9pPr eaLnBrk="1" hangingPunct="1">
+              <a:defRPr>
+                <a:solidFill>
+                  <a:schemeClr val="tx2"/>
+                </a:solidFill>
+              </a:defRPr>
+            </a:lvl9pPr>
+          </a:lstStyle>
+          <a:p>
+            <a:r>
+              <a:rPr lang="en-US" b="1" dirty="0" smtClean="0"/>
+              <a:t>Project Pulse – Frontend</a:t>
+            </a:r>
+            <a:endParaRPr lang="en-US" b="1" dirty="0"/>
+          </a:p>
+        </p:txBody>
+      </p:sp>
+      <p:pic>
+        <p:nvPicPr>
+          <p:cNvPr id="2" name="Picture 1"/>
+          <p:cNvPicPr>
+            <a:picLocks noChangeAspect="1"/>
+          </p:cNvPicPr>
+          <p:nvPr/>
+        </p:nvPicPr>
+        <p:blipFill>
+          <a:blip r:embed="rId2"/>
+          <a:stretch>
+            <a:fillRect/>
+          </a:stretch>
+        </p:blipFill>
+        <p:spPr>
+          <a:xfrm>
+            <a:off x="1479522" y="1770439"/>
+            <a:ext cx="2331881" cy="596120"/>
+          </a:xfrm>
+          <a:prstGeom prst="rect">
+            <a:avLst/>
+          </a:prstGeom>
+        </p:spPr>
+      </p:pic>
+      <p:pic>
+        <p:nvPicPr>
+          <p:cNvPr id="4" name="Picture 3"/>
+          <p:cNvPicPr>
+            <a:picLocks noChangeAspect="1"/>
+          </p:cNvPicPr>
+          <p:nvPr/>
+        </p:nvPicPr>
+        <p:blipFill>
+          <a:blip r:embed="rId3"/>
+          <a:stretch>
+            <a:fillRect/>
+          </a:stretch>
+        </p:blipFill>
+        <p:spPr>
+          <a:xfrm>
+            <a:off x="1479522" y="2495936"/>
+            <a:ext cx="9105820" cy="2912459"/>
+          </a:xfrm>
+          <a:prstGeom prst="rect">
+            <a:avLst/>
+          </a:prstGeom>
+        </p:spPr>
+      </p:pic>
+    </p:spTree>
+    <p:extLst>
+      <p:ext uri="{BB962C8B-B14F-4D97-AF65-F5344CB8AC3E}">
+        <p14:creationId xmlns:p14="http://schemas.microsoft.com/office/powerpoint/2010/main" val="3323179153"/>
+      </p:ext>
+    </p:extLst>
+  </p:cSld>
+  <p:clrMapOvr>
+    <a:masterClrMapping/>
+  </p:clrMapOvr>
+  <mc:AlternateContent xmlns:mc="http://schemas.openxmlformats.org/markup-compatibility/2006" xmlns:p14="http://schemas.microsoft.com/office/powerpoint/2010/main">
+    <mc:Choice Requires="p14">
+      <p:transition spd="slow" p14:dur="2000"/>
+    </mc:Choice>
+    <mc:Fallback xmlns="">
+      <p:transition spd="slow"/>
+    </mc:Fallback>
+  </mc:AlternateContent>
+  <p:timing>
+    <p:tnLst>
+      <p:par>
+        <p:cTn id="1" dur="indefinite" restart="never" nodeType="tmRoot"/>
+      </p:par>
+    </p:tnLst>
+  </p:timing>
+</p:sld>
+</file>
+
+<file path=ppt/slides/slide25.xml><?xml version="1.0" encoding="utf-8"?>
+<p:sld xmlns:a="http://schemas.openxmlformats.org/drawingml/2006/main" xmlns:r="http://schemas.openxmlformats.org/officeDocument/2006/relationships" xmlns:p="http://schemas.openxmlformats.org/presentationml/2006/main">
+  <p:cSld>
+    <p:spTree>
+      <p:nvGrpSpPr>
+        <p:cNvPr id="1" name=""/>
+        <p:cNvGrpSpPr/>
+        <p:nvPr/>
+      </p:nvGrpSpPr>
+      <p:grpSpPr>
+        <a:xfrm>
+          <a:off x="0" y="0"/>
+          <a:ext cx="0" cy="0"/>
+          <a:chOff x="0" y="0"/>
+          <a:chExt cx="0" cy="0"/>
+        </a:xfrm>
+      </p:grpSpPr>
+      <p:sp>
+        <p:nvSpPr>
+          <p:cNvPr id="5" name="Title 1"/>
+          <p:cNvSpPr txBox="1">
+            <a:spLocks/>
+          </p:cNvSpPr>
+          <p:nvPr/>
+        </p:nvSpPr>
+        <p:spPr>
+          <a:xfrm>
+            <a:off x="590449" y="927977"/>
+            <a:ext cx="9514445" cy="1012943"/>
+          </a:xfrm>
+          <a:prstGeom prst="rect">
+            <a:avLst/>
+          </a:prstGeom>
+        </p:spPr>
+        <p:txBody>
+          <a:bodyPr/>
+          <a:lstStyle>
+            <a:lvl1pPr algn="ctr" defTabSz="457200" rtl="0" eaLnBrk="1" latinLnBrk="0" hangingPunct="1">
+              <a:spcBef>
+                <a:spcPct val="0"/>
+              </a:spcBef>
+              <a:buNone/>
+              <a:defRPr sz="4400" kern="1200" cap="none">
+                <a:ln w="3175" cmpd="sng">
+                  <a:noFill/>
+                </a:ln>
+                <a:solidFill>
+                  <a:schemeClr val="tx1">
+                    <a:lumMod val="85000"/>
+                    <a:lumOff val="15000"/>
+                  </a:schemeClr>
+                </a:solidFill>
+                <a:effectLst/>
+                <a:latin typeface="+mj-lt"/>
+                <a:ea typeface="+mj-ea"/>
+                <a:cs typeface="+mj-cs"/>
+              </a:defRPr>
+            </a:lvl1pPr>
+            <a:lvl2pPr eaLnBrk="1" hangingPunct="1">
+              <a:defRPr>
+                <a:solidFill>
+                  <a:schemeClr val="tx2"/>
+                </a:solidFill>
+              </a:defRPr>
+            </a:lvl2pPr>
+            <a:lvl3pPr eaLnBrk="1" hangingPunct="1">
+              <a:defRPr>
+                <a:solidFill>
+                  <a:schemeClr val="tx2"/>
+                </a:solidFill>
+              </a:defRPr>
+            </a:lvl3pPr>
+            <a:lvl4pPr eaLnBrk="1" hangingPunct="1">
+              <a:defRPr>
+                <a:solidFill>
+                  <a:schemeClr val="tx2"/>
+                </a:solidFill>
+              </a:defRPr>
+            </a:lvl4pPr>
+            <a:lvl5pPr eaLnBrk="1" hangingPunct="1">
+              <a:defRPr>
+                <a:solidFill>
+                  <a:schemeClr val="tx2"/>
+                </a:solidFill>
+              </a:defRPr>
+            </a:lvl5pPr>
+            <a:lvl6pPr eaLnBrk="1" hangingPunct="1">
+              <a:defRPr>
+                <a:solidFill>
+                  <a:schemeClr val="tx2"/>
+                </a:solidFill>
+              </a:defRPr>
+            </a:lvl6pPr>
+            <a:lvl7pPr eaLnBrk="1" hangingPunct="1">
+              <a:defRPr>
+                <a:solidFill>
+                  <a:schemeClr val="tx2"/>
+                </a:solidFill>
+              </a:defRPr>
+            </a:lvl7pPr>
+            <a:lvl8pPr eaLnBrk="1" hangingPunct="1">
+              <a:defRPr>
+                <a:solidFill>
+                  <a:schemeClr val="tx2"/>
+                </a:solidFill>
+              </a:defRPr>
+            </a:lvl8pPr>
+            <a:lvl9pPr eaLnBrk="1" hangingPunct="1">
+              <a:defRPr>
+                <a:solidFill>
+                  <a:schemeClr val="tx2"/>
+                </a:solidFill>
+              </a:defRPr>
+            </a:lvl9pPr>
+          </a:lstStyle>
+          <a:p>
+            <a:r>
+              <a:rPr lang="en-US" b="1" dirty="0" smtClean="0"/>
+              <a:t>Project Pulse – Frontend</a:t>
+            </a:r>
+            <a:endParaRPr lang="en-US" b="1" dirty="0"/>
+          </a:p>
+        </p:txBody>
+      </p:sp>
+      <p:pic>
+        <p:nvPicPr>
+          <p:cNvPr id="3" name="Picture 2"/>
+          <p:cNvPicPr>
+            <a:picLocks noChangeAspect="1"/>
+          </p:cNvPicPr>
+          <p:nvPr/>
+        </p:nvPicPr>
+        <p:blipFill>
+          <a:blip r:embed="rId2">
+            <a:extLst>
+              <a:ext uri="{28A0092B-C50C-407E-A947-70E740481C1C}">
+                <a14:useLocalDpi xmlns:a14="http://schemas.microsoft.com/office/drawing/2010/main" val="0"/>
+              </a:ext>
+            </a:extLst>
+          </a:blip>
+          <a:stretch>
+            <a:fillRect/>
+          </a:stretch>
+        </p:blipFill>
+        <p:spPr>
+          <a:xfrm>
+            <a:off x="0" y="449450"/>
+            <a:ext cx="12192000" cy="6149552"/>
+          </a:xfrm>
+          <a:prstGeom prst="rect">
+            <a:avLst/>
+          </a:prstGeom>
+        </p:spPr>
+      </p:pic>
+    </p:spTree>
+    <p:extLst>
+      <p:ext uri="{BB962C8B-B14F-4D97-AF65-F5344CB8AC3E}">
+        <p14:creationId xmlns:p14="http://schemas.microsoft.com/office/powerpoint/2010/main" val="661314622"/>
+      </p:ext>
+    </p:extLst>
+  </p:cSld>
+  <p:clrMapOvr>
+    <a:masterClrMapping/>
+  </p:clrMapOvr>
+  <mc:AlternateContent xmlns:mc="http://schemas.openxmlformats.org/markup-compatibility/2006" xmlns:p14="http://schemas.microsoft.com/office/powerpoint/2010/main">
+    <mc:Choice Requires="p14">
+      <p:transition spd="slow" p14:dur="2000"/>
+    </mc:Choice>
+    <mc:Fallback xmlns="">
+      <p:transition spd="slow"/>
+    </mc:Fallback>
+  </mc:AlternateContent>
+  <p:timing>
+    <p:tnLst>
+      <p:par>
+        <p:cTn id="1" dur="indefinite" restart="never" nodeType="tmRoot"/>
+      </p:par>
+    </p:tnLst>
+  </p:timing>
+</p:sld>
+</file>
+
+<file path=ppt/slides/slide26.xml><?xml version="1.0" encoding="utf-8"?>
+<p:sld xmlns:a="http://schemas.openxmlformats.org/drawingml/2006/main" xmlns:r="http://schemas.openxmlformats.org/officeDocument/2006/relationships" xmlns:p="http://schemas.openxmlformats.org/presentationml/2006/main">
+  <p:cSld>
+    <p:spTree>
+      <p:nvGrpSpPr>
+        <p:cNvPr id="1" name=""/>
+        <p:cNvGrpSpPr/>
+        <p:nvPr/>
+      </p:nvGrpSpPr>
+      <p:grpSpPr>
+        <a:xfrm>
+          <a:off x="0" y="0"/>
+          <a:ext cx="0" cy="0"/>
+          <a:chOff x="0" y="0"/>
+          <a:chExt cx="0" cy="0"/>
+        </a:xfrm>
+      </p:grpSpPr>
+      <p:sp>
+        <p:nvSpPr>
+          <p:cNvPr id="5" name="Title 1"/>
+          <p:cNvSpPr txBox="1">
+            <a:spLocks/>
+          </p:cNvSpPr>
+          <p:nvPr/>
+        </p:nvSpPr>
+        <p:spPr>
+          <a:xfrm>
+            <a:off x="590449" y="927977"/>
+            <a:ext cx="9514445" cy="1012943"/>
+          </a:xfrm>
+          <a:prstGeom prst="rect">
+            <a:avLst/>
+          </a:prstGeom>
+        </p:spPr>
+        <p:txBody>
+          <a:bodyPr/>
+          <a:lstStyle>
+            <a:lvl1pPr algn="ctr" defTabSz="457200" rtl="0" eaLnBrk="1" latinLnBrk="0" hangingPunct="1">
+              <a:spcBef>
+                <a:spcPct val="0"/>
+              </a:spcBef>
+              <a:buNone/>
+              <a:defRPr sz="4400" kern="1200" cap="none">
+                <a:ln w="3175" cmpd="sng">
+                  <a:noFill/>
+                </a:ln>
+                <a:solidFill>
+                  <a:schemeClr val="tx1">
+                    <a:lumMod val="85000"/>
+                    <a:lumOff val="15000"/>
+                  </a:schemeClr>
+                </a:solidFill>
+                <a:effectLst/>
+                <a:latin typeface="+mj-lt"/>
+                <a:ea typeface="+mj-ea"/>
+                <a:cs typeface="+mj-cs"/>
+              </a:defRPr>
+            </a:lvl1pPr>
+            <a:lvl2pPr eaLnBrk="1" hangingPunct="1">
+              <a:defRPr>
+                <a:solidFill>
+                  <a:schemeClr val="tx2"/>
+                </a:solidFill>
+              </a:defRPr>
+            </a:lvl2pPr>
+            <a:lvl3pPr eaLnBrk="1" hangingPunct="1">
+              <a:defRPr>
+                <a:solidFill>
+                  <a:schemeClr val="tx2"/>
+                </a:solidFill>
+              </a:defRPr>
+            </a:lvl3pPr>
+            <a:lvl4pPr eaLnBrk="1" hangingPunct="1">
+              <a:defRPr>
+                <a:solidFill>
+                  <a:schemeClr val="tx2"/>
+                </a:solidFill>
+              </a:defRPr>
+            </a:lvl4pPr>
+            <a:lvl5pPr eaLnBrk="1" hangingPunct="1">
+              <a:defRPr>
+                <a:solidFill>
+                  <a:schemeClr val="tx2"/>
+                </a:solidFill>
+              </a:defRPr>
+            </a:lvl5pPr>
+            <a:lvl6pPr eaLnBrk="1" hangingPunct="1">
+              <a:defRPr>
+                <a:solidFill>
+                  <a:schemeClr val="tx2"/>
+                </a:solidFill>
+              </a:defRPr>
+            </a:lvl6pPr>
+            <a:lvl7pPr eaLnBrk="1" hangingPunct="1">
+              <a:defRPr>
+                <a:solidFill>
+                  <a:schemeClr val="tx2"/>
+                </a:solidFill>
+              </a:defRPr>
+            </a:lvl7pPr>
+            <a:lvl8pPr eaLnBrk="1" hangingPunct="1">
+              <a:defRPr>
+                <a:solidFill>
+                  <a:schemeClr val="tx2"/>
+                </a:solidFill>
+              </a:defRPr>
+            </a:lvl8pPr>
+            <a:lvl9pPr eaLnBrk="1" hangingPunct="1">
+              <a:defRPr>
+                <a:solidFill>
+                  <a:schemeClr val="tx2"/>
+                </a:solidFill>
+              </a:defRPr>
+            </a:lvl9pPr>
+          </a:lstStyle>
+          <a:p>
+            <a:r>
+              <a:rPr lang="en-US" b="1" dirty="0" smtClean="0"/>
+              <a:t>Project Pulse – </a:t>
+            </a:r>
+            <a:r>
+              <a:rPr lang="en-US" b="1" dirty="0" err="1" smtClean="0"/>
+              <a:t>Figma</a:t>
+            </a:r>
+            <a:endParaRPr lang="en-US" b="1" dirty="0"/>
+          </a:p>
+        </p:txBody>
+      </p:sp>
+      <p:pic>
+        <p:nvPicPr>
+          <p:cNvPr id="2" name="Picture 1"/>
+          <p:cNvPicPr>
+            <a:picLocks noChangeAspect="1"/>
+          </p:cNvPicPr>
+          <p:nvPr/>
+        </p:nvPicPr>
+        <p:blipFill>
+          <a:blip r:embed="rId2"/>
+          <a:stretch>
+            <a:fillRect/>
+          </a:stretch>
+        </p:blipFill>
+        <p:spPr>
+          <a:xfrm>
+            <a:off x="1380963" y="2188893"/>
+            <a:ext cx="9374861" cy="1874972"/>
+          </a:xfrm>
+          <a:prstGeom prst="rect">
+            <a:avLst/>
+          </a:prstGeom>
+        </p:spPr>
+      </p:pic>
+    </p:spTree>
+    <p:extLst>
+      <p:ext uri="{BB962C8B-B14F-4D97-AF65-F5344CB8AC3E}">
+        <p14:creationId xmlns:p14="http://schemas.microsoft.com/office/powerpoint/2010/main" val="419210257"/>
+      </p:ext>
+    </p:extLst>
+  </p:cSld>
+  <p:clrMapOvr>
+    <a:masterClrMapping/>
+  </p:clrMapOvr>
+  <mc:AlternateContent xmlns:mc="http://schemas.openxmlformats.org/markup-compatibility/2006" xmlns:p14="http://schemas.microsoft.com/office/powerpoint/2010/main">
+    <mc:Choice Requires="p14">
+      <p:transition spd="slow" p14:dur="2000"/>
+    </mc:Choice>
+    <mc:Fallback xmlns="">
+      <p:transition spd="slow"/>
+    </mc:Fallback>
+  </mc:AlternateContent>
+  <p:timing>
+    <p:tnLst>
+      <p:par>
+        <p:cTn id="1" dur="indefinite" restart="never" nodeType="tmRoot"/>
+      </p:par>
+    </p:tnLst>
+  </p:timing>
+</p:sld>
+</file>
+
+<file path=ppt/slides/slide27.xml><?xml version="1.0" encoding="utf-8"?>
+<p:sld xmlns:a="http://schemas.openxmlformats.org/drawingml/2006/main" xmlns:r="http://schemas.openxmlformats.org/officeDocument/2006/relationships" xmlns:p="http://schemas.openxmlformats.org/presentationml/2006/main">
+  <p:cSld>
+    <p:spTree>
+      <p:nvGrpSpPr>
+        <p:cNvPr id="1" name=""/>
+        <p:cNvGrpSpPr/>
+        <p:nvPr/>
+      </p:nvGrpSpPr>
+      <p:grpSpPr>
+        <a:xfrm>
+          <a:off x="0" y="0"/>
+          <a:ext cx="0" cy="0"/>
+          <a:chOff x="0" y="0"/>
+          <a:chExt cx="0" cy="0"/>
+        </a:xfrm>
+      </p:grpSpPr>
+      <p:sp>
+        <p:nvSpPr>
+          <p:cNvPr id="5" name="Title 1"/>
+          <p:cNvSpPr txBox="1">
+            <a:spLocks/>
+          </p:cNvSpPr>
+          <p:nvPr/>
+        </p:nvSpPr>
+        <p:spPr>
+          <a:xfrm>
+            <a:off x="590449" y="927977"/>
+            <a:ext cx="9514445" cy="1012943"/>
+          </a:xfrm>
+          <a:prstGeom prst="rect">
+            <a:avLst/>
+          </a:prstGeom>
+        </p:spPr>
+        <p:txBody>
+          <a:bodyPr/>
+          <a:lstStyle>
+            <a:lvl1pPr algn="ctr" defTabSz="457200" rtl="0" eaLnBrk="1" latinLnBrk="0" hangingPunct="1">
+              <a:spcBef>
+                <a:spcPct val="0"/>
+              </a:spcBef>
+              <a:buNone/>
+              <a:defRPr sz="4400" kern="1200" cap="none">
+                <a:ln w="3175" cmpd="sng">
+                  <a:noFill/>
+                </a:ln>
+                <a:solidFill>
+                  <a:schemeClr val="tx1">
+                    <a:lumMod val="85000"/>
+                    <a:lumOff val="15000"/>
+                  </a:schemeClr>
+                </a:solidFill>
+                <a:effectLst/>
+                <a:latin typeface="+mj-lt"/>
+                <a:ea typeface="+mj-ea"/>
+                <a:cs typeface="+mj-cs"/>
+              </a:defRPr>
+            </a:lvl1pPr>
+            <a:lvl2pPr eaLnBrk="1" hangingPunct="1">
+              <a:defRPr>
+                <a:solidFill>
+                  <a:schemeClr val="tx2"/>
+                </a:solidFill>
+              </a:defRPr>
+            </a:lvl2pPr>
+            <a:lvl3pPr eaLnBrk="1" hangingPunct="1">
+              <a:defRPr>
+                <a:solidFill>
+                  <a:schemeClr val="tx2"/>
+                </a:solidFill>
+              </a:defRPr>
+            </a:lvl3pPr>
+            <a:lvl4pPr eaLnBrk="1" hangingPunct="1">
+              <a:defRPr>
+                <a:solidFill>
+                  <a:schemeClr val="tx2"/>
+                </a:solidFill>
+              </a:defRPr>
+            </a:lvl4pPr>
+            <a:lvl5pPr eaLnBrk="1" hangingPunct="1">
+              <a:defRPr>
+                <a:solidFill>
+                  <a:schemeClr val="tx2"/>
+                </a:solidFill>
+              </a:defRPr>
+            </a:lvl5pPr>
+            <a:lvl6pPr eaLnBrk="1" hangingPunct="1">
+              <a:defRPr>
+                <a:solidFill>
+                  <a:schemeClr val="tx2"/>
+                </a:solidFill>
+              </a:defRPr>
+            </a:lvl6pPr>
+            <a:lvl7pPr eaLnBrk="1" hangingPunct="1">
+              <a:defRPr>
+                <a:solidFill>
+                  <a:schemeClr val="tx2"/>
+                </a:solidFill>
+              </a:defRPr>
+            </a:lvl7pPr>
+            <a:lvl8pPr eaLnBrk="1" hangingPunct="1">
+              <a:defRPr>
+                <a:solidFill>
+                  <a:schemeClr val="tx2"/>
+                </a:solidFill>
+              </a:defRPr>
+            </a:lvl8pPr>
+            <a:lvl9pPr eaLnBrk="1" hangingPunct="1">
+              <a:defRPr>
+                <a:solidFill>
+                  <a:schemeClr val="tx2"/>
+                </a:solidFill>
+              </a:defRPr>
+            </a:lvl9pPr>
+          </a:lstStyle>
+          <a:p>
+            <a:r>
+              <a:rPr lang="en-US" b="1" dirty="0" smtClean="0"/>
+              <a:t>Project Pulse – </a:t>
+            </a:r>
+            <a:r>
+              <a:rPr lang="en-US" b="1" dirty="0" err="1" smtClean="0"/>
+              <a:t>Figma</a:t>
+            </a:r>
+            <a:endParaRPr lang="en-US" b="1" dirty="0"/>
+          </a:p>
+        </p:txBody>
+      </p:sp>
+      <p:pic>
+        <p:nvPicPr>
+          <p:cNvPr id="4" name="Picture 3"/>
+          <p:cNvPicPr>
+            <a:picLocks noChangeAspect="1"/>
+          </p:cNvPicPr>
+          <p:nvPr/>
+        </p:nvPicPr>
+        <p:blipFill>
+          <a:blip r:embed="rId2"/>
+          <a:stretch>
+            <a:fillRect/>
+          </a:stretch>
+        </p:blipFill>
+        <p:spPr>
+          <a:xfrm>
+            <a:off x="590449" y="927977"/>
+            <a:ext cx="11030422" cy="5020080"/>
+          </a:xfrm>
+          <a:prstGeom prst="rect">
+            <a:avLst/>
+          </a:prstGeom>
+        </p:spPr>
+      </p:pic>
+    </p:spTree>
+    <p:extLst>
+      <p:ext uri="{BB962C8B-B14F-4D97-AF65-F5344CB8AC3E}">
+        <p14:creationId xmlns:p14="http://schemas.microsoft.com/office/powerpoint/2010/main" val="368314005"/>
+      </p:ext>
+    </p:extLst>
+  </p:cSld>
+  <p:clrMapOvr>
+    <a:masterClrMapping/>
+  </p:clrMapOvr>
+  <mc:AlternateContent xmlns:mc="http://schemas.openxmlformats.org/markup-compatibility/2006" xmlns:p14="http://schemas.microsoft.com/office/powerpoint/2010/main">
+    <mc:Choice Requires="p14">
+      <p:transition spd="slow" p14:dur="2000"/>
+    </mc:Choice>
+    <mc:Fallback xmlns="">
+      <p:transition spd="slow"/>
+    </mc:Fallback>
+  </mc:AlternateContent>
+  <p:timing>
+    <p:tnLst>
+      <p:par>
+        <p:cTn id="1" dur="indefinite" restart="never" nodeType="tmRoot"/>
+      </p:par>
+    </p:tnLst>
+  </p:timing>
+</p:sld>
+</file>
+
+<file path=ppt/slides/slide28.xml><?xml version="1.0" encoding="utf-8"?>
+<p:sld xmlns:a="http://schemas.openxmlformats.org/drawingml/2006/main" xmlns:r="http://schemas.openxmlformats.org/officeDocument/2006/relationships" xmlns:p="http://schemas.openxmlformats.org/presentationml/2006/main">
+  <p:cSld>
+    <p:spTree>
+      <p:nvGrpSpPr>
+        <p:cNvPr id="1" name=""/>
+        <p:cNvGrpSpPr/>
+        <p:nvPr/>
+      </p:nvGrpSpPr>
+      <p:grpSpPr>
+        <a:xfrm>
+          <a:off x="0" y="0"/>
+          <a:ext cx="0" cy="0"/>
+          <a:chOff x="0" y="0"/>
+          <a:chExt cx="0" cy="0"/>
+        </a:xfrm>
+      </p:grpSpPr>
+      <p:sp>
+        <p:nvSpPr>
+          <p:cNvPr id="5" name="Title 1"/>
+          <p:cNvSpPr txBox="1">
+            <a:spLocks/>
+          </p:cNvSpPr>
+          <p:nvPr/>
+        </p:nvSpPr>
+        <p:spPr>
+          <a:xfrm>
+            <a:off x="590449" y="927977"/>
+            <a:ext cx="9514445" cy="1012943"/>
+          </a:xfrm>
+          <a:prstGeom prst="rect">
+            <a:avLst/>
+          </a:prstGeom>
+        </p:spPr>
+        <p:txBody>
+          <a:bodyPr/>
+          <a:lstStyle>
+            <a:lvl1pPr algn="ctr" defTabSz="457200" rtl="0" eaLnBrk="1" latinLnBrk="0" hangingPunct="1">
+              <a:spcBef>
+                <a:spcPct val="0"/>
+              </a:spcBef>
+              <a:buNone/>
+              <a:defRPr sz="4400" kern="1200" cap="none">
+                <a:ln w="3175" cmpd="sng">
+                  <a:noFill/>
+                </a:ln>
+                <a:solidFill>
+                  <a:schemeClr val="tx1">
+                    <a:lumMod val="85000"/>
+                    <a:lumOff val="15000"/>
+                  </a:schemeClr>
+                </a:solidFill>
+                <a:effectLst/>
+                <a:latin typeface="+mj-lt"/>
+                <a:ea typeface="+mj-ea"/>
+                <a:cs typeface="+mj-cs"/>
+              </a:defRPr>
+            </a:lvl1pPr>
+            <a:lvl2pPr eaLnBrk="1" hangingPunct="1">
+              <a:defRPr>
+                <a:solidFill>
+                  <a:schemeClr val="tx2"/>
+                </a:solidFill>
+              </a:defRPr>
+            </a:lvl2pPr>
+            <a:lvl3pPr eaLnBrk="1" hangingPunct="1">
+              <a:defRPr>
+                <a:solidFill>
+                  <a:schemeClr val="tx2"/>
+                </a:solidFill>
+              </a:defRPr>
+            </a:lvl3pPr>
+            <a:lvl4pPr eaLnBrk="1" hangingPunct="1">
+              <a:defRPr>
+                <a:solidFill>
+                  <a:schemeClr val="tx2"/>
+                </a:solidFill>
+              </a:defRPr>
+            </a:lvl4pPr>
+            <a:lvl5pPr eaLnBrk="1" hangingPunct="1">
+              <a:defRPr>
+                <a:solidFill>
+                  <a:schemeClr val="tx2"/>
+                </a:solidFill>
+              </a:defRPr>
+            </a:lvl5pPr>
+            <a:lvl6pPr eaLnBrk="1" hangingPunct="1">
+              <a:defRPr>
+                <a:solidFill>
+                  <a:schemeClr val="tx2"/>
+                </a:solidFill>
+              </a:defRPr>
+            </a:lvl6pPr>
+            <a:lvl7pPr eaLnBrk="1" hangingPunct="1">
+              <a:defRPr>
+                <a:solidFill>
+                  <a:schemeClr val="tx2"/>
+                </a:solidFill>
+              </a:defRPr>
+            </a:lvl7pPr>
+            <a:lvl8pPr eaLnBrk="1" hangingPunct="1">
+              <a:defRPr>
+                <a:solidFill>
+                  <a:schemeClr val="tx2"/>
+                </a:solidFill>
+              </a:defRPr>
+            </a:lvl8pPr>
+            <a:lvl9pPr eaLnBrk="1" hangingPunct="1">
+              <a:defRPr>
+                <a:solidFill>
+                  <a:schemeClr val="tx2"/>
+                </a:solidFill>
+              </a:defRPr>
+            </a:lvl9pPr>
+          </a:lstStyle>
+          <a:p>
+            <a:r>
+              <a:rPr lang="en-US" b="1" dirty="0" smtClean="0"/>
+              <a:t>Project Pulse – </a:t>
+            </a:r>
+            <a:r>
+              <a:rPr lang="en-US" b="1" dirty="0" err="1" smtClean="0"/>
+              <a:t>Figma</a:t>
+            </a:r>
+            <a:endParaRPr lang="en-US" b="1" dirty="0"/>
+          </a:p>
+        </p:txBody>
+      </p:sp>
+      <p:pic>
+        <p:nvPicPr>
+          <p:cNvPr id="2" name="Picture 1"/>
+          <p:cNvPicPr>
+            <a:picLocks noChangeAspect="1"/>
+          </p:cNvPicPr>
+          <p:nvPr/>
+        </p:nvPicPr>
+        <p:blipFill>
+          <a:blip r:embed="rId2"/>
+          <a:stretch>
+            <a:fillRect/>
+          </a:stretch>
+        </p:blipFill>
+        <p:spPr>
+          <a:xfrm>
+            <a:off x="590449" y="1129455"/>
+            <a:ext cx="11064276" cy="4582175"/>
+          </a:xfrm>
+          <a:prstGeom prst="rect">
+            <a:avLst/>
+          </a:prstGeom>
+        </p:spPr>
+      </p:pic>
+    </p:spTree>
+    <p:extLst>
+      <p:ext uri="{BB962C8B-B14F-4D97-AF65-F5344CB8AC3E}">
+        <p14:creationId xmlns:p14="http://schemas.microsoft.com/office/powerpoint/2010/main" val="2065412877"/>
+      </p:ext>
+    </p:extLst>
+  </p:cSld>
+  <p:clrMapOvr>
+    <a:masterClrMapping/>
+  </p:clrMapOvr>
+  <mc:AlternateContent xmlns:mc="http://schemas.openxmlformats.org/markup-compatibility/2006" xmlns:p14="http://schemas.microsoft.com/office/powerpoint/2010/main">
+    <mc:Choice Requires="p14">
+      <p:transition spd="slow" p14:dur="2000"/>
+    </mc:Choice>
+    <mc:Fallback xmlns="">
+      <p:transition spd="slow"/>
+    </mc:Fallback>
+  </mc:AlternateContent>
+  <p:timing>
+    <p:tnLst>
+      <p:par>
+        <p:cTn id="1" dur="indefinite" restart="never" nodeType="tmRoot"/>
+      </p:par>
+    </p:tnLst>
+  </p:timing>
+</p:sld>
+</file>
+
+<file path=ppt/slides/slide29.xml><?xml version="1.0" encoding="utf-8"?>
+<p:sld xmlns:a="http://schemas.openxmlformats.org/drawingml/2006/main" xmlns:r="http://schemas.openxmlformats.org/officeDocument/2006/relationships" xmlns:p="http://schemas.openxmlformats.org/presentationml/2006/main">
+  <p:cSld>
+    <p:spTree>
+      <p:nvGrpSpPr>
+        <p:cNvPr id="1" name=""/>
+        <p:cNvGrpSpPr/>
+        <p:nvPr/>
+      </p:nvGrpSpPr>
+      <p:grpSpPr>
+        <a:xfrm>
+          <a:off x="0" y="0"/>
+          <a:ext cx="0" cy="0"/>
+          <a:chOff x="0" y="0"/>
+          <a:chExt cx="0" cy="0"/>
+        </a:xfrm>
+      </p:grpSpPr>
+      <p:sp>
+        <p:nvSpPr>
+          <p:cNvPr id="2" name="Title 1"/>
+          <p:cNvSpPr txBox="1">
+            <a:spLocks/>
+          </p:cNvSpPr>
+          <p:nvPr/>
+        </p:nvSpPr>
+        <p:spPr>
+          <a:xfrm>
+            <a:off x="1101892" y="2849766"/>
+            <a:ext cx="9901905" cy="1520755"/>
+          </a:xfrm>
+          <a:prstGeom prst="rect">
+            <a:avLst/>
+          </a:prstGeom>
+        </p:spPr>
+        <p:txBody>
+          <a:bodyPr/>
+          <a:lstStyle>
+            <a:lvl1pPr algn="ctr" defTabSz="457200" rtl="0" eaLnBrk="1" latinLnBrk="0" hangingPunct="1">
+              <a:spcBef>
+                <a:spcPct val="0"/>
+              </a:spcBef>
+              <a:buNone/>
+              <a:defRPr sz="4400" kern="1200" cap="none">
+                <a:ln w="3175" cmpd="sng">
+                  <a:noFill/>
+                </a:ln>
+                <a:solidFill>
+                  <a:schemeClr val="tx1">
+                    <a:lumMod val="85000"/>
+                    <a:lumOff val="15000"/>
+                  </a:schemeClr>
+                </a:solidFill>
+                <a:effectLst/>
+                <a:latin typeface="+mj-lt"/>
+                <a:ea typeface="+mj-ea"/>
+                <a:cs typeface="+mj-cs"/>
+              </a:defRPr>
+            </a:lvl1pPr>
+            <a:lvl2pPr eaLnBrk="1" hangingPunct="1">
+              <a:defRPr>
+                <a:solidFill>
+                  <a:schemeClr val="tx2"/>
+                </a:solidFill>
+              </a:defRPr>
+            </a:lvl2pPr>
+            <a:lvl3pPr eaLnBrk="1" hangingPunct="1">
+              <a:defRPr>
+                <a:solidFill>
+                  <a:schemeClr val="tx2"/>
+                </a:solidFill>
+              </a:defRPr>
+            </a:lvl3pPr>
+            <a:lvl4pPr eaLnBrk="1" hangingPunct="1">
+              <a:defRPr>
+                <a:solidFill>
+                  <a:schemeClr val="tx2"/>
+                </a:solidFill>
+              </a:defRPr>
+            </a:lvl4pPr>
+            <a:lvl5pPr eaLnBrk="1" hangingPunct="1">
+              <a:defRPr>
+                <a:solidFill>
+                  <a:schemeClr val="tx2"/>
+                </a:solidFill>
+              </a:defRPr>
+            </a:lvl5pPr>
+            <a:lvl6pPr eaLnBrk="1" hangingPunct="1">
+              <a:defRPr>
+                <a:solidFill>
+                  <a:schemeClr val="tx2"/>
+                </a:solidFill>
+              </a:defRPr>
+            </a:lvl6pPr>
+            <a:lvl7pPr eaLnBrk="1" hangingPunct="1">
+              <a:defRPr>
+                <a:solidFill>
+                  <a:schemeClr val="tx2"/>
+                </a:solidFill>
+              </a:defRPr>
+            </a:lvl7pPr>
+            <a:lvl8pPr eaLnBrk="1" hangingPunct="1">
+              <a:defRPr>
+                <a:solidFill>
+                  <a:schemeClr val="tx2"/>
+                </a:solidFill>
+              </a:defRPr>
+            </a:lvl8pPr>
+            <a:lvl9pPr eaLnBrk="1" hangingPunct="1">
+              <a:defRPr>
+                <a:solidFill>
+                  <a:schemeClr val="tx2"/>
+                </a:solidFill>
+              </a:defRPr>
+            </a:lvl9pPr>
+          </a:lstStyle>
+          <a:p>
+            <a:r>
+              <a:rPr lang="en-US" b="1" dirty="0" smtClean="0"/>
+              <a:t>Thank You!</a:t>
+            </a:r>
+            <a:endParaRPr lang="en-US" b="1" dirty="0"/>
+          </a:p>
+        </p:txBody>
+      </p:sp>
+    </p:spTree>
+    <p:extLst>
+      <p:ext uri="{BB962C8B-B14F-4D97-AF65-F5344CB8AC3E}">
+        <p14:creationId xmlns:p14="http://schemas.microsoft.com/office/powerpoint/2010/main" val="702936776"/>
+      </p:ext>
+    </p:extLst>
+  </p:cSld>
+  <p:clrMapOvr>
+    <a:masterClrMapping/>
+  </p:clrMapOvr>
 </p:sld>
 </file>
 
@@ -8302,11 +11395,11 @@
   <p:clrMapOvr>
     <a:masterClrMapping/>
   </p:clrMapOvr>
-  <mc:AlternateContent xmlns:mc="http://schemas.openxmlformats.org/markup-compatibility/2006">
-    <mc:Choice xmlns:p14="http://schemas.microsoft.com/office/powerpoint/2010/main" Requires="p14">
+  <mc:AlternateContent xmlns:mc="http://schemas.openxmlformats.org/markup-compatibility/2006" xmlns:p14="http://schemas.microsoft.com/office/powerpoint/2010/main">
+    <mc:Choice Requires="p14">
       <p:transition spd="slow" p14:dur="2000"/>
     </mc:Choice>
-    <mc:Fallback>
+    <mc:Fallback xmlns="">
       <p:transition spd="slow"/>
     </mc:Fallback>
   </mc:AlternateContent>
@@ -8426,11 +11519,11 @@
   <p:clrMapOvr>
     <a:masterClrMapping/>
   </p:clrMapOvr>
-  <mc:AlternateContent xmlns:mc="http://schemas.openxmlformats.org/markup-compatibility/2006">
-    <mc:Choice xmlns:p14="http://schemas.microsoft.com/office/powerpoint/2010/main" Requires="p14">
+  <mc:AlternateContent xmlns:mc="http://schemas.openxmlformats.org/markup-compatibility/2006" xmlns:p14="http://schemas.microsoft.com/office/powerpoint/2010/main">
+    <mc:Choice Requires="p14">
       <p:transition spd="slow" p14:dur="2000"/>
     </mc:Choice>
-    <mc:Fallback>
+    <mc:Fallback xmlns="">
       <p:transition spd="slow"/>
     </mc:Fallback>
   </mc:AlternateContent>
@@ -8445,7 +11538,7 @@
 </file>
 
 <file path=ppt/slides/slide9.xml><?xml version="1.0" encoding="utf-8"?>
-<p:sld xmlns:a="http://schemas.openxmlformats.org/drawingml/2006/main" xmlns:r="http://schemas.openxmlformats.org/officeDocument/2006/relationships" xmlns:p="http://schemas.openxmlformats.org/presentationml/2006/main">
+<p:sld xmlns:a="http://schemas.openxmlformats.org/drawingml/2006/main" xmlns:r="http://schemas.openxmlformats.org/officeDocument/2006/relationships" xmlns:p="http://schemas.openxmlformats.org/presentationml/2006/main" show="0">
   <p:cSld>
     <p:spTree>
       <p:nvGrpSpPr>
@@ -8513,6 +11606,14 @@
   <p:clrMapOvr>
     <a:masterClrMapping/>
   </p:clrMapOvr>
+  <mc:AlternateContent xmlns:mc="http://schemas.openxmlformats.org/markup-compatibility/2006">
+    <mc:Choice xmlns:p14="http://schemas.microsoft.com/office/powerpoint/2010/main" Requires="p14">
+      <p:transition spd="slow" p14:dur="2000"/>
+    </mc:Choice>
+    <mc:Fallback>
+      <p:transition spd="slow"/>
+    </mc:Fallback>
+  </mc:AlternateContent>
   <p:timing>
     <p:tnLst>
       <p:par>

</xml_diff>